<commit_message>
fix(ppt): increase section vertical spacing on role block
</commit_message>
<xml_diff>
--- a/피우다프로젝트/application_assets/mobile_scene_capture_all_language/app_screen_slides_source/output/app_screen_slides.pptx
+++ b/피우다프로젝트/application_assets/mobile_scene_capture_all_language/app_screen_slides_source/output/app_screen_slides.pptx
@@ -3328,7 +3328,7 @@
         </p:nvSpPr>
         <p:spPr>
           <a:xfrm>
-            <a:off x="3410712" y="3630168"/>
+            <a:off x="3410712" y="3849624"/>
             <a:ext cx="91440" cy="91440"/>
           </a:xfrm>
           <a:prstGeom prst="ellipse">
@@ -3355,7 +3355,7 @@
         </p:nvSpPr>
         <p:spPr>
           <a:xfrm>
-            <a:off x="3611880" y="3493008"/>
+            <a:off x="3611880" y="3712464"/>
             <a:ext cx="8348472" cy="365760"/>
           </a:xfrm>
           <a:prstGeom prst="rect">
@@ -3396,7 +3396,7 @@
         </p:nvSpPr>
         <p:spPr>
           <a:xfrm>
-            <a:off x="3410712" y="3995928"/>
+            <a:off x="3410712" y="4215384"/>
             <a:ext cx="91440" cy="91440"/>
           </a:xfrm>
           <a:prstGeom prst="ellipse">
@@ -3423,7 +3423,7 @@
         </p:nvSpPr>
         <p:spPr>
           <a:xfrm>
-            <a:off x="3611880" y="3858768"/>
+            <a:off x="3611880" y="4078224"/>
             <a:ext cx="8348472" cy="365760"/>
           </a:xfrm>
           <a:prstGeom prst="rect">
@@ -3464,7 +3464,7 @@
         </p:nvSpPr>
         <p:spPr>
           <a:xfrm>
-            <a:off x="3410712" y="4361688"/>
+            <a:off x="3410712" y="4581144"/>
             <a:ext cx="91440" cy="91440"/>
           </a:xfrm>
           <a:prstGeom prst="ellipse">
@@ -3491,7 +3491,7 @@
         </p:nvSpPr>
         <p:spPr>
           <a:xfrm>
-            <a:off x="3611880" y="4224528"/>
+            <a:off x="3611880" y="4443984"/>
             <a:ext cx="8348472" cy="365760"/>
           </a:xfrm>
           <a:prstGeom prst="rect">
@@ -3532,7 +3532,7 @@
         </p:nvSpPr>
         <p:spPr>
           <a:xfrm>
-            <a:off x="3410712" y="4727448"/>
+            <a:off x="3410712" y="4946904"/>
             <a:ext cx="91440" cy="91440"/>
           </a:xfrm>
           <a:prstGeom prst="ellipse">
@@ -3559,7 +3559,7 @@
         </p:nvSpPr>
         <p:spPr>
           <a:xfrm>
-            <a:off x="3611880" y="4590288"/>
+            <a:off x="3611880" y="4809744"/>
             <a:ext cx="8348472" cy="365760"/>
           </a:xfrm>
           <a:prstGeom prst="rect">
@@ -3600,7 +3600,7 @@
         </p:nvSpPr>
         <p:spPr>
           <a:xfrm>
-            <a:off x="3410712" y="4983480"/>
+            <a:off x="3410712" y="5047488"/>
             <a:ext cx="1188720" cy="256032"/>
           </a:xfrm>
           <a:prstGeom prst="rect">
@@ -3641,8 +3641,8 @@
         </p:nvSpPr>
         <p:spPr>
           <a:xfrm>
-            <a:off x="3410712" y="5184648"/>
-            <a:ext cx="8549640" cy="502920"/>
+            <a:off x="3410712" y="5248656"/>
+            <a:ext cx="8549640" cy="411480"/>
           </a:xfrm>
           <a:prstGeom prst="rect">
             <a:avLst/>
@@ -3682,7 +3682,7 @@
         </p:nvSpPr>
         <p:spPr>
           <a:xfrm>
-            <a:off x="3410712" y="5559552"/>
+            <a:off x="3410712" y="5486400"/>
             <a:ext cx="8549640" cy="219456"/>
           </a:xfrm>
           <a:prstGeom prst="rect">
@@ -3723,8 +3723,8 @@
         </p:nvSpPr>
         <p:spPr>
           <a:xfrm>
-            <a:off x="3410712" y="5742432"/>
-            <a:ext cx="8549640" cy="896112"/>
+            <a:off x="3410712" y="5669280"/>
+            <a:ext cx="8549640" cy="749808"/>
           </a:xfrm>
           <a:prstGeom prst="rect">
             <a:avLst/>
@@ -4235,7 +4235,7 @@
         </p:nvSpPr>
         <p:spPr>
           <a:xfrm>
-            <a:off x="3410712" y="3630168"/>
+            <a:off x="3410712" y="3849624"/>
             <a:ext cx="91440" cy="91440"/>
           </a:xfrm>
           <a:prstGeom prst="ellipse">
@@ -4262,7 +4262,7 @@
         </p:nvSpPr>
         <p:spPr>
           <a:xfrm>
-            <a:off x="3611880" y="3493008"/>
+            <a:off x="3611880" y="3712464"/>
             <a:ext cx="8348472" cy="365760"/>
           </a:xfrm>
           <a:prstGeom prst="rect">
@@ -4303,7 +4303,7 @@
         </p:nvSpPr>
         <p:spPr>
           <a:xfrm>
-            <a:off x="3410712" y="3995928"/>
+            <a:off x="3410712" y="4215384"/>
             <a:ext cx="91440" cy="91440"/>
           </a:xfrm>
           <a:prstGeom prst="ellipse">
@@ -4330,7 +4330,7 @@
         </p:nvSpPr>
         <p:spPr>
           <a:xfrm>
-            <a:off x="3611880" y="3858768"/>
+            <a:off x="3611880" y="4078224"/>
             <a:ext cx="8348472" cy="365760"/>
           </a:xfrm>
           <a:prstGeom prst="rect">
@@ -4371,7 +4371,7 @@
         </p:nvSpPr>
         <p:spPr>
           <a:xfrm>
-            <a:off x="3410712" y="4361688"/>
+            <a:off x="3410712" y="4581144"/>
             <a:ext cx="91440" cy="91440"/>
           </a:xfrm>
           <a:prstGeom prst="ellipse">
@@ -4398,7 +4398,7 @@
         </p:nvSpPr>
         <p:spPr>
           <a:xfrm>
-            <a:off x="3611880" y="4224528"/>
+            <a:off x="3611880" y="4443984"/>
             <a:ext cx="8348472" cy="365760"/>
           </a:xfrm>
           <a:prstGeom prst="rect">
@@ -4439,7 +4439,7 @@
         </p:nvSpPr>
         <p:spPr>
           <a:xfrm>
-            <a:off x="3410712" y="4727448"/>
+            <a:off x="3410712" y="4946904"/>
             <a:ext cx="91440" cy="91440"/>
           </a:xfrm>
           <a:prstGeom prst="ellipse">
@@ -4466,7 +4466,7 @@
         </p:nvSpPr>
         <p:spPr>
           <a:xfrm>
-            <a:off x="3611880" y="4590288"/>
+            <a:off x="3611880" y="4809744"/>
             <a:ext cx="8348472" cy="365760"/>
           </a:xfrm>
           <a:prstGeom prst="rect">
@@ -4507,7 +4507,7 @@
         </p:nvSpPr>
         <p:spPr>
           <a:xfrm>
-            <a:off x="3410712" y="4983480"/>
+            <a:off x="3410712" y="5047488"/>
             <a:ext cx="1188720" cy="256032"/>
           </a:xfrm>
           <a:prstGeom prst="rect">
@@ -4548,8 +4548,8 @@
         </p:nvSpPr>
         <p:spPr>
           <a:xfrm>
-            <a:off x="3410712" y="5184648"/>
-            <a:ext cx="8549640" cy="502920"/>
+            <a:off x="3410712" y="5248656"/>
+            <a:ext cx="8549640" cy="411480"/>
           </a:xfrm>
           <a:prstGeom prst="rect">
             <a:avLst/>
@@ -4589,7 +4589,7 @@
         </p:nvSpPr>
         <p:spPr>
           <a:xfrm>
-            <a:off x="3410712" y="5559552"/>
+            <a:off x="3410712" y="5486400"/>
             <a:ext cx="8549640" cy="219456"/>
           </a:xfrm>
           <a:prstGeom prst="rect">
@@ -4630,8 +4630,8 @@
         </p:nvSpPr>
         <p:spPr>
           <a:xfrm>
-            <a:off x="3410712" y="5742432"/>
-            <a:ext cx="8549640" cy="896112"/>
+            <a:off x="3410712" y="5669280"/>
+            <a:ext cx="8549640" cy="749808"/>
           </a:xfrm>
           <a:prstGeom prst="rect">
             <a:avLst/>
@@ -5142,7 +5142,7 @@
         </p:nvSpPr>
         <p:spPr>
           <a:xfrm>
-            <a:off x="3410712" y="3630168"/>
+            <a:off x="3410712" y="3849624"/>
             <a:ext cx="91440" cy="91440"/>
           </a:xfrm>
           <a:prstGeom prst="ellipse">
@@ -5169,7 +5169,7 @@
         </p:nvSpPr>
         <p:spPr>
           <a:xfrm>
-            <a:off x="3611880" y="3493008"/>
+            <a:off x="3611880" y="3712464"/>
             <a:ext cx="8348472" cy="365760"/>
           </a:xfrm>
           <a:prstGeom prst="rect">
@@ -5210,7 +5210,7 @@
         </p:nvSpPr>
         <p:spPr>
           <a:xfrm>
-            <a:off x="3410712" y="3995928"/>
+            <a:off x="3410712" y="4215384"/>
             <a:ext cx="91440" cy="91440"/>
           </a:xfrm>
           <a:prstGeom prst="ellipse">
@@ -5237,7 +5237,7 @@
         </p:nvSpPr>
         <p:spPr>
           <a:xfrm>
-            <a:off x="3611880" y="3858768"/>
+            <a:off x="3611880" y="4078224"/>
             <a:ext cx="8348472" cy="365760"/>
           </a:xfrm>
           <a:prstGeom prst="rect">
@@ -5278,7 +5278,7 @@
         </p:nvSpPr>
         <p:spPr>
           <a:xfrm>
-            <a:off x="3410712" y="4361688"/>
+            <a:off x="3410712" y="4581144"/>
             <a:ext cx="91440" cy="91440"/>
           </a:xfrm>
           <a:prstGeom prst="ellipse">
@@ -5305,7 +5305,7 @@
         </p:nvSpPr>
         <p:spPr>
           <a:xfrm>
-            <a:off x="3611880" y="4224528"/>
+            <a:off x="3611880" y="4443984"/>
             <a:ext cx="8348472" cy="365760"/>
           </a:xfrm>
           <a:prstGeom prst="rect">
@@ -5346,7 +5346,7 @@
         </p:nvSpPr>
         <p:spPr>
           <a:xfrm>
-            <a:off x="3410712" y="4727448"/>
+            <a:off x="3410712" y="4946904"/>
             <a:ext cx="91440" cy="91440"/>
           </a:xfrm>
           <a:prstGeom prst="ellipse">
@@ -5373,7 +5373,7 @@
         </p:nvSpPr>
         <p:spPr>
           <a:xfrm>
-            <a:off x="3611880" y="4590288"/>
+            <a:off x="3611880" y="4809744"/>
             <a:ext cx="8348472" cy="365760"/>
           </a:xfrm>
           <a:prstGeom prst="rect">
@@ -5414,7 +5414,7 @@
         </p:nvSpPr>
         <p:spPr>
           <a:xfrm>
-            <a:off x="3410712" y="4983480"/>
+            <a:off x="3410712" y="5047488"/>
             <a:ext cx="1188720" cy="256032"/>
           </a:xfrm>
           <a:prstGeom prst="rect">
@@ -5455,8 +5455,8 @@
         </p:nvSpPr>
         <p:spPr>
           <a:xfrm>
-            <a:off x="3410712" y="5184648"/>
-            <a:ext cx="8549640" cy="502920"/>
+            <a:off x="3410712" y="5248656"/>
+            <a:ext cx="8549640" cy="411480"/>
           </a:xfrm>
           <a:prstGeom prst="rect">
             <a:avLst/>
@@ -5496,7 +5496,7 @@
         </p:nvSpPr>
         <p:spPr>
           <a:xfrm>
-            <a:off x="3410712" y="5559552"/>
+            <a:off x="3410712" y="5486400"/>
             <a:ext cx="8549640" cy="219456"/>
           </a:xfrm>
           <a:prstGeom prst="rect">
@@ -5537,8 +5537,8 @@
         </p:nvSpPr>
         <p:spPr>
           <a:xfrm>
-            <a:off x="3410712" y="5742432"/>
-            <a:ext cx="8549640" cy="896112"/>
+            <a:off x="3410712" y="5669280"/>
+            <a:ext cx="8549640" cy="749808"/>
           </a:xfrm>
           <a:prstGeom prst="rect">
             <a:avLst/>
@@ -6049,7 +6049,7 @@
         </p:nvSpPr>
         <p:spPr>
           <a:xfrm>
-            <a:off x="3410712" y="3630168"/>
+            <a:off x="3410712" y="3849624"/>
             <a:ext cx="91440" cy="91440"/>
           </a:xfrm>
           <a:prstGeom prst="ellipse">
@@ -6076,7 +6076,7 @@
         </p:nvSpPr>
         <p:spPr>
           <a:xfrm>
-            <a:off x="3611880" y="3493008"/>
+            <a:off x="3611880" y="3712464"/>
             <a:ext cx="8348472" cy="365760"/>
           </a:xfrm>
           <a:prstGeom prst="rect">
@@ -6117,7 +6117,7 @@
         </p:nvSpPr>
         <p:spPr>
           <a:xfrm>
-            <a:off x="3410712" y="3995928"/>
+            <a:off x="3410712" y="4215384"/>
             <a:ext cx="91440" cy="91440"/>
           </a:xfrm>
           <a:prstGeom prst="ellipse">
@@ -6144,7 +6144,7 @@
         </p:nvSpPr>
         <p:spPr>
           <a:xfrm>
-            <a:off x="3611880" y="3858768"/>
+            <a:off x="3611880" y="4078224"/>
             <a:ext cx="8348472" cy="365760"/>
           </a:xfrm>
           <a:prstGeom prst="rect">
@@ -6185,7 +6185,7 @@
         </p:nvSpPr>
         <p:spPr>
           <a:xfrm>
-            <a:off x="3410712" y="4361688"/>
+            <a:off x="3410712" y="4581144"/>
             <a:ext cx="91440" cy="91440"/>
           </a:xfrm>
           <a:prstGeom prst="ellipse">
@@ -6212,7 +6212,7 @@
         </p:nvSpPr>
         <p:spPr>
           <a:xfrm>
-            <a:off x="3611880" y="4224528"/>
+            <a:off x="3611880" y="4443984"/>
             <a:ext cx="8348472" cy="365760"/>
           </a:xfrm>
           <a:prstGeom prst="rect">
@@ -6253,7 +6253,7 @@
         </p:nvSpPr>
         <p:spPr>
           <a:xfrm>
-            <a:off x="3410712" y="4727448"/>
+            <a:off x="3410712" y="4946904"/>
             <a:ext cx="91440" cy="91440"/>
           </a:xfrm>
           <a:prstGeom prst="ellipse">
@@ -6280,7 +6280,7 @@
         </p:nvSpPr>
         <p:spPr>
           <a:xfrm>
-            <a:off x="3611880" y="4590288"/>
+            <a:off x="3611880" y="4809744"/>
             <a:ext cx="8348472" cy="365760"/>
           </a:xfrm>
           <a:prstGeom prst="rect">
@@ -6321,7 +6321,7 @@
         </p:nvSpPr>
         <p:spPr>
           <a:xfrm>
-            <a:off x="3410712" y="4983480"/>
+            <a:off x="3410712" y="5047488"/>
             <a:ext cx="1188720" cy="256032"/>
           </a:xfrm>
           <a:prstGeom prst="rect">
@@ -6362,8 +6362,8 @@
         </p:nvSpPr>
         <p:spPr>
           <a:xfrm>
-            <a:off x="3410712" y="5184648"/>
-            <a:ext cx="8549640" cy="502920"/>
+            <a:off x="3410712" y="5248656"/>
+            <a:ext cx="8549640" cy="411480"/>
           </a:xfrm>
           <a:prstGeom prst="rect">
             <a:avLst/>
@@ -6403,7 +6403,7 @@
         </p:nvSpPr>
         <p:spPr>
           <a:xfrm>
-            <a:off x="3410712" y="5559552"/>
+            <a:off x="3410712" y="5486400"/>
             <a:ext cx="8549640" cy="219456"/>
           </a:xfrm>
           <a:prstGeom prst="rect">
@@ -6444,8 +6444,8 @@
         </p:nvSpPr>
         <p:spPr>
           <a:xfrm>
-            <a:off x="3410712" y="5742432"/>
-            <a:ext cx="8549640" cy="896112"/>
+            <a:off x="3410712" y="5669280"/>
+            <a:ext cx="8549640" cy="749808"/>
           </a:xfrm>
           <a:prstGeom prst="rect">
             <a:avLst/>
@@ -6956,7 +6956,7 @@
         </p:nvSpPr>
         <p:spPr>
           <a:xfrm>
-            <a:off x="3410712" y="3630168"/>
+            <a:off x="3410712" y="3849624"/>
             <a:ext cx="91440" cy="91440"/>
           </a:xfrm>
           <a:prstGeom prst="ellipse">
@@ -6983,7 +6983,7 @@
         </p:nvSpPr>
         <p:spPr>
           <a:xfrm>
-            <a:off x="3611880" y="3493008"/>
+            <a:off x="3611880" y="3712464"/>
             <a:ext cx="8348472" cy="365760"/>
           </a:xfrm>
           <a:prstGeom prst="rect">
@@ -7024,7 +7024,7 @@
         </p:nvSpPr>
         <p:spPr>
           <a:xfrm>
-            <a:off x="3410712" y="3995928"/>
+            <a:off x="3410712" y="4215384"/>
             <a:ext cx="91440" cy="91440"/>
           </a:xfrm>
           <a:prstGeom prst="ellipse">
@@ -7051,7 +7051,7 @@
         </p:nvSpPr>
         <p:spPr>
           <a:xfrm>
-            <a:off x="3611880" y="3858768"/>
+            <a:off x="3611880" y="4078224"/>
             <a:ext cx="8348472" cy="365760"/>
           </a:xfrm>
           <a:prstGeom prst="rect">
@@ -7092,7 +7092,7 @@
         </p:nvSpPr>
         <p:spPr>
           <a:xfrm>
-            <a:off x="3410712" y="4361688"/>
+            <a:off x="3410712" y="4581144"/>
             <a:ext cx="91440" cy="91440"/>
           </a:xfrm>
           <a:prstGeom prst="ellipse">
@@ -7119,7 +7119,7 @@
         </p:nvSpPr>
         <p:spPr>
           <a:xfrm>
-            <a:off x="3611880" y="4224528"/>
+            <a:off x="3611880" y="4443984"/>
             <a:ext cx="8348472" cy="365760"/>
           </a:xfrm>
           <a:prstGeom prst="rect">
@@ -7160,7 +7160,7 @@
         </p:nvSpPr>
         <p:spPr>
           <a:xfrm>
-            <a:off x="3410712" y="4727448"/>
+            <a:off x="3410712" y="4946904"/>
             <a:ext cx="91440" cy="91440"/>
           </a:xfrm>
           <a:prstGeom prst="ellipse">
@@ -7187,7 +7187,7 @@
         </p:nvSpPr>
         <p:spPr>
           <a:xfrm>
-            <a:off x="3611880" y="4590288"/>
+            <a:off x="3611880" y="4809744"/>
             <a:ext cx="8348472" cy="365760"/>
           </a:xfrm>
           <a:prstGeom prst="rect">
@@ -7228,7 +7228,7 @@
         </p:nvSpPr>
         <p:spPr>
           <a:xfrm>
-            <a:off x="3410712" y="4983480"/>
+            <a:off x="3410712" y="5047488"/>
             <a:ext cx="1188720" cy="256032"/>
           </a:xfrm>
           <a:prstGeom prst="rect">
@@ -7269,8 +7269,8 @@
         </p:nvSpPr>
         <p:spPr>
           <a:xfrm>
-            <a:off x="3410712" y="5184648"/>
-            <a:ext cx="8549640" cy="502920"/>
+            <a:off x="3410712" y="5248656"/>
+            <a:ext cx="8549640" cy="411480"/>
           </a:xfrm>
           <a:prstGeom prst="rect">
             <a:avLst/>
@@ -7310,7 +7310,7 @@
         </p:nvSpPr>
         <p:spPr>
           <a:xfrm>
-            <a:off x="3410712" y="5559552"/>
+            <a:off x="3410712" y="5486400"/>
             <a:ext cx="8549640" cy="219456"/>
           </a:xfrm>
           <a:prstGeom prst="rect">
@@ -7351,8 +7351,8 @@
         </p:nvSpPr>
         <p:spPr>
           <a:xfrm>
-            <a:off x="3410712" y="5742432"/>
-            <a:ext cx="8549640" cy="896112"/>
+            <a:off x="3410712" y="5669280"/>
+            <a:ext cx="8549640" cy="749808"/>
           </a:xfrm>
           <a:prstGeom prst="rect">
             <a:avLst/>
@@ -7863,7 +7863,7 @@
         </p:nvSpPr>
         <p:spPr>
           <a:xfrm>
-            <a:off x="3410712" y="3630168"/>
+            <a:off x="3410712" y="3849624"/>
             <a:ext cx="91440" cy="91440"/>
           </a:xfrm>
           <a:prstGeom prst="ellipse">
@@ -7890,7 +7890,7 @@
         </p:nvSpPr>
         <p:spPr>
           <a:xfrm>
-            <a:off x="3611880" y="3493008"/>
+            <a:off x="3611880" y="3712464"/>
             <a:ext cx="8348472" cy="365760"/>
           </a:xfrm>
           <a:prstGeom prst="rect">
@@ -7931,7 +7931,7 @@
         </p:nvSpPr>
         <p:spPr>
           <a:xfrm>
-            <a:off x="3410712" y="3995928"/>
+            <a:off x="3410712" y="4215384"/>
             <a:ext cx="91440" cy="91440"/>
           </a:xfrm>
           <a:prstGeom prst="ellipse">
@@ -7958,7 +7958,7 @@
         </p:nvSpPr>
         <p:spPr>
           <a:xfrm>
-            <a:off x="3611880" y="3858768"/>
+            <a:off x="3611880" y="4078224"/>
             <a:ext cx="8348472" cy="365760"/>
           </a:xfrm>
           <a:prstGeom prst="rect">
@@ -7999,7 +7999,7 @@
         </p:nvSpPr>
         <p:spPr>
           <a:xfrm>
-            <a:off x="3410712" y="4361688"/>
+            <a:off x="3410712" y="4581144"/>
             <a:ext cx="91440" cy="91440"/>
           </a:xfrm>
           <a:prstGeom prst="ellipse">
@@ -8026,7 +8026,7 @@
         </p:nvSpPr>
         <p:spPr>
           <a:xfrm>
-            <a:off x="3611880" y="4224528"/>
+            <a:off x="3611880" y="4443984"/>
             <a:ext cx="8348472" cy="365760"/>
           </a:xfrm>
           <a:prstGeom prst="rect">
@@ -8067,7 +8067,7 @@
         </p:nvSpPr>
         <p:spPr>
           <a:xfrm>
-            <a:off x="3410712" y="4727448"/>
+            <a:off x="3410712" y="4946904"/>
             <a:ext cx="91440" cy="91440"/>
           </a:xfrm>
           <a:prstGeom prst="ellipse">
@@ -8094,7 +8094,7 @@
         </p:nvSpPr>
         <p:spPr>
           <a:xfrm>
-            <a:off x="3611880" y="4590288"/>
+            <a:off x="3611880" y="4809744"/>
             <a:ext cx="8348472" cy="365760"/>
           </a:xfrm>
           <a:prstGeom prst="rect">
@@ -8135,7 +8135,7 @@
         </p:nvSpPr>
         <p:spPr>
           <a:xfrm>
-            <a:off x="3410712" y="4983480"/>
+            <a:off x="3410712" y="5047488"/>
             <a:ext cx="1188720" cy="256032"/>
           </a:xfrm>
           <a:prstGeom prst="rect">
@@ -8176,8 +8176,8 @@
         </p:nvSpPr>
         <p:spPr>
           <a:xfrm>
-            <a:off x="3410712" y="5184648"/>
-            <a:ext cx="8549640" cy="502920"/>
+            <a:off x="3410712" y="5248656"/>
+            <a:ext cx="8549640" cy="411480"/>
           </a:xfrm>
           <a:prstGeom prst="rect">
             <a:avLst/>
@@ -8217,7 +8217,7 @@
         </p:nvSpPr>
         <p:spPr>
           <a:xfrm>
-            <a:off x="3410712" y="5559552"/>
+            <a:off x="3410712" y="5486400"/>
             <a:ext cx="8549640" cy="219456"/>
           </a:xfrm>
           <a:prstGeom prst="rect">
@@ -8258,8 +8258,8 @@
         </p:nvSpPr>
         <p:spPr>
           <a:xfrm>
-            <a:off x="3410712" y="5742432"/>
-            <a:ext cx="8549640" cy="896112"/>
+            <a:off x="3410712" y="5669280"/>
+            <a:ext cx="8549640" cy="749808"/>
           </a:xfrm>
           <a:prstGeom prst="rect">
             <a:avLst/>
@@ -8770,7 +8770,7 @@
         </p:nvSpPr>
         <p:spPr>
           <a:xfrm>
-            <a:off x="3410712" y="3630168"/>
+            <a:off x="3410712" y="3849624"/>
             <a:ext cx="91440" cy="91440"/>
           </a:xfrm>
           <a:prstGeom prst="ellipse">
@@ -8797,7 +8797,7 @@
         </p:nvSpPr>
         <p:spPr>
           <a:xfrm>
-            <a:off x="3611880" y="3493008"/>
+            <a:off x="3611880" y="3712464"/>
             <a:ext cx="8348472" cy="365760"/>
           </a:xfrm>
           <a:prstGeom prst="rect">
@@ -8838,7 +8838,7 @@
         </p:nvSpPr>
         <p:spPr>
           <a:xfrm>
-            <a:off x="3410712" y="3995928"/>
+            <a:off x="3410712" y="4215384"/>
             <a:ext cx="91440" cy="91440"/>
           </a:xfrm>
           <a:prstGeom prst="ellipse">
@@ -8865,7 +8865,7 @@
         </p:nvSpPr>
         <p:spPr>
           <a:xfrm>
-            <a:off x="3611880" y="3858768"/>
+            <a:off x="3611880" y="4078224"/>
             <a:ext cx="8348472" cy="365760"/>
           </a:xfrm>
           <a:prstGeom prst="rect">
@@ -8906,7 +8906,7 @@
         </p:nvSpPr>
         <p:spPr>
           <a:xfrm>
-            <a:off x="3410712" y="4361688"/>
+            <a:off x="3410712" y="4581144"/>
             <a:ext cx="91440" cy="91440"/>
           </a:xfrm>
           <a:prstGeom prst="ellipse">
@@ -8933,7 +8933,7 @@
         </p:nvSpPr>
         <p:spPr>
           <a:xfrm>
-            <a:off x="3611880" y="4224528"/>
+            <a:off x="3611880" y="4443984"/>
             <a:ext cx="8348472" cy="365760"/>
           </a:xfrm>
           <a:prstGeom prst="rect">
@@ -8974,7 +8974,7 @@
         </p:nvSpPr>
         <p:spPr>
           <a:xfrm>
-            <a:off x="3410712" y="4727448"/>
+            <a:off x="3410712" y="4946904"/>
             <a:ext cx="91440" cy="91440"/>
           </a:xfrm>
           <a:prstGeom prst="ellipse">
@@ -9001,7 +9001,7 @@
         </p:nvSpPr>
         <p:spPr>
           <a:xfrm>
-            <a:off x="3611880" y="4590288"/>
+            <a:off x="3611880" y="4809744"/>
             <a:ext cx="8348472" cy="365760"/>
           </a:xfrm>
           <a:prstGeom prst="rect">
@@ -9042,7 +9042,7 @@
         </p:nvSpPr>
         <p:spPr>
           <a:xfrm>
-            <a:off x="3410712" y="4983480"/>
+            <a:off x="3410712" y="5047488"/>
             <a:ext cx="1188720" cy="256032"/>
           </a:xfrm>
           <a:prstGeom prst="rect">
@@ -9083,8 +9083,8 @@
         </p:nvSpPr>
         <p:spPr>
           <a:xfrm>
-            <a:off x="3410712" y="5184648"/>
-            <a:ext cx="8549640" cy="502920"/>
+            <a:off x="3410712" y="5248656"/>
+            <a:ext cx="8549640" cy="411480"/>
           </a:xfrm>
           <a:prstGeom prst="rect">
             <a:avLst/>
@@ -9124,7 +9124,7 @@
         </p:nvSpPr>
         <p:spPr>
           <a:xfrm>
-            <a:off x="3410712" y="5559552"/>
+            <a:off x="3410712" y="5486400"/>
             <a:ext cx="8549640" cy="219456"/>
           </a:xfrm>
           <a:prstGeom prst="rect">
@@ -9165,8 +9165,8 @@
         </p:nvSpPr>
         <p:spPr>
           <a:xfrm>
-            <a:off x="3410712" y="5742432"/>
-            <a:ext cx="8549640" cy="896112"/>
+            <a:off x="3410712" y="5669280"/>
+            <a:ext cx="8549640" cy="749808"/>
           </a:xfrm>
           <a:prstGeom prst="rect">
             <a:avLst/>
@@ -9677,7 +9677,7 @@
         </p:nvSpPr>
         <p:spPr>
           <a:xfrm>
-            <a:off x="3410712" y="3630168"/>
+            <a:off x="3410712" y="3849624"/>
             <a:ext cx="91440" cy="91440"/>
           </a:xfrm>
           <a:prstGeom prst="ellipse">
@@ -9704,7 +9704,7 @@
         </p:nvSpPr>
         <p:spPr>
           <a:xfrm>
-            <a:off x="3611880" y="3493008"/>
+            <a:off x="3611880" y="3712464"/>
             <a:ext cx="8348472" cy="365760"/>
           </a:xfrm>
           <a:prstGeom prst="rect">
@@ -9745,7 +9745,7 @@
         </p:nvSpPr>
         <p:spPr>
           <a:xfrm>
-            <a:off x="3410712" y="3995928"/>
+            <a:off x="3410712" y="4215384"/>
             <a:ext cx="91440" cy="91440"/>
           </a:xfrm>
           <a:prstGeom prst="ellipse">
@@ -9772,7 +9772,7 @@
         </p:nvSpPr>
         <p:spPr>
           <a:xfrm>
-            <a:off x="3611880" y="3858768"/>
+            <a:off x="3611880" y="4078224"/>
             <a:ext cx="8348472" cy="365760"/>
           </a:xfrm>
           <a:prstGeom prst="rect">
@@ -9813,7 +9813,7 @@
         </p:nvSpPr>
         <p:spPr>
           <a:xfrm>
-            <a:off x="3410712" y="4361688"/>
+            <a:off x="3410712" y="4581144"/>
             <a:ext cx="91440" cy="91440"/>
           </a:xfrm>
           <a:prstGeom prst="ellipse">
@@ -9840,7 +9840,7 @@
         </p:nvSpPr>
         <p:spPr>
           <a:xfrm>
-            <a:off x="3611880" y="4224528"/>
+            <a:off x="3611880" y="4443984"/>
             <a:ext cx="8348472" cy="365760"/>
           </a:xfrm>
           <a:prstGeom prst="rect">
@@ -9881,7 +9881,7 @@
         </p:nvSpPr>
         <p:spPr>
           <a:xfrm>
-            <a:off x="3410712" y="4727448"/>
+            <a:off x="3410712" y="4946904"/>
             <a:ext cx="91440" cy="91440"/>
           </a:xfrm>
           <a:prstGeom prst="ellipse">
@@ -9908,7 +9908,7 @@
         </p:nvSpPr>
         <p:spPr>
           <a:xfrm>
-            <a:off x="3611880" y="4590288"/>
+            <a:off x="3611880" y="4809744"/>
             <a:ext cx="8348472" cy="365760"/>
           </a:xfrm>
           <a:prstGeom prst="rect">
@@ -9949,7 +9949,7 @@
         </p:nvSpPr>
         <p:spPr>
           <a:xfrm>
-            <a:off x="3410712" y="4983480"/>
+            <a:off x="3410712" y="5047488"/>
             <a:ext cx="1188720" cy="256032"/>
           </a:xfrm>
           <a:prstGeom prst="rect">
@@ -9990,8 +9990,8 @@
         </p:nvSpPr>
         <p:spPr>
           <a:xfrm>
-            <a:off x="3410712" y="5184648"/>
-            <a:ext cx="8549640" cy="502920"/>
+            <a:off x="3410712" y="5248656"/>
+            <a:ext cx="8549640" cy="411480"/>
           </a:xfrm>
           <a:prstGeom prst="rect">
             <a:avLst/>
@@ -10031,7 +10031,7 @@
         </p:nvSpPr>
         <p:spPr>
           <a:xfrm>
-            <a:off x="3410712" y="5559552"/>
+            <a:off x="3410712" y="5486400"/>
             <a:ext cx="8549640" cy="219456"/>
           </a:xfrm>
           <a:prstGeom prst="rect">
@@ -10072,8 +10072,8 @@
         </p:nvSpPr>
         <p:spPr>
           <a:xfrm>
-            <a:off x="3410712" y="5742432"/>
-            <a:ext cx="8549640" cy="896112"/>
+            <a:off x="3410712" y="5669280"/>
+            <a:ext cx="8549640" cy="749808"/>
           </a:xfrm>
           <a:prstGeom prst="rect">
             <a:avLst/>
@@ -10584,7 +10584,7 @@
         </p:nvSpPr>
         <p:spPr>
           <a:xfrm>
-            <a:off x="3410712" y="3630168"/>
+            <a:off x="3410712" y="3849624"/>
             <a:ext cx="91440" cy="91440"/>
           </a:xfrm>
           <a:prstGeom prst="ellipse">
@@ -10611,7 +10611,7 @@
         </p:nvSpPr>
         <p:spPr>
           <a:xfrm>
-            <a:off x="3611880" y="3493008"/>
+            <a:off x="3611880" y="3712464"/>
             <a:ext cx="8348472" cy="365760"/>
           </a:xfrm>
           <a:prstGeom prst="rect">
@@ -10652,7 +10652,7 @@
         </p:nvSpPr>
         <p:spPr>
           <a:xfrm>
-            <a:off x="3410712" y="3995928"/>
+            <a:off x="3410712" y="4215384"/>
             <a:ext cx="91440" cy="91440"/>
           </a:xfrm>
           <a:prstGeom prst="ellipse">
@@ -10679,7 +10679,7 @@
         </p:nvSpPr>
         <p:spPr>
           <a:xfrm>
-            <a:off x="3611880" y="3858768"/>
+            <a:off x="3611880" y="4078224"/>
             <a:ext cx="8348472" cy="365760"/>
           </a:xfrm>
           <a:prstGeom prst="rect">
@@ -10720,7 +10720,7 @@
         </p:nvSpPr>
         <p:spPr>
           <a:xfrm>
-            <a:off x="3410712" y="4361688"/>
+            <a:off x="3410712" y="4581144"/>
             <a:ext cx="91440" cy="91440"/>
           </a:xfrm>
           <a:prstGeom prst="ellipse">
@@ -10747,7 +10747,7 @@
         </p:nvSpPr>
         <p:spPr>
           <a:xfrm>
-            <a:off x="3611880" y="4224528"/>
+            <a:off x="3611880" y="4443984"/>
             <a:ext cx="8348472" cy="365760"/>
           </a:xfrm>
           <a:prstGeom prst="rect">
@@ -10788,7 +10788,7 @@
         </p:nvSpPr>
         <p:spPr>
           <a:xfrm>
-            <a:off x="3410712" y="4727448"/>
+            <a:off x="3410712" y="4946904"/>
             <a:ext cx="91440" cy="91440"/>
           </a:xfrm>
           <a:prstGeom prst="ellipse">
@@ -10815,7 +10815,7 @@
         </p:nvSpPr>
         <p:spPr>
           <a:xfrm>
-            <a:off x="3611880" y="4590288"/>
+            <a:off x="3611880" y="4809744"/>
             <a:ext cx="8348472" cy="365760"/>
           </a:xfrm>
           <a:prstGeom prst="rect">
@@ -10856,7 +10856,7 @@
         </p:nvSpPr>
         <p:spPr>
           <a:xfrm>
-            <a:off x="3410712" y="4983480"/>
+            <a:off x="3410712" y="5047488"/>
             <a:ext cx="1188720" cy="256032"/>
           </a:xfrm>
           <a:prstGeom prst="rect">
@@ -10897,8 +10897,8 @@
         </p:nvSpPr>
         <p:spPr>
           <a:xfrm>
-            <a:off x="3410712" y="5184648"/>
-            <a:ext cx="8549640" cy="502920"/>
+            <a:off x="3410712" y="5248656"/>
+            <a:ext cx="8549640" cy="411480"/>
           </a:xfrm>
           <a:prstGeom prst="rect">
             <a:avLst/>
@@ -10938,7 +10938,7 @@
         </p:nvSpPr>
         <p:spPr>
           <a:xfrm>
-            <a:off x="3410712" y="5559552"/>
+            <a:off x="3410712" y="5486400"/>
             <a:ext cx="8549640" cy="219456"/>
           </a:xfrm>
           <a:prstGeom prst="rect">
@@ -10979,8 +10979,8 @@
         </p:nvSpPr>
         <p:spPr>
           <a:xfrm>
-            <a:off x="3410712" y="5742432"/>
-            <a:ext cx="8549640" cy="896112"/>
+            <a:off x="3410712" y="5669280"/>
+            <a:ext cx="8549640" cy="749808"/>
           </a:xfrm>
           <a:prstGeom prst="rect">
             <a:avLst/>
@@ -11491,7 +11491,7 @@
         </p:nvSpPr>
         <p:spPr>
           <a:xfrm>
-            <a:off x="3410712" y="3630168"/>
+            <a:off x="3410712" y="3849624"/>
             <a:ext cx="91440" cy="91440"/>
           </a:xfrm>
           <a:prstGeom prst="ellipse">
@@ -11518,7 +11518,7 @@
         </p:nvSpPr>
         <p:spPr>
           <a:xfrm>
-            <a:off x="3611880" y="3493008"/>
+            <a:off x="3611880" y="3712464"/>
             <a:ext cx="8348472" cy="365760"/>
           </a:xfrm>
           <a:prstGeom prst="rect">
@@ -11559,7 +11559,7 @@
         </p:nvSpPr>
         <p:spPr>
           <a:xfrm>
-            <a:off x="3410712" y="3995928"/>
+            <a:off x="3410712" y="4215384"/>
             <a:ext cx="91440" cy="91440"/>
           </a:xfrm>
           <a:prstGeom prst="ellipse">
@@ -11586,7 +11586,7 @@
         </p:nvSpPr>
         <p:spPr>
           <a:xfrm>
-            <a:off x="3611880" y="3858768"/>
+            <a:off x="3611880" y="4078224"/>
             <a:ext cx="8348472" cy="365760"/>
           </a:xfrm>
           <a:prstGeom prst="rect">
@@ -11627,7 +11627,7 @@
         </p:nvSpPr>
         <p:spPr>
           <a:xfrm>
-            <a:off x="3410712" y="4361688"/>
+            <a:off x="3410712" y="4581144"/>
             <a:ext cx="91440" cy="91440"/>
           </a:xfrm>
           <a:prstGeom prst="ellipse">
@@ -11654,7 +11654,7 @@
         </p:nvSpPr>
         <p:spPr>
           <a:xfrm>
-            <a:off x="3611880" y="4224528"/>
+            <a:off x="3611880" y="4443984"/>
             <a:ext cx="8348472" cy="365760"/>
           </a:xfrm>
           <a:prstGeom prst="rect">
@@ -11695,7 +11695,7 @@
         </p:nvSpPr>
         <p:spPr>
           <a:xfrm>
-            <a:off x="3410712" y="4727448"/>
+            <a:off x="3410712" y="4946904"/>
             <a:ext cx="91440" cy="91440"/>
           </a:xfrm>
           <a:prstGeom prst="ellipse">
@@ -11722,7 +11722,7 @@
         </p:nvSpPr>
         <p:spPr>
           <a:xfrm>
-            <a:off x="3611880" y="4590288"/>
+            <a:off x="3611880" y="4809744"/>
             <a:ext cx="8348472" cy="365760"/>
           </a:xfrm>
           <a:prstGeom prst="rect">
@@ -11763,7 +11763,7 @@
         </p:nvSpPr>
         <p:spPr>
           <a:xfrm>
-            <a:off x="3410712" y="4983480"/>
+            <a:off x="3410712" y="5047488"/>
             <a:ext cx="1188720" cy="256032"/>
           </a:xfrm>
           <a:prstGeom prst="rect">
@@ -11804,8 +11804,8 @@
         </p:nvSpPr>
         <p:spPr>
           <a:xfrm>
-            <a:off x="3410712" y="5184648"/>
-            <a:ext cx="8549640" cy="502920"/>
+            <a:off x="3410712" y="5248656"/>
+            <a:ext cx="8549640" cy="411480"/>
           </a:xfrm>
           <a:prstGeom prst="rect">
             <a:avLst/>
@@ -11845,7 +11845,7 @@
         </p:nvSpPr>
         <p:spPr>
           <a:xfrm>
-            <a:off x="3410712" y="5559552"/>
+            <a:off x="3410712" y="5486400"/>
             <a:ext cx="8549640" cy="219456"/>
           </a:xfrm>
           <a:prstGeom prst="rect">
@@ -11886,8 +11886,8 @@
         </p:nvSpPr>
         <p:spPr>
           <a:xfrm>
-            <a:off x="3410712" y="5742432"/>
-            <a:ext cx="8549640" cy="896112"/>
+            <a:off x="3410712" y="5669280"/>
+            <a:ext cx="8549640" cy="749808"/>
           </a:xfrm>
           <a:prstGeom prst="rect">
             <a:avLst/>
@@ -12398,7 +12398,7 @@
         </p:nvSpPr>
         <p:spPr>
           <a:xfrm>
-            <a:off x="3410712" y="3630168"/>
+            <a:off x="3410712" y="3849624"/>
             <a:ext cx="91440" cy="91440"/>
           </a:xfrm>
           <a:prstGeom prst="ellipse">
@@ -12425,7 +12425,7 @@
         </p:nvSpPr>
         <p:spPr>
           <a:xfrm>
-            <a:off x="3611880" y="3493008"/>
+            <a:off x="3611880" y="3712464"/>
             <a:ext cx="8348472" cy="365760"/>
           </a:xfrm>
           <a:prstGeom prst="rect">
@@ -12466,7 +12466,7 @@
         </p:nvSpPr>
         <p:spPr>
           <a:xfrm>
-            <a:off x="3410712" y="3995928"/>
+            <a:off x="3410712" y="4215384"/>
             <a:ext cx="91440" cy="91440"/>
           </a:xfrm>
           <a:prstGeom prst="ellipse">
@@ -12493,7 +12493,7 @@
         </p:nvSpPr>
         <p:spPr>
           <a:xfrm>
-            <a:off x="3611880" y="3858768"/>
+            <a:off x="3611880" y="4078224"/>
             <a:ext cx="8348472" cy="365760"/>
           </a:xfrm>
           <a:prstGeom prst="rect">
@@ -12534,7 +12534,7 @@
         </p:nvSpPr>
         <p:spPr>
           <a:xfrm>
-            <a:off x="3410712" y="4361688"/>
+            <a:off x="3410712" y="4581144"/>
             <a:ext cx="91440" cy="91440"/>
           </a:xfrm>
           <a:prstGeom prst="ellipse">
@@ -12561,7 +12561,7 @@
         </p:nvSpPr>
         <p:spPr>
           <a:xfrm>
-            <a:off x="3611880" y="4224528"/>
+            <a:off x="3611880" y="4443984"/>
             <a:ext cx="8348472" cy="365760"/>
           </a:xfrm>
           <a:prstGeom prst="rect">
@@ -12602,7 +12602,7 @@
         </p:nvSpPr>
         <p:spPr>
           <a:xfrm>
-            <a:off x="3410712" y="4727448"/>
+            <a:off x="3410712" y="4946904"/>
             <a:ext cx="91440" cy="91440"/>
           </a:xfrm>
           <a:prstGeom prst="ellipse">
@@ -12629,7 +12629,7 @@
         </p:nvSpPr>
         <p:spPr>
           <a:xfrm>
-            <a:off x="3611880" y="4590288"/>
+            <a:off x="3611880" y="4809744"/>
             <a:ext cx="8348472" cy="365760"/>
           </a:xfrm>
           <a:prstGeom prst="rect">
@@ -12670,7 +12670,7 @@
         </p:nvSpPr>
         <p:spPr>
           <a:xfrm>
-            <a:off x="3410712" y="4983480"/>
+            <a:off x="3410712" y="5047488"/>
             <a:ext cx="1188720" cy="256032"/>
           </a:xfrm>
           <a:prstGeom prst="rect">
@@ -12711,8 +12711,8 @@
         </p:nvSpPr>
         <p:spPr>
           <a:xfrm>
-            <a:off x="3410712" y="5184648"/>
-            <a:ext cx="8549640" cy="502920"/>
+            <a:off x="3410712" y="5248656"/>
+            <a:ext cx="8549640" cy="411480"/>
           </a:xfrm>
           <a:prstGeom prst="rect">
             <a:avLst/>
@@ -12752,7 +12752,7 @@
         </p:nvSpPr>
         <p:spPr>
           <a:xfrm>
-            <a:off x="3410712" y="5559552"/>
+            <a:off x="3410712" y="5486400"/>
             <a:ext cx="8549640" cy="219456"/>
           </a:xfrm>
           <a:prstGeom prst="rect">
@@ -12793,8 +12793,8 @@
         </p:nvSpPr>
         <p:spPr>
           <a:xfrm>
-            <a:off x="3410712" y="5742432"/>
-            <a:ext cx="8549640" cy="896112"/>
+            <a:off x="3410712" y="5669280"/>
+            <a:ext cx="8549640" cy="749808"/>
           </a:xfrm>
           <a:prstGeom prst="rect">
             <a:avLst/>
@@ -13305,7 +13305,7 @@
         </p:nvSpPr>
         <p:spPr>
           <a:xfrm>
-            <a:off x="3410712" y="3630168"/>
+            <a:off x="3410712" y="3849624"/>
             <a:ext cx="91440" cy="91440"/>
           </a:xfrm>
           <a:prstGeom prst="ellipse">
@@ -13332,7 +13332,7 @@
         </p:nvSpPr>
         <p:spPr>
           <a:xfrm>
-            <a:off x="3611880" y="3493008"/>
+            <a:off x="3611880" y="3712464"/>
             <a:ext cx="8348472" cy="365760"/>
           </a:xfrm>
           <a:prstGeom prst="rect">
@@ -13373,7 +13373,7 @@
         </p:nvSpPr>
         <p:spPr>
           <a:xfrm>
-            <a:off x="3410712" y="3995928"/>
+            <a:off x="3410712" y="4215384"/>
             <a:ext cx="91440" cy="91440"/>
           </a:xfrm>
           <a:prstGeom prst="ellipse">
@@ -13400,7 +13400,7 @@
         </p:nvSpPr>
         <p:spPr>
           <a:xfrm>
-            <a:off x="3611880" y="3858768"/>
+            <a:off x="3611880" y="4078224"/>
             <a:ext cx="8348472" cy="365760"/>
           </a:xfrm>
           <a:prstGeom prst="rect">
@@ -13441,7 +13441,7 @@
         </p:nvSpPr>
         <p:spPr>
           <a:xfrm>
-            <a:off x="3410712" y="4361688"/>
+            <a:off x="3410712" y="4581144"/>
             <a:ext cx="91440" cy="91440"/>
           </a:xfrm>
           <a:prstGeom prst="ellipse">
@@ -13468,7 +13468,7 @@
         </p:nvSpPr>
         <p:spPr>
           <a:xfrm>
-            <a:off x="3611880" y="4224528"/>
+            <a:off x="3611880" y="4443984"/>
             <a:ext cx="8348472" cy="365760"/>
           </a:xfrm>
           <a:prstGeom prst="rect">
@@ -13509,7 +13509,7 @@
         </p:nvSpPr>
         <p:spPr>
           <a:xfrm>
-            <a:off x="3410712" y="4727448"/>
+            <a:off x="3410712" y="4946904"/>
             <a:ext cx="91440" cy="91440"/>
           </a:xfrm>
           <a:prstGeom prst="ellipse">
@@ -13536,7 +13536,7 @@
         </p:nvSpPr>
         <p:spPr>
           <a:xfrm>
-            <a:off x="3611880" y="4590288"/>
+            <a:off x="3611880" y="4809744"/>
             <a:ext cx="8348472" cy="365760"/>
           </a:xfrm>
           <a:prstGeom prst="rect">
@@ -13577,7 +13577,7 @@
         </p:nvSpPr>
         <p:spPr>
           <a:xfrm>
-            <a:off x="3410712" y="4983480"/>
+            <a:off x="3410712" y="5047488"/>
             <a:ext cx="1188720" cy="256032"/>
           </a:xfrm>
           <a:prstGeom prst="rect">
@@ -13618,8 +13618,8 @@
         </p:nvSpPr>
         <p:spPr>
           <a:xfrm>
-            <a:off x="3410712" y="5184648"/>
-            <a:ext cx="8549640" cy="502920"/>
+            <a:off x="3410712" y="5248656"/>
+            <a:ext cx="8549640" cy="411480"/>
           </a:xfrm>
           <a:prstGeom prst="rect">
             <a:avLst/>
@@ -13659,7 +13659,7 @@
         </p:nvSpPr>
         <p:spPr>
           <a:xfrm>
-            <a:off x="3410712" y="5559552"/>
+            <a:off x="3410712" y="5486400"/>
             <a:ext cx="8549640" cy="219456"/>
           </a:xfrm>
           <a:prstGeom prst="rect">
@@ -13700,8 +13700,8 @@
         </p:nvSpPr>
         <p:spPr>
           <a:xfrm>
-            <a:off x="3410712" y="5742432"/>
-            <a:ext cx="8549640" cy="896112"/>
+            <a:off x="3410712" y="5669280"/>
+            <a:ext cx="8549640" cy="749808"/>
           </a:xfrm>
           <a:prstGeom prst="rect">
             <a:avLst/>
@@ -14212,7 +14212,7 @@
         </p:nvSpPr>
         <p:spPr>
           <a:xfrm>
-            <a:off x="3410712" y="3630168"/>
+            <a:off x="3410712" y="3849624"/>
             <a:ext cx="91440" cy="91440"/>
           </a:xfrm>
           <a:prstGeom prst="ellipse">
@@ -14239,7 +14239,7 @@
         </p:nvSpPr>
         <p:spPr>
           <a:xfrm>
-            <a:off x="3611880" y="3493008"/>
+            <a:off x="3611880" y="3712464"/>
             <a:ext cx="8348472" cy="365760"/>
           </a:xfrm>
           <a:prstGeom prst="rect">
@@ -14280,7 +14280,7 @@
         </p:nvSpPr>
         <p:spPr>
           <a:xfrm>
-            <a:off x="3410712" y="3995928"/>
+            <a:off x="3410712" y="4215384"/>
             <a:ext cx="91440" cy="91440"/>
           </a:xfrm>
           <a:prstGeom prst="ellipse">
@@ -14307,7 +14307,7 @@
         </p:nvSpPr>
         <p:spPr>
           <a:xfrm>
-            <a:off x="3611880" y="3858768"/>
+            <a:off x="3611880" y="4078224"/>
             <a:ext cx="8348472" cy="365760"/>
           </a:xfrm>
           <a:prstGeom prst="rect">
@@ -14348,7 +14348,7 @@
         </p:nvSpPr>
         <p:spPr>
           <a:xfrm>
-            <a:off x="3410712" y="4361688"/>
+            <a:off x="3410712" y="4581144"/>
             <a:ext cx="91440" cy="91440"/>
           </a:xfrm>
           <a:prstGeom prst="ellipse">
@@ -14375,7 +14375,7 @@
         </p:nvSpPr>
         <p:spPr>
           <a:xfrm>
-            <a:off x="3611880" y="4224528"/>
+            <a:off x="3611880" y="4443984"/>
             <a:ext cx="8348472" cy="365760"/>
           </a:xfrm>
           <a:prstGeom prst="rect">
@@ -14416,7 +14416,7 @@
         </p:nvSpPr>
         <p:spPr>
           <a:xfrm>
-            <a:off x="3410712" y="4727448"/>
+            <a:off x="3410712" y="4946904"/>
             <a:ext cx="91440" cy="91440"/>
           </a:xfrm>
           <a:prstGeom prst="ellipse">
@@ -14443,7 +14443,7 @@
         </p:nvSpPr>
         <p:spPr>
           <a:xfrm>
-            <a:off x="3611880" y="4590288"/>
+            <a:off x="3611880" y="4809744"/>
             <a:ext cx="8348472" cy="365760"/>
           </a:xfrm>
           <a:prstGeom prst="rect">
@@ -14484,7 +14484,7 @@
         </p:nvSpPr>
         <p:spPr>
           <a:xfrm>
-            <a:off x="3410712" y="4983480"/>
+            <a:off x="3410712" y="5047488"/>
             <a:ext cx="1188720" cy="256032"/>
           </a:xfrm>
           <a:prstGeom prst="rect">
@@ -14525,8 +14525,8 @@
         </p:nvSpPr>
         <p:spPr>
           <a:xfrm>
-            <a:off x="3410712" y="5184648"/>
-            <a:ext cx="8549640" cy="502920"/>
+            <a:off x="3410712" y="5248656"/>
+            <a:ext cx="8549640" cy="411480"/>
           </a:xfrm>
           <a:prstGeom prst="rect">
             <a:avLst/>
@@ -14566,7 +14566,7 @@
         </p:nvSpPr>
         <p:spPr>
           <a:xfrm>
-            <a:off x="3410712" y="5559552"/>
+            <a:off x="3410712" y="5486400"/>
             <a:ext cx="8549640" cy="219456"/>
           </a:xfrm>
           <a:prstGeom prst="rect">
@@ -14607,8 +14607,8 @@
         </p:nvSpPr>
         <p:spPr>
           <a:xfrm>
-            <a:off x="3410712" y="5742432"/>
-            <a:ext cx="8549640" cy="896112"/>
+            <a:off x="3410712" y="5669280"/>
+            <a:ext cx="8549640" cy="749808"/>
           </a:xfrm>
           <a:prstGeom prst="rect">
             <a:avLst/>
@@ -15119,7 +15119,7 @@
         </p:nvSpPr>
         <p:spPr>
           <a:xfrm>
-            <a:off x="3410712" y="3630168"/>
+            <a:off x="3410712" y="3849624"/>
             <a:ext cx="91440" cy="91440"/>
           </a:xfrm>
           <a:prstGeom prst="ellipse">
@@ -15146,7 +15146,7 @@
         </p:nvSpPr>
         <p:spPr>
           <a:xfrm>
-            <a:off x="3611880" y="3493008"/>
+            <a:off x="3611880" y="3712464"/>
             <a:ext cx="8348472" cy="365760"/>
           </a:xfrm>
           <a:prstGeom prst="rect">
@@ -15187,7 +15187,7 @@
         </p:nvSpPr>
         <p:spPr>
           <a:xfrm>
-            <a:off x="3410712" y="3995928"/>
+            <a:off x="3410712" y="4215384"/>
             <a:ext cx="91440" cy="91440"/>
           </a:xfrm>
           <a:prstGeom prst="ellipse">
@@ -15214,7 +15214,7 @@
         </p:nvSpPr>
         <p:spPr>
           <a:xfrm>
-            <a:off x="3611880" y="3858768"/>
+            <a:off x="3611880" y="4078224"/>
             <a:ext cx="8348472" cy="365760"/>
           </a:xfrm>
           <a:prstGeom prst="rect">
@@ -15255,7 +15255,7 @@
         </p:nvSpPr>
         <p:spPr>
           <a:xfrm>
-            <a:off x="3410712" y="4361688"/>
+            <a:off x="3410712" y="4581144"/>
             <a:ext cx="91440" cy="91440"/>
           </a:xfrm>
           <a:prstGeom prst="ellipse">
@@ -15282,7 +15282,7 @@
         </p:nvSpPr>
         <p:spPr>
           <a:xfrm>
-            <a:off x="3611880" y="4224528"/>
+            <a:off x="3611880" y="4443984"/>
             <a:ext cx="8348472" cy="365760"/>
           </a:xfrm>
           <a:prstGeom prst="rect">
@@ -15323,7 +15323,7 @@
         </p:nvSpPr>
         <p:spPr>
           <a:xfrm>
-            <a:off x="3410712" y="4727448"/>
+            <a:off x="3410712" y="4946904"/>
             <a:ext cx="91440" cy="91440"/>
           </a:xfrm>
           <a:prstGeom prst="ellipse">
@@ -15350,7 +15350,7 @@
         </p:nvSpPr>
         <p:spPr>
           <a:xfrm>
-            <a:off x="3611880" y="4590288"/>
+            <a:off x="3611880" y="4809744"/>
             <a:ext cx="8348472" cy="365760"/>
           </a:xfrm>
           <a:prstGeom prst="rect">
@@ -15391,7 +15391,7 @@
         </p:nvSpPr>
         <p:spPr>
           <a:xfrm>
-            <a:off x="3410712" y="4983480"/>
+            <a:off x="3410712" y="5047488"/>
             <a:ext cx="1188720" cy="256032"/>
           </a:xfrm>
           <a:prstGeom prst="rect">
@@ -15432,8 +15432,8 @@
         </p:nvSpPr>
         <p:spPr>
           <a:xfrm>
-            <a:off x="3410712" y="5184648"/>
-            <a:ext cx="8549640" cy="502920"/>
+            <a:off x="3410712" y="5248656"/>
+            <a:ext cx="8549640" cy="411480"/>
           </a:xfrm>
           <a:prstGeom prst="rect">
             <a:avLst/>
@@ -15473,7 +15473,7 @@
         </p:nvSpPr>
         <p:spPr>
           <a:xfrm>
-            <a:off x="3410712" y="5559552"/>
+            <a:off x="3410712" y="5486400"/>
             <a:ext cx="8549640" cy="219456"/>
           </a:xfrm>
           <a:prstGeom prst="rect">
@@ -15514,8 +15514,8 @@
         </p:nvSpPr>
         <p:spPr>
           <a:xfrm>
-            <a:off x="3410712" y="5742432"/>
-            <a:ext cx="8549640" cy="896112"/>
+            <a:off x="3410712" y="5669280"/>
+            <a:ext cx="8549640" cy="749808"/>
           </a:xfrm>
           <a:prstGeom prst="rect">
             <a:avLst/>
@@ -16026,7 +16026,7 @@
         </p:nvSpPr>
         <p:spPr>
           <a:xfrm>
-            <a:off x="3410712" y="3630168"/>
+            <a:off x="3410712" y="3849624"/>
             <a:ext cx="91440" cy="91440"/>
           </a:xfrm>
           <a:prstGeom prst="ellipse">
@@ -16053,7 +16053,7 @@
         </p:nvSpPr>
         <p:spPr>
           <a:xfrm>
-            <a:off x="3611880" y="3493008"/>
+            <a:off x="3611880" y="3712464"/>
             <a:ext cx="8348472" cy="365760"/>
           </a:xfrm>
           <a:prstGeom prst="rect">
@@ -16094,7 +16094,7 @@
         </p:nvSpPr>
         <p:spPr>
           <a:xfrm>
-            <a:off x="3410712" y="3995928"/>
+            <a:off x="3410712" y="4215384"/>
             <a:ext cx="91440" cy="91440"/>
           </a:xfrm>
           <a:prstGeom prst="ellipse">
@@ -16121,7 +16121,7 @@
         </p:nvSpPr>
         <p:spPr>
           <a:xfrm>
-            <a:off x="3611880" y="3858768"/>
+            <a:off x="3611880" y="4078224"/>
             <a:ext cx="8348472" cy="365760"/>
           </a:xfrm>
           <a:prstGeom prst="rect">
@@ -16162,7 +16162,7 @@
         </p:nvSpPr>
         <p:spPr>
           <a:xfrm>
-            <a:off x="3410712" y="4361688"/>
+            <a:off x="3410712" y="4581144"/>
             <a:ext cx="91440" cy="91440"/>
           </a:xfrm>
           <a:prstGeom prst="ellipse">
@@ -16189,7 +16189,7 @@
         </p:nvSpPr>
         <p:spPr>
           <a:xfrm>
-            <a:off x="3611880" y="4224528"/>
+            <a:off x="3611880" y="4443984"/>
             <a:ext cx="8348472" cy="365760"/>
           </a:xfrm>
           <a:prstGeom prst="rect">
@@ -16230,7 +16230,7 @@
         </p:nvSpPr>
         <p:spPr>
           <a:xfrm>
-            <a:off x="3410712" y="4727448"/>
+            <a:off x="3410712" y="4946904"/>
             <a:ext cx="91440" cy="91440"/>
           </a:xfrm>
           <a:prstGeom prst="ellipse">
@@ -16257,7 +16257,7 @@
         </p:nvSpPr>
         <p:spPr>
           <a:xfrm>
-            <a:off x="3611880" y="4590288"/>
+            <a:off x="3611880" y="4809744"/>
             <a:ext cx="8348472" cy="365760"/>
           </a:xfrm>
           <a:prstGeom prst="rect">
@@ -16298,7 +16298,7 @@
         </p:nvSpPr>
         <p:spPr>
           <a:xfrm>
-            <a:off x="3410712" y="4983480"/>
+            <a:off x="3410712" y="5047488"/>
             <a:ext cx="1188720" cy="256032"/>
           </a:xfrm>
           <a:prstGeom prst="rect">
@@ -16339,8 +16339,8 @@
         </p:nvSpPr>
         <p:spPr>
           <a:xfrm>
-            <a:off x="3410712" y="5184648"/>
-            <a:ext cx="8549640" cy="502920"/>
+            <a:off x="3410712" y="5248656"/>
+            <a:ext cx="8549640" cy="411480"/>
           </a:xfrm>
           <a:prstGeom prst="rect">
             <a:avLst/>
@@ -16380,7 +16380,7 @@
         </p:nvSpPr>
         <p:spPr>
           <a:xfrm>
-            <a:off x="3410712" y="5559552"/>
+            <a:off x="3410712" y="5486400"/>
             <a:ext cx="8549640" cy="219456"/>
           </a:xfrm>
           <a:prstGeom prst="rect">
@@ -16421,8 +16421,8 @@
         </p:nvSpPr>
         <p:spPr>
           <a:xfrm>
-            <a:off x="3410712" y="5742432"/>
-            <a:ext cx="8549640" cy="896112"/>
+            <a:off x="3410712" y="5669280"/>
+            <a:ext cx="8549640" cy="749808"/>
           </a:xfrm>
           <a:prstGeom prst="rect">
             <a:avLst/>
@@ -16933,7 +16933,7 @@
         </p:nvSpPr>
         <p:spPr>
           <a:xfrm>
-            <a:off x="3410712" y="3630168"/>
+            <a:off x="3410712" y="3849624"/>
             <a:ext cx="91440" cy="91440"/>
           </a:xfrm>
           <a:prstGeom prst="ellipse">
@@ -16960,7 +16960,7 @@
         </p:nvSpPr>
         <p:spPr>
           <a:xfrm>
-            <a:off x="3611880" y="3493008"/>
+            <a:off x="3611880" y="3712464"/>
             <a:ext cx="8348472" cy="365760"/>
           </a:xfrm>
           <a:prstGeom prst="rect">
@@ -17001,7 +17001,7 @@
         </p:nvSpPr>
         <p:spPr>
           <a:xfrm>
-            <a:off x="3410712" y="3995928"/>
+            <a:off x="3410712" y="4215384"/>
             <a:ext cx="91440" cy="91440"/>
           </a:xfrm>
           <a:prstGeom prst="ellipse">
@@ -17028,7 +17028,7 @@
         </p:nvSpPr>
         <p:spPr>
           <a:xfrm>
-            <a:off x="3611880" y="3858768"/>
+            <a:off x="3611880" y="4078224"/>
             <a:ext cx="8348472" cy="365760"/>
           </a:xfrm>
           <a:prstGeom prst="rect">
@@ -17069,7 +17069,7 @@
         </p:nvSpPr>
         <p:spPr>
           <a:xfrm>
-            <a:off x="3410712" y="4361688"/>
+            <a:off x="3410712" y="4581144"/>
             <a:ext cx="91440" cy="91440"/>
           </a:xfrm>
           <a:prstGeom prst="ellipse">
@@ -17096,7 +17096,7 @@
         </p:nvSpPr>
         <p:spPr>
           <a:xfrm>
-            <a:off x="3611880" y="4224528"/>
+            <a:off x="3611880" y="4443984"/>
             <a:ext cx="8348472" cy="365760"/>
           </a:xfrm>
           <a:prstGeom prst="rect">
@@ -17137,7 +17137,7 @@
         </p:nvSpPr>
         <p:spPr>
           <a:xfrm>
-            <a:off x="3410712" y="4727448"/>
+            <a:off x="3410712" y="4946904"/>
             <a:ext cx="91440" cy="91440"/>
           </a:xfrm>
           <a:prstGeom prst="ellipse">
@@ -17164,7 +17164,7 @@
         </p:nvSpPr>
         <p:spPr>
           <a:xfrm>
-            <a:off x="3611880" y="4590288"/>
+            <a:off x="3611880" y="4809744"/>
             <a:ext cx="8348472" cy="365760"/>
           </a:xfrm>
           <a:prstGeom prst="rect">
@@ -17205,7 +17205,7 @@
         </p:nvSpPr>
         <p:spPr>
           <a:xfrm>
-            <a:off x="3410712" y="4983480"/>
+            <a:off x="3410712" y="5047488"/>
             <a:ext cx="1188720" cy="256032"/>
           </a:xfrm>
           <a:prstGeom prst="rect">
@@ -17246,8 +17246,8 @@
         </p:nvSpPr>
         <p:spPr>
           <a:xfrm>
-            <a:off x="3410712" y="5184648"/>
-            <a:ext cx="8549640" cy="502920"/>
+            <a:off x="3410712" y="5248656"/>
+            <a:ext cx="8549640" cy="411480"/>
           </a:xfrm>
           <a:prstGeom prst="rect">
             <a:avLst/>
@@ -17287,7 +17287,7 @@
         </p:nvSpPr>
         <p:spPr>
           <a:xfrm>
-            <a:off x="3410712" y="5559552"/>
+            <a:off x="3410712" y="5486400"/>
             <a:ext cx="8549640" cy="219456"/>
           </a:xfrm>
           <a:prstGeom prst="rect">
@@ -17328,8 +17328,8 @@
         </p:nvSpPr>
         <p:spPr>
           <a:xfrm>
-            <a:off x="3410712" y="5742432"/>
-            <a:ext cx="8549640" cy="896112"/>
+            <a:off x="3410712" y="5669280"/>
+            <a:ext cx="8549640" cy="749808"/>
           </a:xfrm>
           <a:prstGeom prst="rect">
             <a:avLst/>
@@ -17840,7 +17840,7 @@
         </p:nvSpPr>
         <p:spPr>
           <a:xfrm>
-            <a:off x="3410712" y="3630168"/>
+            <a:off x="3410712" y="3849624"/>
             <a:ext cx="91440" cy="91440"/>
           </a:xfrm>
           <a:prstGeom prst="ellipse">
@@ -17867,7 +17867,7 @@
         </p:nvSpPr>
         <p:spPr>
           <a:xfrm>
-            <a:off x="3611880" y="3493008"/>
+            <a:off x="3611880" y="3712464"/>
             <a:ext cx="8348472" cy="365760"/>
           </a:xfrm>
           <a:prstGeom prst="rect">
@@ -17908,7 +17908,7 @@
         </p:nvSpPr>
         <p:spPr>
           <a:xfrm>
-            <a:off x="3410712" y="3995928"/>
+            <a:off x="3410712" y="4215384"/>
             <a:ext cx="91440" cy="91440"/>
           </a:xfrm>
           <a:prstGeom prst="ellipse">
@@ -17935,7 +17935,7 @@
         </p:nvSpPr>
         <p:spPr>
           <a:xfrm>
-            <a:off x="3611880" y="3858768"/>
+            <a:off x="3611880" y="4078224"/>
             <a:ext cx="8348472" cy="365760"/>
           </a:xfrm>
           <a:prstGeom prst="rect">
@@ -17976,7 +17976,7 @@
         </p:nvSpPr>
         <p:spPr>
           <a:xfrm>
-            <a:off x="3410712" y="4361688"/>
+            <a:off x="3410712" y="4581144"/>
             <a:ext cx="91440" cy="91440"/>
           </a:xfrm>
           <a:prstGeom prst="ellipse">
@@ -18003,7 +18003,7 @@
         </p:nvSpPr>
         <p:spPr>
           <a:xfrm>
-            <a:off x="3611880" y="4224528"/>
+            <a:off x="3611880" y="4443984"/>
             <a:ext cx="8348472" cy="365760"/>
           </a:xfrm>
           <a:prstGeom prst="rect">
@@ -18044,7 +18044,7 @@
         </p:nvSpPr>
         <p:spPr>
           <a:xfrm>
-            <a:off x="3410712" y="4727448"/>
+            <a:off x="3410712" y="4946904"/>
             <a:ext cx="91440" cy="91440"/>
           </a:xfrm>
           <a:prstGeom prst="ellipse">
@@ -18071,7 +18071,7 @@
         </p:nvSpPr>
         <p:spPr>
           <a:xfrm>
-            <a:off x="3611880" y="4590288"/>
+            <a:off x="3611880" y="4809744"/>
             <a:ext cx="8348472" cy="365760"/>
           </a:xfrm>
           <a:prstGeom prst="rect">
@@ -18112,7 +18112,7 @@
         </p:nvSpPr>
         <p:spPr>
           <a:xfrm>
-            <a:off x="3410712" y="4983480"/>
+            <a:off x="3410712" y="5047488"/>
             <a:ext cx="1188720" cy="256032"/>
           </a:xfrm>
           <a:prstGeom prst="rect">
@@ -18153,8 +18153,8 @@
         </p:nvSpPr>
         <p:spPr>
           <a:xfrm>
-            <a:off x="3410712" y="5184648"/>
-            <a:ext cx="8549640" cy="502920"/>
+            <a:off x="3410712" y="5248656"/>
+            <a:ext cx="8549640" cy="411480"/>
           </a:xfrm>
           <a:prstGeom prst="rect">
             <a:avLst/>
@@ -18194,7 +18194,7 @@
         </p:nvSpPr>
         <p:spPr>
           <a:xfrm>
-            <a:off x="3410712" y="5559552"/>
+            <a:off x="3410712" y="5486400"/>
             <a:ext cx="8549640" cy="219456"/>
           </a:xfrm>
           <a:prstGeom prst="rect">
@@ -18235,8 +18235,8 @@
         </p:nvSpPr>
         <p:spPr>
           <a:xfrm>
-            <a:off x="3410712" y="5742432"/>
-            <a:ext cx="8549640" cy="896112"/>
+            <a:off x="3410712" y="5669280"/>
+            <a:ext cx="8549640" cy="749808"/>
           </a:xfrm>
           <a:prstGeom prst="rect">
             <a:avLst/>
@@ -18747,7 +18747,7 @@
         </p:nvSpPr>
         <p:spPr>
           <a:xfrm>
-            <a:off x="3410712" y="3630168"/>
+            <a:off x="3410712" y="3849624"/>
             <a:ext cx="91440" cy="91440"/>
           </a:xfrm>
           <a:prstGeom prst="ellipse">
@@ -18774,7 +18774,7 @@
         </p:nvSpPr>
         <p:spPr>
           <a:xfrm>
-            <a:off x="3611880" y="3493008"/>
+            <a:off x="3611880" y="3712464"/>
             <a:ext cx="8348472" cy="365760"/>
           </a:xfrm>
           <a:prstGeom prst="rect">
@@ -18815,7 +18815,7 @@
         </p:nvSpPr>
         <p:spPr>
           <a:xfrm>
-            <a:off x="3410712" y="3995928"/>
+            <a:off x="3410712" y="4215384"/>
             <a:ext cx="91440" cy="91440"/>
           </a:xfrm>
           <a:prstGeom prst="ellipse">
@@ -18842,7 +18842,7 @@
         </p:nvSpPr>
         <p:spPr>
           <a:xfrm>
-            <a:off x="3611880" y="3858768"/>
+            <a:off x="3611880" y="4078224"/>
             <a:ext cx="8348472" cy="365760"/>
           </a:xfrm>
           <a:prstGeom prst="rect">
@@ -18883,7 +18883,7 @@
         </p:nvSpPr>
         <p:spPr>
           <a:xfrm>
-            <a:off x="3410712" y="4361688"/>
+            <a:off x="3410712" y="4581144"/>
             <a:ext cx="91440" cy="91440"/>
           </a:xfrm>
           <a:prstGeom prst="ellipse">
@@ -18910,7 +18910,7 @@
         </p:nvSpPr>
         <p:spPr>
           <a:xfrm>
-            <a:off x="3611880" y="4224528"/>
+            <a:off x="3611880" y="4443984"/>
             <a:ext cx="8348472" cy="365760"/>
           </a:xfrm>
           <a:prstGeom prst="rect">
@@ -18951,7 +18951,7 @@
         </p:nvSpPr>
         <p:spPr>
           <a:xfrm>
-            <a:off x="3410712" y="4727448"/>
+            <a:off x="3410712" y="4946904"/>
             <a:ext cx="91440" cy="91440"/>
           </a:xfrm>
           <a:prstGeom prst="ellipse">
@@ -18978,7 +18978,7 @@
         </p:nvSpPr>
         <p:spPr>
           <a:xfrm>
-            <a:off x="3611880" y="4590288"/>
+            <a:off x="3611880" y="4809744"/>
             <a:ext cx="8348472" cy="365760"/>
           </a:xfrm>
           <a:prstGeom prst="rect">
@@ -19019,7 +19019,7 @@
         </p:nvSpPr>
         <p:spPr>
           <a:xfrm>
-            <a:off x="3410712" y="4983480"/>
+            <a:off x="3410712" y="5047488"/>
             <a:ext cx="1188720" cy="256032"/>
           </a:xfrm>
           <a:prstGeom prst="rect">
@@ -19060,8 +19060,8 @@
         </p:nvSpPr>
         <p:spPr>
           <a:xfrm>
-            <a:off x="3410712" y="5184648"/>
-            <a:ext cx="8549640" cy="502920"/>
+            <a:off x="3410712" y="5248656"/>
+            <a:ext cx="8549640" cy="411480"/>
           </a:xfrm>
           <a:prstGeom prst="rect">
             <a:avLst/>
@@ -19101,7 +19101,7 @@
         </p:nvSpPr>
         <p:spPr>
           <a:xfrm>
-            <a:off x="3410712" y="5559552"/>
+            <a:off x="3410712" y="5486400"/>
             <a:ext cx="8549640" cy="219456"/>
           </a:xfrm>
           <a:prstGeom prst="rect">
@@ -19142,8 +19142,8 @@
         </p:nvSpPr>
         <p:spPr>
           <a:xfrm>
-            <a:off x="3410712" y="5742432"/>
-            <a:ext cx="8549640" cy="896112"/>
+            <a:off x="3410712" y="5669280"/>
+            <a:ext cx="8549640" cy="749808"/>
           </a:xfrm>
           <a:prstGeom prst="rect">
             <a:avLst/>
@@ -19654,7 +19654,7 @@
         </p:nvSpPr>
         <p:spPr>
           <a:xfrm>
-            <a:off x="3410712" y="3630168"/>
+            <a:off x="3410712" y="3849624"/>
             <a:ext cx="91440" cy="91440"/>
           </a:xfrm>
           <a:prstGeom prst="ellipse">
@@ -19681,7 +19681,7 @@
         </p:nvSpPr>
         <p:spPr>
           <a:xfrm>
-            <a:off x="3611880" y="3493008"/>
+            <a:off x="3611880" y="3712464"/>
             <a:ext cx="8348472" cy="365760"/>
           </a:xfrm>
           <a:prstGeom prst="rect">
@@ -19722,7 +19722,7 @@
         </p:nvSpPr>
         <p:spPr>
           <a:xfrm>
-            <a:off x="3410712" y="3995928"/>
+            <a:off x="3410712" y="4215384"/>
             <a:ext cx="91440" cy="91440"/>
           </a:xfrm>
           <a:prstGeom prst="ellipse">
@@ -19749,7 +19749,7 @@
         </p:nvSpPr>
         <p:spPr>
           <a:xfrm>
-            <a:off x="3611880" y="3858768"/>
+            <a:off x="3611880" y="4078224"/>
             <a:ext cx="8348472" cy="365760"/>
           </a:xfrm>
           <a:prstGeom prst="rect">
@@ -19790,7 +19790,7 @@
         </p:nvSpPr>
         <p:spPr>
           <a:xfrm>
-            <a:off x="3410712" y="4361688"/>
+            <a:off x="3410712" y="4581144"/>
             <a:ext cx="91440" cy="91440"/>
           </a:xfrm>
           <a:prstGeom prst="ellipse">
@@ -19817,7 +19817,7 @@
         </p:nvSpPr>
         <p:spPr>
           <a:xfrm>
-            <a:off x="3611880" y="4224528"/>
+            <a:off x="3611880" y="4443984"/>
             <a:ext cx="8348472" cy="365760"/>
           </a:xfrm>
           <a:prstGeom prst="rect">
@@ -19858,7 +19858,7 @@
         </p:nvSpPr>
         <p:spPr>
           <a:xfrm>
-            <a:off x="3410712" y="4727448"/>
+            <a:off x="3410712" y="4946904"/>
             <a:ext cx="91440" cy="91440"/>
           </a:xfrm>
           <a:prstGeom prst="ellipse">
@@ -19885,7 +19885,7 @@
         </p:nvSpPr>
         <p:spPr>
           <a:xfrm>
-            <a:off x="3611880" y="4590288"/>
+            <a:off x="3611880" y="4809744"/>
             <a:ext cx="8348472" cy="365760"/>
           </a:xfrm>
           <a:prstGeom prst="rect">
@@ -19926,7 +19926,7 @@
         </p:nvSpPr>
         <p:spPr>
           <a:xfrm>
-            <a:off x="3410712" y="4983480"/>
+            <a:off x="3410712" y="5047488"/>
             <a:ext cx="1188720" cy="256032"/>
           </a:xfrm>
           <a:prstGeom prst="rect">
@@ -19967,8 +19967,8 @@
         </p:nvSpPr>
         <p:spPr>
           <a:xfrm>
-            <a:off x="3410712" y="5184648"/>
-            <a:ext cx="8549640" cy="502920"/>
+            <a:off x="3410712" y="5248656"/>
+            <a:ext cx="8549640" cy="411480"/>
           </a:xfrm>
           <a:prstGeom prst="rect">
             <a:avLst/>
@@ -20008,7 +20008,7 @@
         </p:nvSpPr>
         <p:spPr>
           <a:xfrm>
-            <a:off x="3410712" y="5559552"/>
+            <a:off x="3410712" y="5486400"/>
             <a:ext cx="8549640" cy="219456"/>
           </a:xfrm>
           <a:prstGeom prst="rect">
@@ -20049,8 +20049,8 @@
         </p:nvSpPr>
         <p:spPr>
           <a:xfrm>
-            <a:off x="3410712" y="5742432"/>
-            <a:ext cx="8549640" cy="896112"/>
+            <a:off x="3410712" y="5669280"/>
+            <a:ext cx="8549640" cy="749808"/>
           </a:xfrm>
           <a:prstGeom prst="rect">
             <a:avLst/>
@@ -20561,7 +20561,7 @@
         </p:nvSpPr>
         <p:spPr>
           <a:xfrm>
-            <a:off x="3410712" y="3630168"/>
+            <a:off x="3410712" y="3849624"/>
             <a:ext cx="91440" cy="91440"/>
           </a:xfrm>
           <a:prstGeom prst="ellipse">
@@ -20588,7 +20588,7 @@
         </p:nvSpPr>
         <p:spPr>
           <a:xfrm>
-            <a:off x="3611880" y="3493008"/>
+            <a:off x="3611880" y="3712464"/>
             <a:ext cx="8348472" cy="365760"/>
           </a:xfrm>
           <a:prstGeom prst="rect">
@@ -20629,7 +20629,7 @@
         </p:nvSpPr>
         <p:spPr>
           <a:xfrm>
-            <a:off x="3410712" y="3995928"/>
+            <a:off x="3410712" y="4215384"/>
             <a:ext cx="91440" cy="91440"/>
           </a:xfrm>
           <a:prstGeom prst="ellipse">
@@ -20656,7 +20656,7 @@
         </p:nvSpPr>
         <p:spPr>
           <a:xfrm>
-            <a:off x="3611880" y="3858768"/>
+            <a:off x="3611880" y="4078224"/>
             <a:ext cx="8348472" cy="365760"/>
           </a:xfrm>
           <a:prstGeom prst="rect">
@@ -20697,7 +20697,7 @@
         </p:nvSpPr>
         <p:spPr>
           <a:xfrm>
-            <a:off x="3410712" y="4361688"/>
+            <a:off x="3410712" y="4581144"/>
             <a:ext cx="91440" cy="91440"/>
           </a:xfrm>
           <a:prstGeom prst="ellipse">
@@ -20724,7 +20724,7 @@
         </p:nvSpPr>
         <p:spPr>
           <a:xfrm>
-            <a:off x="3611880" y="4224528"/>
+            <a:off x="3611880" y="4443984"/>
             <a:ext cx="8348472" cy="365760"/>
           </a:xfrm>
           <a:prstGeom prst="rect">
@@ -20765,7 +20765,7 @@
         </p:nvSpPr>
         <p:spPr>
           <a:xfrm>
-            <a:off x="3410712" y="4727448"/>
+            <a:off x="3410712" y="4946904"/>
             <a:ext cx="91440" cy="91440"/>
           </a:xfrm>
           <a:prstGeom prst="ellipse">
@@ -20792,7 +20792,7 @@
         </p:nvSpPr>
         <p:spPr>
           <a:xfrm>
-            <a:off x="3611880" y="4590288"/>
+            <a:off x="3611880" y="4809744"/>
             <a:ext cx="8348472" cy="365760"/>
           </a:xfrm>
           <a:prstGeom prst="rect">
@@ -20833,7 +20833,7 @@
         </p:nvSpPr>
         <p:spPr>
           <a:xfrm>
-            <a:off x="3410712" y="4983480"/>
+            <a:off x="3410712" y="5047488"/>
             <a:ext cx="1188720" cy="256032"/>
           </a:xfrm>
           <a:prstGeom prst="rect">
@@ -20874,8 +20874,8 @@
         </p:nvSpPr>
         <p:spPr>
           <a:xfrm>
-            <a:off x="3410712" y="5184648"/>
-            <a:ext cx="8549640" cy="502920"/>
+            <a:off x="3410712" y="5248656"/>
+            <a:ext cx="8549640" cy="411480"/>
           </a:xfrm>
           <a:prstGeom prst="rect">
             <a:avLst/>
@@ -20915,7 +20915,7 @@
         </p:nvSpPr>
         <p:spPr>
           <a:xfrm>
-            <a:off x="3410712" y="5559552"/>
+            <a:off x="3410712" y="5486400"/>
             <a:ext cx="8549640" cy="219456"/>
           </a:xfrm>
           <a:prstGeom prst="rect">
@@ -20956,8 +20956,8 @@
         </p:nvSpPr>
         <p:spPr>
           <a:xfrm>
-            <a:off x="3410712" y="5742432"/>
-            <a:ext cx="8549640" cy="896112"/>
+            <a:off x="3410712" y="5669280"/>
+            <a:ext cx="8549640" cy="749808"/>
           </a:xfrm>
           <a:prstGeom prst="rect">
             <a:avLst/>
@@ -21468,7 +21468,7 @@
         </p:nvSpPr>
         <p:spPr>
           <a:xfrm>
-            <a:off x="3410712" y="3630168"/>
+            <a:off x="3410712" y="3849624"/>
             <a:ext cx="91440" cy="91440"/>
           </a:xfrm>
           <a:prstGeom prst="ellipse">
@@ -21495,7 +21495,7 @@
         </p:nvSpPr>
         <p:spPr>
           <a:xfrm>
-            <a:off x="3611880" y="3493008"/>
+            <a:off x="3611880" y="3712464"/>
             <a:ext cx="8348472" cy="365760"/>
           </a:xfrm>
           <a:prstGeom prst="rect">
@@ -21536,7 +21536,7 @@
         </p:nvSpPr>
         <p:spPr>
           <a:xfrm>
-            <a:off x="3410712" y="3995928"/>
+            <a:off x="3410712" y="4215384"/>
             <a:ext cx="91440" cy="91440"/>
           </a:xfrm>
           <a:prstGeom prst="ellipse">
@@ -21563,7 +21563,7 @@
         </p:nvSpPr>
         <p:spPr>
           <a:xfrm>
-            <a:off x="3611880" y="3858768"/>
+            <a:off x="3611880" y="4078224"/>
             <a:ext cx="8348472" cy="365760"/>
           </a:xfrm>
           <a:prstGeom prst="rect">
@@ -21604,7 +21604,7 @@
         </p:nvSpPr>
         <p:spPr>
           <a:xfrm>
-            <a:off x="3410712" y="4361688"/>
+            <a:off x="3410712" y="4581144"/>
             <a:ext cx="91440" cy="91440"/>
           </a:xfrm>
           <a:prstGeom prst="ellipse">
@@ -21631,7 +21631,7 @@
         </p:nvSpPr>
         <p:spPr>
           <a:xfrm>
-            <a:off x="3611880" y="4224528"/>
+            <a:off x="3611880" y="4443984"/>
             <a:ext cx="8348472" cy="365760"/>
           </a:xfrm>
           <a:prstGeom prst="rect">
@@ -21672,7 +21672,7 @@
         </p:nvSpPr>
         <p:spPr>
           <a:xfrm>
-            <a:off x="3410712" y="4727448"/>
+            <a:off x="3410712" y="4946904"/>
             <a:ext cx="91440" cy="91440"/>
           </a:xfrm>
           <a:prstGeom prst="ellipse">
@@ -21699,7 +21699,7 @@
         </p:nvSpPr>
         <p:spPr>
           <a:xfrm>
-            <a:off x="3611880" y="4590288"/>
+            <a:off x="3611880" y="4809744"/>
             <a:ext cx="8348472" cy="365760"/>
           </a:xfrm>
           <a:prstGeom prst="rect">
@@ -21740,7 +21740,7 @@
         </p:nvSpPr>
         <p:spPr>
           <a:xfrm>
-            <a:off x="3410712" y="4983480"/>
+            <a:off x="3410712" y="5047488"/>
             <a:ext cx="1188720" cy="256032"/>
           </a:xfrm>
           <a:prstGeom prst="rect">
@@ -21781,8 +21781,8 @@
         </p:nvSpPr>
         <p:spPr>
           <a:xfrm>
-            <a:off x="3410712" y="5184648"/>
-            <a:ext cx="8549640" cy="502920"/>
+            <a:off x="3410712" y="5248656"/>
+            <a:ext cx="8549640" cy="411480"/>
           </a:xfrm>
           <a:prstGeom prst="rect">
             <a:avLst/>
@@ -21822,7 +21822,7 @@
         </p:nvSpPr>
         <p:spPr>
           <a:xfrm>
-            <a:off x="3410712" y="5559552"/>
+            <a:off x="3410712" y="5486400"/>
             <a:ext cx="8549640" cy="219456"/>
           </a:xfrm>
           <a:prstGeom prst="rect">
@@ -21863,8 +21863,8 @@
         </p:nvSpPr>
         <p:spPr>
           <a:xfrm>
-            <a:off x="3410712" y="5742432"/>
-            <a:ext cx="8549640" cy="896112"/>
+            <a:off x="3410712" y="5669280"/>
+            <a:ext cx="8549640" cy="749808"/>
           </a:xfrm>
           <a:prstGeom prst="rect">
             <a:avLst/>
@@ -22375,7 +22375,7 @@
         </p:nvSpPr>
         <p:spPr>
           <a:xfrm>
-            <a:off x="3410712" y="3630168"/>
+            <a:off x="3410712" y="3849624"/>
             <a:ext cx="91440" cy="91440"/>
           </a:xfrm>
           <a:prstGeom prst="ellipse">
@@ -22402,7 +22402,7 @@
         </p:nvSpPr>
         <p:spPr>
           <a:xfrm>
-            <a:off x="3611880" y="3493008"/>
+            <a:off x="3611880" y="3712464"/>
             <a:ext cx="8348472" cy="365760"/>
           </a:xfrm>
           <a:prstGeom prst="rect">
@@ -22443,7 +22443,7 @@
         </p:nvSpPr>
         <p:spPr>
           <a:xfrm>
-            <a:off x="3410712" y="3995928"/>
+            <a:off x="3410712" y="4215384"/>
             <a:ext cx="91440" cy="91440"/>
           </a:xfrm>
           <a:prstGeom prst="ellipse">
@@ -22470,7 +22470,7 @@
         </p:nvSpPr>
         <p:spPr>
           <a:xfrm>
-            <a:off x="3611880" y="3858768"/>
+            <a:off x="3611880" y="4078224"/>
             <a:ext cx="8348472" cy="365760"/>
           </a:xfrm>
           <a:prstGeom prst="rect">
@@ -22511,7 +22511,7 @@
         </p:nvSpPr>
         <p:spPr>
           <a:xfrm>
-            <a:off x="3410712" y="4361688"/>
+            <a:off x="3410712" y="4581144"/>
             <a:ext cx="91440" cy="91440"/>
           </a:xfrm>
           <a:prstGeom prst="ellipse">
@@ -22538,7 +22538,7 @@
         </p:nvSpPr>
         <p:spPr>
           <a:xfrm>
-            <a:off x="3611880" y="4224528"/>
+            <a:off x="3611880" y="4443984"/>
             <a:ext cx="8348472" cy="365760"/>
           </a:xfrm>
           <a:prstGeom prst="rect">
@@ -22579,7 +22579,7 @@
         </p:nvSpPr>
         <p:spPr>
           <a:xfrm>
-            <a:off x="3410712" y="4727448"/>
+            <a:off x="3410712" y="4946904"/>
             <a:ext cx="91440" cy="91440"/>
           </a:xfrm>
           <a:prstGeom prst="ellipse">
@@ -22606,7 +22606,7 @@
         </p:nvSpPr>
         <p:spPr>
           <a:xfrm>
-            <a:off x="3611880" y="4590288"/>
+            <a:off x="3611880" y="4809744"/>
             <a:ext cx="8348472" cy="365760"/>
           </a:xfrm>
           <a:prstGeom prst="rect">
@@ -22647,7 +22647,7 @@
         </p:nvSpPr>
         <p:spPr>
           <a:xfrm>
-            <a:off x="3410712" y="4983480"/>
+            <a:off x="3410712" y="5047488"/>
             <a:ext cx="1188720" cy="256032"/>
           </a:xfrm>
           <a:prstGeom prst="rect">
@@ -22688,8 +22688,8 @@
         </p:nvSpPr>
         <p:spPr>
           <a:xfrm>
-            <a:off x="3410712" y="5184648"/>
-            <a:ext cx="8549640" cy="502920"/>
+            <a:off x="3410712" y="5248656"/>
+            <a:ext cx="8549640" cy="411480"/>
           </a:xfrm>
           <a:prstGeom prst="rect">
             <a:avLst/>
@@ -22729,7 +22729,7 @@
         </p:nvSpPr>
         <p:spPr>
           <a:xfrm>
-            <a:off x="3410712" y="5559552"/>
+            <a:off x="3410712" y="5486400"/>
             <a:ext cx="8549640" cy="219456"/>
           </a:xfrm>
           <a:prstGeom prst="rect">
@@ -22770,8 +22770,8 @@
         </p:nvSpPr>
         <p:spPr>
           <a:xfrm>
-            <a:off x="3410712" y="5742432"/>
-            <a:ext cx="8549640" cy="896112"/>
+            <a:off x="3410712" y="5669280"/>
+            <a:ext cx="8549640" cy="749808"/>
           </a:xfrm>
           <a:prstGeom prst="rect">
             <a:avLst/>
@@ -23282,7 +23282,7 @@
         </p:nvSpPr>
         <p:spPr>
           <a:xfrm>
-            <a:off x="3410712" y="3630168"/>
+            <a:off x="3410712" y="3849624"/>
             <a:ext cx="91440" cy="91440"/>
           </a:xfrm>
           <a:prstGeom prst="ellipse">
@@ -23309,7 +23309,7 @@
         </p:nvSpPr>
         <p:spPr>
           <a:xfrm>
-            <a:off x="3611880" y="3493008"/>
+            <a:off x="3611880" y="3712464"/>
             <a:ext cx="8348472" cy="365760"/>
           </a:xfrm>
           <a:prstGeom prst="rect">
@@ -23350,7 +23350,7 @@
         </p:nvSpPr>
         <p:spPr>
           <a:xfrm>
-            <a:off x="3410712" y="3995928"/>
+            <a:off x="3410712" y="4215384"/>
             <a:ext cx="91440" cy="91440"/>
           </a:xfrm>
           <a:prstGeom prst="ellipse">
@@ -23377,7 +23377,7 @@
         </p:nvSpPr>
         <p:spPr>
           <a:xfrm>
-            <a:off x="3611880" y="3858768"/>
+            <a:off x="3611880" y="4078224"/>
             <a:ext cx="8348472" cy="365760"/>
           </a:xfrm>
           <a:prstGeom prst="rect">
@@ -23418,7 +23418,7 @@
         </p:nvSpPr>
         <p:spPr>
           <a:xfrm>
-            <a:off x="3410712" y="4361688"/>
+            <a:off x="3410712" y="4581144"/>
             <a:ext cx="91440" cy="91440"/>
           </a:xfrm>
           <a:prstGeom prst="ellipse">
@@ -23445,7 +23445,7 @@
         </p:nvSpPr>
         <p:spPr>
           <a:xfrm>
-            <a:off x="3611880" y="4224528"/>
+            <a:off x="3611880" y="4443984"/>
             <a:ext cx="8348472" cy="365760"/>
           </a:xfrm>
           <a:prstGeom prst="rect">
@@ -23486,7 +23486,7 @@
         </p:nvSpPr>
         <p:spPr>
           <a:xfrm>
-            <a:off x="3410712" y="4727448"/>
+            <a:off x="3410712" y="4946904"/>
             <a:ext cx="91440" cy="91440"/>
           </a:xfrm>
           <a:prstGeom prst="ellipse">
@@ -23513,7 +23513,7 @@
         </p:nvSpPr>
         <p:spPr>
           <a:xfrm>
-            <a:off x="3611880" y="4590288"/>
+            <a:off x="3611880" y="4809744"/>
             <a:ext cx="8348472" cy="365760"/>
           </a:xfrm>
           <a:prstGeom prst="rect">
@@ -23554,7 +23554,7 @@
         </p:nvSpPr>
         <p:spPr>
           <a:xfrm>
-            <a:off x="3410712" y="4983480"/>
+            <a:off x="3410712" y="5047488"/>
             <a:ext cx="1188720" cy="256032"/>
           </a:xfrm>
           <a:prstGeom prst="rect">
@@ -23595,8 +23595,8 @@
         </p:nvSpPr>
         <p:spPr>
           <a:xfrm>
-            <a:off x="3410712" y="5184648"/>
-            <a:ext cx="8549640" cy="502920"/>
+            <a:off x="3410712" y="5248656"/>
+            <a:ext cx="8549640" cy="411480"/>
           </a:xfrm>
           <a:prstGeom prst="rect">
             <a:avLst/>
@@ -23636,7 +23636,7 @@
         </p:nvSpPr>
         <p:spPr>
           <a:xfrm>
-            <a:off x="3410712" y="5559552"/>
+            <a:off x="3410712" y="5486400"/>
             <a:ext cx="8549640" cy="219456"/>
           </a:xfrm>
           <a:prstGeom prst="rect">
@@ -23677,8 +23677,8 @@
         </p:nvSpPr>
         <p:spPr>
           <a:xfrm>
-            <a:off x="3410712" y="5742432"/>
-            <a:ext cx="8549640" cy="896112"/>
+            <a:off x="3410712" y="5669280"/>
+            <a:ext cx="8549640" cy="749808"/>
           </a:xfrm>
           <a:prstGeom prst="rect">
             <a:avLst/>
@@ -24189,7 +24189,7 @@
         </p:nvSpPr>
         <p:spPr>
           <a:xfrm>
-            <a:off x="3410712" y="3630168"/>
+            <a:off x="3410712" y="3849624"/>
             <a:ext cx="91440" cy="91440"/>
           </a:xfrm>
           <a:prstGeom prst="ellipse">
@@ -24216,7 +24216,7 @@
         </p:nvSpPr>
         <p:spPr>
           <a:xfrm>
-            <a:off x="3611880" y="3493008"/>
+            <a:off x="3611880" y="3712464"/>
             <a:ext cx="8348472" cy="365760"/>
           </a:xfrm>
           <a:prstGeom prst="rect">
@@ -24257,7 +24257,7 @@
         </p:nvSpPr>
         <p:spPr>
           <a:xfrm>
-            <a:off x="3410712" y="3995928"/>
+            <a:off x="3410712" y="4215384"/>
             <a:ext cx="91440" cy="91440"/>
           </a:xfrm>
           <a:prstGeom prst="ellipse">
@@ -24284,7 +24284,7 @@
         </p:nvSpPr>
         <p:spPr>
           <a:xfrm>
-            <a:off x="3611880" y="3858768"/>
+            <a:off x="3611880" y="4078224"/>
             <a:ext cx="8348472" cy="365760"/>
           </a:xfrm>
           <a:prstGeom prst="rect">
@@ -24325,7 +24325,7 @@
         </p:nvSpPr>
         <p:spPr>
           <a:xfrm>
-            <a:off x="3410712" y="4361688"/>
+            <a:off x="3410712" y="4581144"/>
             <a:ext cx="91440" cy="91440"/>
           </a:xfrm>
           <a:prstGeom prst="ellipse">
@@ -24352,7 +24352,7 @@
         </p:nvSpPr>
         <p:spPr>
           <a:xfrm>
-            <a:off x="3611880" y="4224528"/>
+            <a:off x="3611880" y="4443984"/>
             <a:ext cx="8348472" cy="365760"/>
           </a:xfrm>
           <a:prstGeom prst="rect">
@@ -24393,7 +24393,7 @@
         </p:nvSpPr>
         <p:spPr>
           <a:xfrm>
-            <a:off x="3410712" y="4727448"/>
+            <a:off x="3410712" y="4946904"/>
             <a:ext cx="91440" cy="91440"/>
           </a:xfrm>
           <a:prstGeom prst="ellipse">
@@ -24420,7 +24420,7 @@
         </p:nvSpPr>
         <p:spPr>
           <a:xfrm>
-            <a:off x="3611880" y="4590288"/>
+            <a:off x="3611880" y="4809744"/>
             <a:ext cx="8348472" cy="365760"/>
           </a:xfrm>
           <a:prstGeom prst="rect">
@@ -24461,7 +24461,7 @@
         </p:nvSpPr>
         <p:spPr>
           <a:xfrm>
-            <a:off x="3410712" y="4983480"/>
+            <a:off x="3410712" y="5047488"/>
             <a:ext cx="1188720" cy="256032"/>
           </a:xfrm>
           <a:prstGeom prst="rect">
@@ -24502,8 +24502,8 @@
         </p:nvSpPr>
         <p:spPr>
           <a:xfrm>
-            <a:off x="3410712" y="5184648"/>
-            <a:ext cx="8549640" cy="502920"/>
+            <a:off x="3410712" y="5248656"/>
+            <a:ext cx="8549640" cy="411480"/>
           </a:xfrm>
           <a:prstGeom prst="rect">
             <a:avLst/>
@@ -24543,7 +24543,7 @@
         </p:nvSpPr>
         <p:spPr>
           <a:xfrm>
-            <a:off x="3410712" y="5559552"/>
+            <a:off x="3410712" y="5486400"/>
             <a:ext cx="8549640" cy="219456"/>
           </a:xfrm>
           <a:prstGeom prst="rect">
@@ -24584,8 +24584,8 @@
         </p:nvSpPr>
         <p:spPr>
           <a:xfrm>
-            <a:off x="3410712" y="5742432"/>
-            <a:ext cx="8549640" cy="896112"/>
+            <a:off x="3410712" y="5669280"/>
+            <a:ext cx="8549640" cy="749808"/>
           </a:xfrm>
           <a:prstGeom prst="rect">
             <a:avLst/>

</xml_diff>

<commit_message>
chore(slides): adjust section spacing and subtitle-body rhythm
</commit_message>
<xml_diff>
--- a/피우다프로젝트/application_assets/mobile_scene_capture_all_language/app_screen_slides_source/output/app_screen_slides.pptx
+++ b/피우다프로젝트/application_assets/mobile_scene_capture_all_language/app_screen_slides_source/output/app_screen_slides.pptx
@@ -3328,7 +3328,7 @@
         </p:nvSpPr>
         <p:spPr>
           <a:xfrm>
-            <a:off x="3410712" y="3849624"/>
+            <a:off x="3410712" y="3872484"/>
             <a:ext cx="91440" cy="91440"/>
           </a:xfrm>
           <a:prstGeom prst="ellipse">
@@ -3355,8 +3355,8 @@
         </p:nvSpPr>
         <p:spPr>
           <a:xfrm>
-            <a:off x="3611880" y="3712464"/>
-            <a:ext cx="8348472" cy="365760"/>
+            <a:off x="3611880" y="3767328"/>
+            <a:ext cx="8348472" cy="301752"/>
           </a:xfrm>
           <a:prstGeom prst="rect">
             <a:avLst/>
@@ -3396,7 +3396,7 @@
         </p:nvSpPr>
         <p:spPr>
           <a:xfrm>
-            <a:off x="3410712" y="4215384"/>
+            <a:off x="3410712" y="4174236"/>
             <a:ext cx="91440" cy="91440"/>
           </a:xfrm>
           <a:prstGeom prst="ellipse">
@@ -3423,8 +3423,8 @@
         </p:nvSpPr>
         <p:spPr>
           <a:xfrm>
-            <a:off x="3611880" y="4078224"/>
-            <a:ext cx="8348472" cy="365760"/>
+            <a:off x="3611880" y="4069080"/>
+            <a:ext cx="8348472" cy="301752"/>
           </a:xfrm>
           <a:prstGeom prst="rect">
             <a:avLst/>
@@ -3464,7 +3464,7 @@
         </p:nvSpPr>
         <p:spPr>
           <a:xfrm>
-            <a:off x="3410712" y="4581144"/>
+            <a:off x="3410712" y="4475988"/>
             <a:ext cx="91440" cy="91440"/>
           </a:xfrm>
           <a:prstGeom prst="ellipse">
@@ -3491,8 +3491,8 @@
         </p:nvSpPr>
         <p:spPr>
           <a:xfrm>
-            <a:off x="3611880" y="4443984"/>
-            <a:ext cx="8348472" cy="365760"/>
+            <a:off x="3611880" y="4370832"/>
+            <a:ext cx="8348472" cy="301752"/>
           </a:xfrm>
           <a:prstGeom prst="rect">
             <a:avLst/>
@@ -3532,7 +3532,7 @@
         </p:nvSpPr>
         <p:spPr>
           <a:xfrm>
-            <a:off x="3410712" y="4946904"/>
+            <a:off x="3410712" y="4777740"/>
             <a:ext cx="91440" cy="91440"/>
           </a:xfrm>
           <a:prstGeom prst="ellipse">
@@ -3559,8 +3559,8 @@
         </p:nvSpPr>
         <p:spPr>
           <a:xfrm>
-            <a:off x="3611880" y="4809744"/>
-            <a:ext cx="8348472" cy="365760"/>
+            <a:off x="3611880" y="4672584"/>
+            <a:ext cx="8348472" cy="301752"/>
           </a:xfrm>
           <a:prstGeom prst="rect">
             <a:avLst/>
@@ -3600,7 +3600,7 @@
         </p:nvSpPr>
         <p:spPr>
           <a:xfrm>
-            <a:off x="3410712" y="5047488"/>
+            <a:off x="3410712" y="5120640"/>
             <a:ext cx="1188720" cy="256032"/>
           </a:xfrm>
           <a:prstGeom prst="rect">
@@ -3619,7 +3619,7 @@
               <a:buNone/>
             </a:pPr>
             <a:r>
-              <a:rPr lang="en-US" sz="1200" b="1" dirty="0">
+              <a:rPr lang="en-US" sz="1300" b="1" dirty="0">
                 <a:solidFill>
                   <a:srgbClr val="222222"/>
                 </a:solidFill>
@@ -3629,7 +3629,7 @@
               </a:rPr>
               <a:t>디자인 포인트</a:t>
             </a:r>
-            <a:endParaRPr lang="en-US" sz="1200" dirty="0"/>
+            <a:endParaRPr lang="en-US" sz="1300" dirty="0"/>
           </a:p>
         </p:txBody>
       </p:sp>
@@ -3641,8 +3641,8 @@
         </p:nvSpPr>
         <p:spPr>
           <a:xfrm>
-            <a:off x="3410712" y="5248656"/>
-            <a:ext cx="8549640" cy="411480"/>
+            <a:off x="3410712" y="5468112"/>
+            <a:ext cx="8549640" cy="484632"/>
           </a:xfrm>
           <a:prstGeom prst="rect">
             <a:avLst/>
@@ -3682,7 +3682,7 @@
         </p:nvSpPr>
         <p:spPr>
           <a:xfrm>
-            <a:off x="3410712" y="5486400"/>
+            <a:off x="3410712" y="6099048"/>
             <a:ext cx="8549640" cy="219456"/>
           </a:xfrm>
           <a:prstGeom prst="rect">
@@ -3701,7 +3701,7 @@
               <a:buNone/>
             </a:pPr>
             <a:r>
-              <a:rPr lang="en-US" sz="1050" b="1" dirty="0">
+              <a:rPr lang="en-US" sz="1300" b="1" dirty="0">
                 <a:solidFill>
                   <a:srgbClr val="222222"/>
                 </a:solidFill>
@@ -3711,7 +3711,7 @@
               </a:rPr>
               <a:t>의학·인지과학 근거</a:t>
             </a:r>
-            <a:endParaRPr lang="en-US" sz="1050" dirty="0"/>
+            <a:endParaRPr lang="en-US" sz="1300" dirty="0"/>
           </a:p>
         </p:txBody>
       </p:sp>
@@ -3723,8 +3723,8 @@
         </p:nvSpPr>
         <p:spPr>
           <a:xfrm>
-            <a:off x="3410712" y="5669280"/>
-            <a:ext cx="8549640" cy="749808"/>
+            <a:off x="3410712" y="6446520"/>
+            <a:ext cx="8549640" cy="457200"/>
           </a:xfrm>
           <a:prstGeom prst="rect">
             <a:avLst/>
@@ -3742,7 +3742,7 @@
               <a:buNone/>
             </a:pPr>
             <a:r>
-              <a:rPr lang="en-US" sz="940" dirty="0">
+              <a:rPr lang="en-US" sz="1020" dirty="0">
                 <a:solidFill>
                   <a:srgbClr val="6A6A6A"/>
                 </a:solidFill>
@@ -3752,7 +3752,7 @@
               </a:rPr>
               <a:t>근거축: 고령자 초기 진입 부담을 낮추기 위해 승인 동작 중심으로 과제를 시작하는 방식은 SAGE(Scharre et al., 2010/2021)의 자기관리형 다영역 루틴 운영에서 영감을 받았습니다.</a:t>
             </a:r>
-            <a:endParaRPr lang="en-US" sz="940" dirty="0"/>
+            <a:endParaRPr lang="en-US" sz="1020" dirty="0"/>
           </a:p>
         </p:txBody>
       </p:sp>
@@ -4235,7 +4235,7 @@
         </p:nvSpPr>
         <p:spPr>
           <a:xfrm>
-            <a:off x="3410712" y="3849624"/>
+            <a:off x="3410712" y="3872484"/>
             <a:ext cx="91440" cy="91440"/>
           </a:xfrm>
           <a:prstGeom prst="ellipse">
@@ -4262,8 +4262,8 @@
         </p:nvSpPr>
         <p:spPr>
           <a:xfrm>
-            <a:off x="3611880" y="3712464"/>
-            <a:ext cx="8348472" cy="365760"/>
+            <a:off x="3611880" y="3767328"/>
+            <a:ext cx="8348472" cy="301752"/>
           </a:xfrm>
           <a:prstGeom prst="rect">
             <a:avLst/>
@@ -4303,7 +4303,7 @@
         </p:nvSpPr>
         <p:spPr>
           <a:xfrm>
-            <a:off x="3410712" y="4215384"/>
+            <a:off x="3410712" y="4174236"/>
             <a:ext cx="91440" cy="91440"/>
           </a:xfrm>
           <a:prstGeom prst="ellipse">
@@ -4330,8 +4330,8 @@
         </p:nvSpPr>
         <p:spPr>
           <a:xfrm>
-            <a:off x="3611880" y="4078224"/>
-            <a:ext cx="8348472" cy="365760"/>
+            <a:off x="3611880" y="4069080"/>
+            <a:ext cx="8348472" cy="301752"/>
           </a:xfrm>
           <a:prstGeom prst="rect">
             <a:avLst/>
@@ -4371,7 +4371,7 @@
         </p:nvSpPr>
         <p:spPr>
           <a:xfrm>
-            <a:off x="3410712" y="4581144"/>
+            <a:off x="3410712" y="4475988"/>
             <a:ext cx="91440" cy="91440"/>
           </a:xfrm>
           <a:prstGeom prst="ellipse">
@@ -4398,8 +4398,8 @@
         </p:nvSpPr>
         <p:spPr>
           <a:xfrm>
-            <a:off x="3611880" y="4443984"/>
-            <a:ext cx="8348472" cy="365760"/>
+            <a:off x="3611880" y="4370832"/>
+            <a:ext cx="8348472" cy="301752"/>
           </a:xfrm>
           <a:prstGeom prst="rect">
             <a:avLst/>
@@ -4439,7 +4439,7 @@
         </p:nvSpPr>
         <p:spPr>
           <a:xfrm>
-            <a:off x="3410712" y="4946904"/>
+            <a:off x="3410712" y="4777740"/>
             <a:ext cx="91440" cy="91440"/>
           </a:xfrm>
           <a:prstGeom prst="ellipse">
@@ -4466,8 +4466,8 @@
         </p:nvSpPr>
         <p:spPr>
           <a:xfrm>
-            <a:off x="3611880" y="4809744"/>
-            <a:ext cx="8348472" cy="365760"/>
+            <a:off x="3611880" y="4672584"/>
+            <a:ext cx="8348472" cy="301752"/>
           </a:xfrm>
           <a:prstGeom prst="rect">
             <a:avLst/>
@@ -4507,7 +4507,7 @@
         </p:nvSpPr>
         <p:spPr>
           <a:xfrm>
-            <a:off x="3410712" y="5047488"/>
+            <a:off x="3410712" y="5120640"/>
             <a:ext cx="1188720" cy="256032"/>
           </a:xfrm>
           <a:prstGeom prst="rect">
@@ -4526,7 +4526,7 @@
               <a:buNone/>
             </a:pPr>
             <a:r>
-              <a:rPr lang="en-US" sz="1200" b="1" dirty="0">
+              <a:rPr lang="en-US" sz="1300" b="1" dirty="0">
                 <a:solidFill>
                   <a:srgbClr val="222222"/>
                 </a:solidFill>
@@ -4536,7 +4536,7 @@
               </a:rPr>
               <a:t>디자인 포인트</a:t>
             </a:r>
-            <a:endParaRPr lang="en-US" sz="1200" dirty="0"/>
+            <a:endParaRPr lang="en-US" sz="1300" dirty="0"/>
           </a:p>
         </p:txBody>
       </p:sp>
@@ -4548,8 +4548,8 @@
         </p:nvSpPr>
         <p:spPr>
           <a:xfrm>
-            <a:off x="3410712" y="5248656"/>
-            <a:ext cx="8549640" cy="411480"/>
+            <a:off x="3410712" y="5468112"/>
+            <a:ext cx="8549640" cy="484632"/>
           </a:xfrm>
           <a:prstGeom prst="rect">
             <a:avLst/>
@@ -4589,7 +4589,7 @@
         </p:nvSpPr>
         <p:spPr>
           <a:xfrm>
-            <a:off x="3410712" y="5486400"/>
+            <a:off x="3410712" y="6099048"/>
             <a:ext cx="8549640" cy="219456"/>
           </a:xfrm>
           <a:prstGeom prst="rect">
@@ -4608,7 +4608,7 @@
               <a:buNone/>
             </a:pPr>
             <a:r>
-              <a:rPr lang="en-US" sz="1050" b="1" dirty="0">
+              <a:rPr lang="en-US" sz="1300" b="1" dirty="0">
                 <a:solidFill>
                   <a:srgbClr val="222222"/>
                 </a:solidFill>
@@ -4618,7 +4618,7 @@
               </a:rPr>
               <a:t>의학·인지과학 근거</a:t>
             </a:r>
-            <a:endParaRPr lang="en-US" sz="1050" dirty="0"/>
+            <a:endParaRPr lang="en-US" sz="1300" dirty="0"/>
           </a:p>
         </p:txBody>
       </p:sp>
@@ -4630,8 +4630,8 @@
         </p:nvSpPr>
         <p:spPr>
           <a:xfrm>
-            <a:off x="3410712" y="5669280"/>
-            <a:ext cx="8549640" cy="749808"/>
+            <a:off x="3410712" y="6446520"/>
+            <a:ext cx="8549640" cy="457200"/>
           </a:xfrm>
           <a:prstGeom prst="rect">
             <a:avLst/>
@@ -4649,7 +4649,7 @@
               <a:buNone/>
             </a:pPr>
             <a:r>
-              <a:rPr lang="en-US" sz="940" dirty="0">
+              <a:rPr lang="en-US" sz="1020" dirty="0">
                 <a:solidFill>
                   <a:srgbClr val="6A6A6A"/>
                 </a:solidFill>
@@ -4659,7 +4659,7 @@
               </a:rPr>
               <a:t>근거축: 규칙 전환 기반 선택 과제는 TMT 계열의 집행기능 요구를 TMT-lite 난이도로 가벼운 형태로 재구성했습니다.</a:t>
             </a:r>
-            <a:endParaRPr lang="en-US" sz="940" dirty="0"/>
+            <a:endParaRPr lang="en-US" sz="1020" dirty="0"/>
           </a:p>
         </p:txBody>
       </p:sp>
@@ -5142,7 +5142,7 @@
         </p:nvSpPr>
         <p:spPr>
           <a:xfrm>
-            <a:off x="3410712" y="3849624"/>
+            <a:off x="3410712" y="3872484"/>
             <a:ext cx="91440" cy="91440"/>
           </a:xfrm>
           <a:prstGeom prst="ellipse">
@@ -5169,8 +5169,8 @@
         </p:nvSpPr>
         <p:spPr>
           <a:xfrm>
-            <a:off x="3611880" y="3712464"/>
-            <a:ext cx="8348472" cy="365760"/>
+            <a:off x="3611880" y="3767328"/>
+            <a:ext cx="8348472" cy="301752"/>
           </a:xfrm>
           <a:prstGeom prst="rect">
             <a:avLst/>
@@ -5210,7 +5210,7 @@
         </p:nvSpPr>
         <p:spPr>
           <a:xfrm>
-            <a:off x="3410712" y="4215384"/>
+            <a:off x="3410712" y="4174236"/>
             <a:ext cx="91440" cy="91440"/>
           </a:xfrm>
           <a:prstGeom prst="ellipse">
@@ -5237,8 +5237,8 @@
         </p:nvSpPr>
         <p:spPr>
           <a:xfrm>
-            <a:off x="3611880" y="4078224"/>
-            <a:ext cx="8348472" cy="365760"/>
+            <a:off x="3611880" y="4069080"/>
+            <a:ext cx="8348472" cy="301752"/>
           </a:xfrm>
           <a:prstGeom prst="rect">
             <a:avLst/>
@@ -5278,7 +5278,7 @@
         </p:nvSpPr>
         <p:spPr>
           <a:xfrm>
-            <a:off x="3410712" y="4581144"/>
+            <a:off x="3410712" y="4475988"/>
             <a:ext cx="91440" cy="91440"/>
           </a:xfrm>
           <a:prstGeom prst="ellipse">
@@ -5305,8 +5305,8 @@
         </p:nvSpPr>
         <p:spPr>
           <a:xfrm>
-            <a:off x="3611880" y="4443984"/>
-            <a:ext cx="8348472" cy="365760"/>
+            <a:off x="3611880" y="4370832"/>
+            <a:ext cx="8348472" cy="301752"/>
           </a:xfrm>
           <a:prstGeom prst="rect">
             <a:avLst/>
@@ -5346,7 +5346,7 @@
         </p:nvSpPr>
         <p:spPr>
           <a:xfrm>
-            <a:off x="3410712" y="4946904"/>
+            <a:off x="3410712" y="4777740"/>
             <a:ext cx="91440" cy="91440"/>
           </a:xfrm>
           <a:prstGeom prst="ellipse">
@@ -5373,8 +5373,8 @@
         </p:nvSpPr>
         <p:spPr>
           <a:xfrm>
-            <a:off x="3611880" y="4809744"/>
-            <a:ext cx="8348472" cy="365760"/>
+            <a:off x="3611880" y="4672584"/>
+            <a:ext cx="8348472" cy="301752"/>
           </a:xfrm>
           <a:prstGeom prst="rect">
             <a:avLst/>
@@ -5414,7 +5414,7 @@
         </p:nvSpPr>
         <p:spPr>
           <a:xfrm>
-            <a:off x="3410712" y="5047488"/>
+            <a:off x="3410712" y="5120640"/>
             <a:ext cx="1188720" cy="256032"/>
           </a:xfrm>
           <a:prstGeom prst="rect">
@@ -5433,7 +5433,7 @@
               <a:buNone/>
             </a:pPr>
             <a:r>
-              <a:rPr lang="en-US" sz="1200" b="1" dirty="0">
+              <a:rPr lang="en-US" sz="1300" b="1" dirty="0">
                 <a:solidFill>
                   <a:srgbClr val="222222"/>
                 </a:solidFill>
@@ -5443,7 +5443,7 @@
               </a:rPr>
               <a:t>디자인 포인트</a:t>
             </a:r>
-            <a:endParaRPr lang="en-US" sz="1200" dirty="0"/>
+            <a:endParaRPr lang="en-US" sz="1300" dirty="0"/>
           </a:p>
         </p:txBody>
       </p:sp>
@@ -5455,8 +5455,8 @@
         </p:nvSpPr>
         <p:spPr>
           <a:xfrm>
-            <a:off x="3410712" y="5248656"/>
-            <a:ext cx="8549640" cy="411480"/>
+            <a:off x="3410712" y="5468112"/>
+            <a:ext cx="8549640" cy="484632"/>
           </a:xfrm>
           <a:prstGeom prst="rect">
             <a:avLst/>
@@ -5496,7 +5496,7 @@
         </p:nvSpPr>
         <p:spPr>
           <a:xfrm>
-            <a:off x="3410712" y="5486400"/>
+            <a:off x="3410712" y="6099048"/>
             <a:ext cx="8549640" cy="219456"/>
           </a:xfrm>
           <a:prstGeom prst="rect">
@@ -5515,7 +5515,7 @@
               <a:buNone/>
             </a:pPr>
             <a:r>
-              <a:rPr lang="en-US" sz="1050" b="1" dirty="0">
+              <a:rPr lang="en-US" sz="1300" b="1" dirty="0">
                 <a:solidFill>
                   <a:srgbClr val="222222"/>
                 </a:solidFill>
@@ -5525,7 +5525,7 @@
               </a:rPr>
               <a:t>의학·인지과학 근거</a:t>
             </a:r>
-            <a:endParaRPr lang="en-US" sz="1050" dirty="0"/>
+            <a:endParaRPr lang="en-US" sz="1300" dirty="0"/>
           </a:p>
         </p:txBody>
       </p:sp>
@@ -5537,8 +5537,8 @@
         </p:nvSpPr>
         <p:spPr>
           <a:xfrm>
-            <a:off x="3410712" y="5669280"/>
-            <a:ext cx="8549640" cy="749808"/>
+            <a:off x="3410712" y="6446520"/>
+            <a:ext cx="8549640" cy="457200"/>
           </a:xfrm>
           <a:prstGeom prst="rect">
             <a:avLst/>
@@ -5556,7 +5556,7 @@
               <a:buNone/>
             </a:pPr>
             <a:r>
-              <a:rPr lang="en-US" sz="940" dirty="0">
+              <a:rPr lang="en-US" sz="1020" dirty="0">
                 <a:solidFill>
                   <a:srgbClr val="6A6A6A"/>
                 </a:solidFill>
@@ -5566,7 +5566,7 @@
               </a:rPr>
               <a:t>근거축: 연상·연결 과제는 연계 기억 자극을 반복 노출하고 일상 전환 추적을 위한 간접 신호를 모으는 방식으로 설계했습니다.</a:t>
             </a:r>
-            <a:endParaRPr lang="en-US" sz="940" dirty="0"/>
+            <a:endParaRPr lang="en-US" sz="1020" dirty="0"/>
           </a:p>
         </p:txBody>
       </p:sp>
@@ -6049,7 +6049,7 @@
         </p:nvSpPr>
         <p:spPr>
           <a:xfrm>
-            <a:off x="3410712" y="3849624"/>
+            <a:off x="3410712" y="3872484"/>
             <a:ext cx="91440" cy="91440"/>
           </a:xfrm>
           <a:prstGeom prst="ellipse">
@@ -6076,8 +6076,8 @@
         </p:nvSpPr>
         <p:spPr>
           <a:xfrm>
-            <a:off x="3611880" y="3712464"/>
-            <a:ext cx="8348472" cy="365760"/>
+            <a:off x="3611880" y="3767328"/>
+            <a:ext cx="8348472" cy="301752"/>
           </a:xfrm>
           <a:prstGeom prst="rect">
             <a:avLst/>
@@ -6117,7 +6117,7 @@
         </p:nvSpPr>
         <p:spPr>
           <a:xfrm>
-            <a:off x="3410712" y="4215384"/>
+            <a:off x="3410712" y="4174236"/>
             <a:ext cx="91440" cy="91440"/>
           </a:xfrm>
           <a:prstGeom prst="ellipse">
@@ -6144,8 +6144,8 @@
         </p:nvSpPr>
         <p:spPr>
           <a:xfrm>
-            <a:off x="3611880" y="4078224"/>
-            <a:ext cx="8348472" cy="365760"/>
+            <a:off x="3611880" y="4069080"/>
+            <a:ext cx="8348472" cy="301752"/>
           </a:xfrm>
           <a:prstGeom prst="rect">
             <a:avLst/>
@@ -6185,7 +6185,7 @@
         </p:nvSpPr>
         <p:spPr>
           <a:xfrm>
-            <a:off x="3410712" y="4581144"/>
+            <a:off x="3410712" y="4475988"/>
             <a:ext cx="91440" cy="91440"/>
           </a:xfrm>
           <a:prstGeom prst="ellipse">
@@ -6212,8 +6212,8 @@
         </p:nvSpPr>
         <p:spPr>
           <a:xfrm>
-            <a:off x="3611880" y="4443984"/>
-            <a:ext cx="8348472" cy="365760"/>
+            <a:off x="3611880" y="4370832"/>
+            <a:ext cx="8348472" cy="301752"/>
           </a:xfrm>
           <a:prstGeom prst="rect">
             <a:avLst/>
@@ -6253,7 +6253,7 @@
         </p:nvSpPr>
         <p:spPr>
           <a:xfrm>
-            <a:off x="3410712" y="4946904"/>
+            <a:off x="3410712" y="4777740"/>
             <a:ext cx="91440" cy="91440"/>
           </a:xfrm>
           <a:prstGeom prst="ellipse">
@@ -6280,8 +6280,8 @@
         </p:nvSpPr>
         <p:spPr>
           <a:xfrm>
-            <a:off x="3611880" y="4809744"/>
-            <a:ext cx="8348472" cy="365760"/>
+            <a:off x="3611880" y="4672584"/>
+            <a:ext cx="8348472" cy="301752"/>
           </a:xfrm>
           <a:prstGeom prst="rect">
             <a:avLst/>
@@ -6321,7 +6321,7 @@
         </p:nvSpPr>
         <p:spPr>
           <a:xfrm>
-            <a:off x="3410712" y="5047488"/>
+            <a:off x="3410712" y="5120640"/>
             <a:ext cx="1188720" cy="256032"/>
           </a:xfrm>
           <a:prstGeom prst="rect">
@@ -6340,7 +6340,7 @@
               <a:buNone/>
             </a:pPr>
             <a:r>
-              <a:rPr lang="en-US" sz="1200" b="1" dirty="0">
+              <a:rPr lang="en-US" sz="1300" b="1" dirty="0">
                 <a:solidFill>
                   <a:srgbClr val="222222"/>
                 </a:solidFill>
@@ -6350,7 +6350,7 @@
               </a:rPr>
               <a:t>디자인 포인트</a:t>
             </a:r>
-            <a:endParaRPr lang="en-US" sz="1200" dirty="0"/>
+            <a:endParaRPr lang="en-US" sz="1300" dirty="0"/>
           </a:p>
         </p:txBody>
       </p:sp>
@@ -6362,8 +6362,8 @@
         </p:nvSpPr>
         <p:spPr>
           <a:xfrm>
-            <a:off x="3410712" y="5248656"/>
-            <a:ext cx="8549640" cy="411480"/>
+            <a:off x="3410712" y="5468112"/>
+            <a:ext cx="8549640" cy="484632"/>
           </a:xfrm>
           <a:prstGeom prst="rect">
             <a:avLst/>
@@ -6403,7 +6403,7 @@
         </p:nvSpPr>
         <p:spPr>
           <a:xfrm>
-            <a:off x="3410712" y="5486400"/>
+            <a:off x="3410712" y="6099048"/>
             <a:ext cx="8549640" cy="219456"/>
           </a:xfrm>
           <a:prstGeom prst="rect">
@@ -6422,7 +6422,7 @@
               <a:buNone/>
             </a:pPr>
             <a:r>
-              <a:rPr lang="en-US" sz="1050" b="1" dirty="0">
+              <a:rPr lang="en-US" sz="1300" b="1" dirty="0">
                 <a:solidFill>
                   <a:srgbClr val="222222"/>
                 </a:solidFill>
@@ -6432,7 +6432,7 @@
               </a:rPr>
               <a:t>의학·인지과학 근거</a:t>
             </a:r>
-            <a:endParaRPr lang="en-US" sz="1050" dirty="0"/>
+            <a:endParaRPr lang="en-US" sz="1300" dirty="0"/>
           </a:p>
         </p:txBody>
       </p:sp>
@@ -6444,8 +6444,8 @@
         </p:nvSpPr>
         <p:spPr>
           <a:xfrm>
-            <a:off x="3410712" y="5669280"/>
-            <a:ext cx="8549640" cy="749808"/>
+            <a:off x="3410712" y="6446520"/>
+            <a:ext cx="8549640" cy="457200"/>
           </a:xfrm>
           <a:prstGeom prst="rect">
             <a:avLst/>
@@ -6463,7 +6463,7 @@
               <a:buNone/>
             </a:pPr>
             <a:r>
-              <a:rPr lang="en-US" sz="940" dirty="0">
+              <a:rPr lang="en-US" sz="1020" dirty="0">
                 <a:solidFill>
                   <a:srgbClr val="6A6A6A"/>
                 </a:solidFill>
@@ -6473,7 +6473,7 @@
               </a:rPr>
               <a:t>근거축: 순서 정렬은 일상 수행을 지원하는 계획성·시퀀싱 연습으로, 정답보다 처리를 연속 추적합니다.</a:t>
             </a:r>
-            <a:endParaRPr lang="en-US" sz="940" dirty="0"/>
+            <a:endParaRPr lang="en-US" sz="1020" dirty="0"/>
           </a:p>
         </p:txBody>
       </p:sp>
@@ -6956,7 +6956,7 @@
         </p:nvSpPr>
         <p:spPr>
           <a:xfrm>
-            <a:off x="3410712" y="3849624"/>
+            <a:off x="3410712" y="3872484"/>
             <a:ext cx="91440" cy="91440"/>
           </a:xfrm>
           <a:prstGeom prst="ellipse">
@@ -6983,8 +6983,8 @@
         </p:nvSpPr>
         <p:spPr>
           <a:xfrm>
-            <a:off x="3611880" y="3712464"/>
-            <a:ext cx="8348472" cy="365760"/>
+            <a:off x="3611880" y="3767328"/>
+            <a:ext cx="8348472" cy="301752"/>
           </a:xfrm>
           <a:prstGeom prst="rect">
             <a:avLst/>
@@ -7024,7 +7024,7 @@
         </p:nvSpPr>
         <p:spPr>
           <a:xfrm>
-            <a:off x="3410712" y="4215384"/>
+            <a:off x="3410712" y="4174236"/>
             <a:ext cx="91440" cy="91440"/>
           </a:xfrm>
           <a:prstGeom prst="ellipse">
@@ -7051,8 +7051,8 @@
         </p:nvSpPr>
         <p:spPr>
           <a:xfrm>
-            <a:off x="3611880" y="4078224"/>
-            <a:ext cx="8348472" cy="365760"/>
+            <a:off x="3611880" y="4069080"/>
+            <a:ext cx="8348472" cy="301752"/>
           </a:xfrm>
           <a:prstGeom prst="rect">
             <a:avLst/>
@@ -7092,7 +7092,7 @@
         </p:nvSpPr>
         <p:spPr>
           <a:xfrm>
-            <a:off x="3410712" y="4581144"/>
+            <a:off x="3410712" y="4475988"/>
             <a:ext cx="91440" cy="91440"/>
           </a:xfrm>
           <a:prstGeom prst="ellipse">
@@ -7119,8 +7119,8 @@
         </p:nvSpPr>
         <p:spPr>
           <a:xfrm>
-            <a:off x="3611880" y="4443984"/>
-            <a:ext cx="8348472" cy="365760"/>
+            <a:off x="3611880" y="4370832"/>
+            <a:ext cx="8348472" cy="301752"/>
           </a:xfrm>
           <a:prstGeom prst="rect">
             <a:avLst/>
@@ -7160,7 +7160,7 @@
         </p:nvSpPr>
         <p:spPr>
           <a:xfrm>
-            <a:off x="3410712" y="4946904"/>
+            <a:off x="3410712" y="4777740"/>
             <a:ext cx="91440" cy="91440"/>
           </a:xfrm>
           <a:prstGeom prst="ellipse">
@@ -7187,8 +7187,8 @@
         </p:nvSpPr>
         <p:spPr>
           <a:xfrm>
-            <a:off x="3611880" y="4809744"/>
-            <a:ext cx="8348472" cy="365760"/>
+            <a:off x="3611880" y="4672584"/>
+            <a:ext cx="8348472" cy="301752"/>
           </a:xfrm>
           <a:prstGeom prst="rect">
             <a:avLst/>
@@ -7228,7 +7228,7 @@
         </p:nvSpPr>
         <p:spPr>
           <a:xfrm>
-            <a:off x="3410712" y="5047488"/>
+            <a:off x="3410712" y="5120640"/>
             <a:ext cx="1188720" cy="256032"/>
           </a:xfrm>
           <a:prstGeom prst="rect">
@@ -7247,7 +7247,7 @@
               <a:buNone/>
             </a:pPr>
             <a:r>
-              <a:rPr lang="en-US" sz="1200" b="1" dirty="0">
+              <a:rPr lang="en-US" sz="1300" b="1" dirty="0">
                 <a:solidFill>
                   <a:srgbClr val="222222"/>
                 </a:solidFill>
@@ -7257,7 +7257,7 @@
               </a:rPr>
               <a:t>디자인 포인트</a:t>
             </a:r>
-            <a:endParaRPr lang="en-US" sz="1200" dirty="0"/>
+            <a:endParaRPr lang="en-US" sz="1300" dirty="0"/>
           </a:p>
         </p:txBody>
       </p:sp>
@@ -7269,8 +7269,8 @@
         </p:nvSpPr>
         <p:spPr>
           <a:xfrm>
-            <a:off x="3410712" y="5248656"/>
-            <a:ext cx="8549640" cy="411480"/>
+            <a:off x="3410712" y="5468112"/>
+            <a:ext cx="8549640" cy="484632"/>
           </a:xfrm>
           <a:prstGeom prst="rect">
             <a:avLst/>
@@ -7310,7 +7310,7 @@
         </p:nvSpPr>
         <p:spPr>
           <a:xfrm>
-            <a:off x="3410712" y="5486400"/>
+            <a:off x="3410712" y="6099048"/>
             <a:ext cx="8549640" cy="219456"/>
           </a:xfrm>
           <a:prstGeom prst="rect">
@@ -7329,7 +7329,7 @@
               <a:buNone/>
             </a:pPr>
             <a:r>
-              <a:rPr lang="en-US" sz="1050" b="1" dirty="0">
+              <a:rPr lang="en-US" sz="1300" b="1" dirty="0">
                 <a:solidFill>
                   <a:srgbClr val="222222"/>
                 </a:solidFill>
@@ -7339,7 +7339,7 @@
               </a:rPr>
               <a:t>의학·인지과학 근거</a:t>
             </a:r>
-            <a:endParaRPr lang="en-US" sz="1050" dirty="0"/>
+            <a:endParaRPr lang="en-US" sz="1300" dirty="0"/>
           </a:p>
         </p:txBody>
       </p:sp>
@@ -7351,8 +7351,8 @@
         </p:nvSpPr>
         <p:spPr>
           <a:xfrm>
-            <a:off x="3410712" y="5669280"/>
-            <a:ext cx="8549640" cy="749808"/>
+            <a:off x="3410712" y="6446520"/>
+            <a:ext cx="8549640" cy="457200"/>
           </a:xfrm>
           <a:prstGeom prst="rect">
             <a:avLst/>
@@ -7370,7 +7370,7 @@
               <a:buNone/>
             </a:pPr>
             <a:r>
-              <a:rPr lang="en-US" sz="940" dirty="0">
+              <a:rPr lang="en-US" sz="1020" dirty="0">
                 <a:solidFill>
                   <a:srgbClr val="6A6A6A"/>
                 </a:solidFill>
@@ -7380,7 +7380,7 @@
               </a:rPr>
               <a:t>근거축: 청각 선택 과제는 멀티모달 전환을 통해 문해 의존도를 낮추고 반응 지속 패턴을 기록하는 보조 과제입니다.</a:t>
             </a:r>
-            <a:endParaRPr lang="en-US" sz="940" dirty="0"/>
+            <a:endParaRPr lang="en-US" sz="1020" dirty="0"/>
           </a:p>
         </p:txBody>
       </p:sp>
@@ -7863,7 +7863,7 @@
         </p:nvSpPr>
         <p:spPr>
           <a:xfrm>
-            <a:off x="3410712" y="3849624"/>
+            <a:off x="3410712" y="3872484"/>
             <a:ext cx="91440" cy="91440"/>
           </a:xfrm>
           <a:prstGeom prst="ellipse">
@@ -7890,8 +7890,8 @@
         </p:nvSpPr>
         <p:spPr>
           <a:xfrm>
-            <a:off x="3611880" y="3712464"/>
-            <a:ext cx="8348472" cy="365760"/>
+            <a:off x="3611880" y="3767328"/>
+            <a:ext cx="8348472" cy="301752"/>
           </a:xfrm>
           <a:prstGeom prst="rect">
             <a:avLst/>
@@ -7931,7 +7931,7 @@
         </p:nvSpPr>
         <p:spPr>
           <a:xfrm>
-            <a:off x="3410712" y="4215384"/>
+            <a:off x="3410712" y="4174236"/>
             <a:ext cx="91440" cy="91440"/>
           </a:xfrm>
           <a:prstGeom prst="ellipse">
@@ -7958,8 +7958,8 @@
         </p:nvSpPr>
         <p:spPr>
           <a:xfrm>
-            <a:off x="3611880" y="4078224"/>
-            <a:ext cx="8348472" cy="365760"/>
+            <a:off x="3611880" y="4069080"/>
+            <a:ext cx="8348472" cy="301752"/>
           </a:xfrm>
           <a:prstGeom prst="rect">
             <a:avLst/>
@@ -7999,7 +7999,7 @@
         </p:nvSpPr>
         <p:spPr>
           <a:xfrm>
-            <a:off x="3410712" y="4581144"/>
+            <a:off x="3410712" y="4475988"/>
             <a:ext cx="91440" cy="91440"/>
           </a:xfrm>
           <a:prstGeom prst="ellipse">
@@ -8026,8 +8026,8 @@
         </p:nvSpPr>
         <p:spPr>
           <a:xfrm>
-            <a:off x="3611880" y="4443984"/>
-            <a:ext cx="8348472" cy="365760"/>
+            <a:off x="3611880" y="4370832"/>
+            <a:ext cx="8348472" cy="301752"/>
           </a:xfrm>
           <a:prstGeom prst="rect">
             <a:avLst/>
@@ -8067,7 +8067,7 @@
         </p:nvSpPr>
         <p:spPr>
           <a:xfrm>
-            <a:off x="3410712" y="4946904"/>
+            <a:off x="3410712" y="4777740"/>
             <a:ext cx="91440" cy="91440"/>
           </a:xfrm>
           <a:prstGeom prst="ellipse">
@@ -8094,8 +8094,8 @@
         </p:nvSpPr>
         <p:spPr>
           <a:xfrm>
-            <a:off x="3611880" y="4809744"/>
-            <a:ext cx="8348472" cy="365760"/>
+            <a:off x="3611880" y="4672584"/>
+            <a:ext cx="8348472" cy="301752"/>
           </a:xfrm>
           <a:prstGeom prst="rect">
             <a:avLst/>
@@ -8135,7 +8135,7 @@
         </p:nvSpPr>
         <p:spPr>
           <a:xfrm>
-            <a:off x="3410712" y="5047488"/>
+            <a:off x="3410712" y="5120640"/>
             <a:ext cx="1188720" cy="256032"/>
           </a:xfrm>
           <a:prstGeom prst="rect">
@@ -8154,7 +8154,7 @@
               <a:buNone/>
             </a:pPr>
             <a:r>
-              <a:rPr lang="en-US" sz="1200" b="1" dirty="0">
+              <a:rPr lang="en-US" sz="1300" b="1" dirty="0">
                 <a:solidFill>
                   <a:srgbClr val="222222"/>
                 </a:solidFill>
@@ -8164,7 +8164,7 @@
               </a:rPr>
               <a:t>디자인 포인트</a:t>
             </a:r>
-            <a:endParaRPr lang="en-US" sz="1200" dirty="0"/>
+            <a:endParaRPr lang="en-US" sz="1300" dirty="0"/>
           </a:p>
         </p:txBody>
       </p:sp>
@@ -8176,8 +8176,8 @@
         </p:nvSpPr>
         <p:spPr>
           <a:xfrm>
-            <a:off x="3410712" y="5248656"/>
-            <a:ext cx="8549640" cy="411480"/>
+            <a:off x="3410712" y="5468112"/>
+            <a:ext cx="8549640" cy="484632"/>
           </a:xfrm>
           <a:prstGeom prst="rect">
             <a:avLst/>
@@ -8217,7 +8217,7 @@
         </p:nvSpPr>
         <p:spPr>
           <a:xfrm>
-            <a:off x="3410712" y="5486400"/>
+            <a:off x="3410712" y="6099048"/>
             <a:ext cx="8549640" cy="219456"/>
           </a:xfrm>
           <a:prstGeom prst="rect">
@@ -8236,7 +8236,7 @@
               <a:buNone/>
             </a:pPr>
             <a:r>
-              <a:rPr lang="en-US" sz="1050" b="1" dirty="0">
+              <a:rPr lang="en-US" sz="1300" b="1" dirty="0">
                 <a:solidFill>
                   <a:srgbClr val="222222"/>
                 </a:solidFill>
@@ -8246,7 +8246,7 @@
               </a:rPr>
               <a:t>의학·인지과학 근거</a:t>
             </a:r>
-            <a:endParaRPr lang="en-US" sz="1050" dirty="0"/>
+            <a:endParaRPr lang="en-US" sz="1300" dirty="0"/>
           </a:p>
         </p:txBody>
       </p:sp>
@@ -8258,8 +8258,8 @@
         </p:nvSpPr>
         <p:spPr>
           <a:xfrm>
-            <a:off x="3410712" y="5669280"/>
-            <a:ext cx="8549640" cy="749808"/>
+            <a:off x="3410712" y="6446520"/>
+            <a:ext cx="8549640" cy="457200"/>
           </a:xfrm>
           <a:prstGeom prst="rect">
             <a:avLst/>
@@ -8277,7 +8277,7 @@
               <a:buNone/>
             </a:pPr>
             <a:r>
-              <a:rPr lang="en-US" sz="940" dirty="0">
+              <a:rPr lang="en-US" sz="1020" dirty="0">
                 <a:solidFill>
                   <a:srgbClr val="6A6A6A"/>
                 </a:solidFill>
@@ -8287,7 +8287,7 @@
               </a:rPr>
               <a:t>근거축: 비언어 그림 선택은 시각 판단 경로로 진입장벽을 낮추고 접근성을 높이기 위한 보조 과제 설계입니다.</a:t>
             </a:r>
-            <a:endParaRPr lang="en-US" sz="940" dirty="0"/>
+            <a:endParaRPr lang="en-US" sz="1020" dirty="0"/>
           </a:p>
         </p:txBody>
       </p:sp>
@@ -8770,7 +8770,7 @@
         </p:nvSpPr>
         <p:spPr>
           <a:xfrm>
-            <a:off x="3410712" y="3849624"/>
+            <a:off x="3410712" y="3872484"/>
             <a:ext cx="91440" cy="91440"/>
           </a:xfrm>
           <a:prstGeom prst="ellipse">
@@ -8797,8 +8797,8 @@
         </p:nvSpPr>
         <p:spPr>
           <a:xfrm>
-            <a:off x="3611880" y="3712464"/>
-            <a:ext cx="8348472" cy="365760"/>
+            <a:off x="3611880" y="3767328"/>
+            <a:ext cx="8348472" cy="301752"/>
           </a:xfrm>
           <a:prstGeom prst="rect">
             <a:avLst/>
@@ -8838,7 +8838,7 @@
         </p:nvSpPr>
         <p:spPr>
           <a:xfrm>
-            <a:off x="3410712" y="4215384"/>
+            <a:off x="3410712" y="4174236"/>
             <a:ext cx="91440" cy="91440"/>
           </a:xfrm>
           <a:prstGeom prst="ellipse">
@@ -8865,8 +8865,8 @@
         </p:nvSpPr>
         <p:spPr>
           <a:xfrm>
-            <a:off x="3611880" y="4078224"/>
-            <a:ext cx="8348472" cy="365760"/>
+            <a:off x="3611880" y="4069080"/>
+            <a:ext cx="8348472" cy="301752"/>
           </a:xfrm>
           <a:prstGeom prst="rect">
             <a:avLst/>
@@ -8906,7 +8906,7 @@
         </p:nvSpPr>
         <p:spPr>
           <a:xfrm>
-            <a:off x="3410712" y="4581144"/>
+            <a:off x="3410712" y="4475988"/>
             <a:ext cx="91440" cy="91440"/>
           </a:xfrm>
           <a:prstGeom prst="ellipse">
@@ -8933,8 +8933,8 @@
         </p:nvSpPr>
         <p:spPr>
           <a:xfrm>
-            <a:off x="3611880" y="4443984"/>
-            <a:ext cx="8348472" cy="365760"/>
+            <a:off x="3611880" y="4370832"/>
+            <a:ext cx="8348472" cy="301752"/>
           </a:xfrm>
           <a:prstGeom prst="rect">
             <a:avLst/>
@@ -8974,7 +8974,7 @@
         </p:nvSpPr>
         <p:spPr>
           <a:xfrm>
-            <a:off x="3410712" y="4946904"/>
+            <a:off x="3410712" y="4777740"/>
             <a:ext cx="91440" cy="91440"/>
           </a:xfrm>
           <a:prstGeom prst="ellipse">
@@ -9001,8 +9001,8 @@
         </p:nvSpPr>
         <p:spPr>
           <a:xfrm>
-            <a:off x="3611880" y="4809744"/>
-            <a:ext cx="8348472" cy="365760"/>
+            <a:off x="3611880" y="4672584"/>
+            <a:ext cx="8348472" cy="301752"/>
           </a:xfrm>
           <a:prstGeom prst="rect">
             <a:avLst/>
@@ -9042,7 +9042,7 @@
         </p:nvSpPr>
         <p:spPr>
           <a:xfrm>
-            <a:off x="3410712" y="5047488"/>
+            <a:off x="3410712" y="5120640"/>
             <a:ext cx="1188720" cy="256032"/>
           </a:xfrm>
           <a:prstGeom prst="rect">
@@ -9061,7 +9061,7 @@
               <a:buNone/>
             </a:pPr>
             <a:r>
-              <a:rPr lang="en-US" sz="1200" b="1" dirty="0">
+              <a:rPr lang="en-US" sz="1300" b="1" dirty="0">
                 <a:solidFill>
                   <a:srgbClr val="222222"/>
                 </a:solidFill>
@@ -9071,7 +9071,7 @@
               </a:rPr>
               <a:t>디자인 포인트</a:t>
             </a:r>
-            <a:endParaRPr lang="en-US" sz="1200" dirty="0"/>
+            <a:endParaRPr lang="en-US" sz="1300" dirty="0"/>
           </a:p>
         </p:txBody>
       </p:sp>
@@ -9083,8 +9083,8 @@
         </p:nvSpPr>
         <p:spPr>
           <a:xfrm>
-            <a:off x="3410712" y="5248656"/>
-            <a:ext cx="8549640" cy="411480"/>
+            <a:off x="3410712" y="5468112"/>
+            <a:ext cx="8549640" cy="484632"/>
           </a:xfrm>
           <a:prstGeom prst="rect">
             <a:avLst/>
@@ -9124,7 +9124,7 @@
         </p:nvSpPr>
         <p:spPr>
           <a:xfrm>
-            <a:off x="3410712" y="5486400"/>
+            <a:off x="3410712" y="6099048"/>
             <a:ext cx="8549640" cy="219456"/>
           </a:xfrm>
           <a:prstGeom prst="rect">
@@ -9143,7 +9143,7 @@
               <a:buNone/>
             </a:pPr>
             <a:r>
-              <a:rPr lang="en-US" sz="1050" b="1" dirty="0">
+              <a:rPr lang="en-US" sz="1300" b="1" dirty="0">
                 <a:solidFill>
                   <a:srgbClr val="222222"/>
                 </a:solidFill>
@@ -9153,7 +9153,7 @@
               </a:rPr>
               <a:t>의학·인지과학 근거</a:t>
             </a:r>
-            <a:endParaRPr lang="en-US" sz="1050" dirty="0"/>
+            <a:endParaRPr lang="en-US" sz="1300" dirty="0"/>
           </a:p>
         </p:txBody>
       </p:sp>
@@ -9165,8 +9165,8 @@
         </p:nvSpPr>
         <p:spPr>
           <a:xfrm>
-            <a:off x="3410712" y="5669280"/>
-            <a:ext cx="8549640" cy="749808"/>
+            <a:off x="3410712" y="6446520"/>
+            <a:ext cx="8549640" cy="457200"/>
           </a:xfrm>
           <a:prstGeom prst="rect">
             <a:avLst/>
@@ -9184,7 +9184,7 @@
               <a:buNone/>
             </a:pPr>
             <a:r>
-              <a:rPr lang="en-US" sz="940" dirty="0">
+              <a:rPr lang="en-US" sz="1020" dirty="0">
                 <a:solidFill>
                   <a:srgbClr val="6A6A6A"/>
                 </a:solidFill>
@@ -9194,7 +9194,7 @@
               </a:rPr>
               <a:t>근거축: 도형 따라 그리기 과제는 dCDT류의 추적형 관측 원리를 반영해 점수화 대신 획수·정지 시간·경로를 정성 신호로 누적합니다.</a:t>
             </a:r>
-            <a:endParaRPr lang="en-US" sz="940" dirty="0"/>
+            <a:endParaRPr lang="en-US" sz="1020" dirty="0"/>
           </a:p>
         </p:txBody>
       </p:sp>
@@ -9677,7 +9677,7 @@
         </p:nvSpPr>
         <p:spPr>
           <a:xfrm>
-            <a:off x="3410712" y="3849624"/>
+            <a:off x="3410712" y="3872484"/>
             <a:ext cx="91440" cy="91440"/>
           </a:xfrm>
           <a:prstGeom prst="ellipse">
@@ -9704,8 +9704,8 @@
         </p:nvSpPr>
         <p:spPr>
           <a:xfrm>
-            <a:off x="3611880" y="3712464"/>
-            <a:ext cx="8348472" cy="365760"/>
+            <a:off x="3611880" y="3767328"/>
+            <a:ext cx="8348472" cy="301752"/>
           </a:xfrm>
           <a:prstGeom prst="rect">
             <a:avLst/>
@@ -9745,7 +9745,7 @@
         </p:nvSpPr>
         <p:spPr>
           <a:xfrm>
-            <a:off x="3410712" y="4215384"/>
+            <a:off x="3410712" y="4174236"/>
             <a:ext cx="91440" cy="91440"/>
           </a:xfrm>
           <a:prstGeom prst="ellipse">
@@ -9772,8 +9772,8 @@
         </p:nvSpPr>
         <p:spPr>
           <a:xfrm>
-            <a:off x="3611880" y="4078224"/>
-            <a:ext cx="8348472" cy="365760"/>
+            <a:off x="3611880" y="4069080"/>
+            <a:ext cx="8348472" cy="301752"/>
           </a:xfrm>
           <a:prstGeom prst="rect">
             <a:avLst/>
@@ -9813,7 +9813,7 @@
         </p:nvSpPr>
         <p:spPr>
           <a:xfrm>
-            <a:off x="3410712" y="4581144"/>
+            <a:off x="3410712" y="4475988"/>
             <a:ext cx="91440" cy="91440"/>
           </a:xfrm>
           <a:prstGeom prst="ellipse">
@@ -9840,8 +9840,8 @@
         </p:nvSpPr>
         <p:spPr>
           <a:xfrm>
-            <a:off x="3611880" y="4443984"/>
-            <a:ext cx="8348472" cy="365760"/>
+            <a:off x="3611880" y="4370832"/>
+            <a:ext cx="8348472" cy="301752"/>
           </a:xfrm>
           <a:prstGeom prst="rect">
             <a:avLst/>
@@ -9881,7 +9881,7 @@
         </p:nvSpPr>
         <p:spPr>
           <a:xfrm>
-            <a:off x="3410712" y="4946904"/>
+            <a:off x="3410712" y="4777740"/>
             <a:ext cx="91440" cy="91440"/>
           </a:xfrm>
           <a:prstGeom prst="ellipse">
@@ -9908,8 +9908,8 @@
         </p:nvSpPr>
         <p:spPr>
           <a:xfrm>
-            <a:off x="3611880" y="4809744"/>
-            <a:ext cx="8348472" cy="365760"/>
+            <a:off x="3611880" y="4672584"/>
+            <a:ext cx="8348472" cy="301752"/>
           </a:xfrm>
           <a:prstGeom prst="rect">
             <a:avLst/>
@@ -9949,7 +9949,7 @@
         </p:nvSpPr>
         <p:spPr>
           <a:xfrm>
-            <a:off x="3410712" y="5047488"/>
+            <a:off x="3410712" y="5120640"/>
             <a:ext cx="1188720" cy="256032"/>
           </a:xfrm>
           <a:prstGeom prst="rect">
@@ -9968,7 +9968,7 @@
               <a:buNone/>
             </a:pPr>
             <a:r>
-              <a:rPr lang="en-US" sz="1200" b="1" dirty="0">
+              <a:rPr lang="en-US" sz="1300" b="1" dirty="0">
                 <a:solidFill>
                   <a:srgbClr val="222222"/>
                 </a:solidFill>
@@ -9978,7 +9978,7 @@
               </a:rPr>
               <a:t>디자인 포인트</a:t>
             </a:r>
-            <a:endParaRPr lang="en-US" sz="1200" dirty="0"/>
+            <a:endParaRPr lang="en-US" sz="1300" dirty="0"/>
           </a:p>
         </p:txBody>
       </p:sp>
@@ -9990,8 +9990,8 @@
         </p:nvSpPr>
         <p:spPr>
           <a:xfrm>
-            <a:off x="3410712" y="5248656"/>
-            <a:ext cx="8549640" cy="411480"/>
+            <a:off x="3410712" y="5468112"/>
+            <a:ext cx="8549640" cy="484632"/>
           </a:xfrm>
           <a:prstGeom prst="rect">
             <a:avLst/>
@@ -10031,7 +10031,7 @@
         </p:nvSpPr>
         <p:spPr>
           <a:xfrm>
-            <a:off x="3410712" y="5486400"/>
+            <a:off x="3410712" y="6099048"/>
             <a:ext cx="8549640" cy="219456"/>
           </a:xfrm>
           <a:prstGeom prst="rect">
@@ -10050,7 +10050,7 @@
               <a:buNone/>
             </a:pPr>
             <a:r>
-              <a:rPr lang="en-US" sz="1050" b="1" dirty="0">
+              <a:rPr lang="en-US" sz="1300" b="1" dirty="0">
                 <a:solidFill>
                   <a:srgbClr val="222222"/>
                 </a:solidFill>
@@ -10060,7 +10060,7 @@
               </a:rPr>
               <a:t>의학·인지과학 근거</a:t>
             </a:r>
-            <a:endParaRPr lang="en-US" sz="1050" dirty="0"/>
+            <a:endParaRPr lang="en-US" sz="1300" dirty="0"/>
           </a:p>
         </p:txBody>
       </p:sp>
@@ -10072,8 +10072,8 @@
         </p:nvSpPr>
         <p:spPr>
           <a:xfrm>
-            <a:off x="3410712" y="5669280"/>
-            <a:ext cx="8549640" cy="749808"/>
+            <a:off x="3410712" y="6446520"/>
+            <a:ext cx="8549640" cy="457200"/>
           </a:xfrm>
           <a:prstGeom prst="rect">
             <a:avLst/>
@@ -10091,7 +10091,7 @@
               <a:buNone/>
             </a:pPr>
             <a:r>
-              <a:rPr lang="en-US" sz="940" dirty="0">
+              <a:rPr lang="en-US" sz="1020" dirty="0">
                 <a:solidFill>
                   <a:srgbClr val="6A6A6A"/>
                 </a:solidFill>
@@ -10101,7 +10101,7 @@
               </a:rPr>
               <a:t>근거축: 음성 반복은 발화 연습 중심의 완화형 루틴으로, 음성 인식 실패 시 텍스트 fallback를 함께 운용해 접근성을 보장합니다.</a:t>
             </a:r>
-            <a:endParaRPr lang="en-US" sz="940" dirty="0"/>
+            <a:endParaRPr lang="en-US" sz="1020" dirty="0"/>
           </a:p>
         </p:txBody>
       </p:sp>
@@ -10584,7 +10584,7 @@
         </p:nvSpPr>
         <p:spPr>
           <a:xfrm>
-            <a:off x="3410712" y="3849624"/>
+            <a:off x="3410712" y="3872484"/>
             <a:ext cx="91440" cy="91440"/>
           </a:xfrm>
           <a:prstGeom prst="ellipse">
@@ -10611,8 +10611,8 @@
         </p:nvSpPr>
         <p:spPr>
           <a:xfrm>
-            <a:off x="3611880" y="3712464"/>
-            <a:ext cx="8348472" cy="365760"/>
+            <a:off x="3611880" y="3767328"/>
+            <a:ext cx="8348472" cy="301752"/>
           </a:xfrm>
           <a:prstGeom prst="rect">
             <a:avLst/>
@@ -10652,7 +10652,7 @@
         </p:nvSpPr>
         <p:spPr>
           <a:xfrm>
-            <a:off x="3410712" y="4215384"/>
+            <a:off x="3410712" y="4174236"/>
             <a:ext cx="91440" cy="91440"/>
           </a:xfrm>
           <a:prstGeom prst="ellipse">
@@ -10679,8 +10679,8 @@
         </p:nvSpPr>
         <p:spPr>
           <a:xfrm>
-            <a:off x="3611880" y="4078224"/>
-            <a:ext cx="8348472" cy="365760"/>
+            <a:off x="3611880" y="4069080"/>
+            <a:ext cx="8348472" cy="301752"/>
           </a:xfrm>
           <a:prstGeom prst="rect">
             <a:avLst/>
@@ -10720,7 +10720,7 @@
         </p:nvSpPr>
         <p:spPr>
           <a:xfrm>
-            <a:off x="3410712" y="4581144"/>
+            <a:off x="3410712" y="4475988"/>
             <a:ext cx="91440" cy="91440"/>
           </a:xfrm>
           <a:prstGeom prst="ellipse">
@@ -10747,8 +10747,8 @@
         </p:nvSpPr>
         <p:spPr>
           <a:xfrm>
-            <a:off x="3611880" y="4443984"/>
-            <a:ext cx="8348472" cy="365760"/>
+            <a:off x="3611880" y="4370832"/>
+            <a:ext cx="8348472" cy="301752"/>
           </a:xfrm>
           <a:prstGeom prst="rect">
             <a:avLst/>
@@ -10788,7 +10788,7 @@
         </p:nvSpPr>
         <p:spPr>
           <a:xfrm>
-            <a:off x="3410712" y="4946904"/>
+            <a:off x="3410712" y="4777740"/>
             <a:ext cx="91440" cy="91440"/>
           </a:xfrm>
           <a:prstGeom prst="ellipse">
@@ -10815,8 +10815,8 @@
         </p:nvSpPr>
         <p:spPr>
           <a:xfrm>
-            <a:off x="3611880" y="4809744"/>
-            <a:ext cx="8348472" cy="365760"/>
+            <a:off x="3611880" y="4672584"/>
+            <a:ext cx="8348472" cy="301752"/>
           </a:xfrm>
           <a:prstGeom prst="rect">
             <a:avLst/>
@@ -10856,7 +10856,7 @@
         </p:nvSpPr>
         <p:spPr>
           <a:xfrm>
-            <a:off x="3410712" y="5047488"/>
+            <a:off x="3410712" y="5120640"/>
             <a:ext cx="1188720" cy="256032"/>
           </a:xfrm>
           <a:prstGeom prst="rect">
@@ -10875,7 +10875,7 @@
               <a:buNone/>
             </a:pPr>
             <a:r>
-              <a:rPr lang="en-US" sz="1200" b="1" dirty="0">
+              <a:rPr lang="en-US" sz="1300" b="1" dirty="0">
                 <a:solidFill>
                   <a:srgbClr val="222222"/>
                 </a:solidFill>
@@ -10885,7 +10885,7 @@
               </a:rPr>
               <a:t>디자인 포인트</a:t>
             </a:r>
-            <a:endParaRPr lang="en-US" sz="1200" dirty="0"/>
+            <a:endParaRPr lang="en-US" sz="1300" dirty="0"/>
           </a:p>
         </p:txBody>
       </p:sp>
@@ -10897,8 +10897,8 @@
         </p:nvSpPr>
         <p:spPr>
           <a:xfrm>
-            <a:off x="3410712" y="5248656"/>
-            <a:ext cx="8549640" cy="411480"/>
+            <a:off x="3410712" y="5468112"/>
+            <a:ext cx="8549640" cy="484632"/>
           </a:xfrm>
           <a:prstGeom prst="rect">
             <a:avLst/>
@@ -10938,7 +10938,7 @@
         </p:nvSpPr>
         <p:spPr>
           <a:xfrm>
-            <a:off x="3410712" y="5486400"/>
+            <a:off x="3410712" y="6099048"/>
             <a:ext cx="8549640" cy="219456"/>
           </a:xfrm>
           <a:prstGeom prst="rect">
@@ -10957,7 +10957,7 @@
               <a:buNone/>
             </a:pPr>
             <a:r>
-              <a:rPr lang="en-US" sz="1050" b="1" dirty="0">
+              <a:rPr lang="en-US" sz="1300" b="1" dirty="0">
                 <a:solidFill>
                   <a:srgbClr val="222222"/>
                 </a:solidFill>
@@ -10967,7 +10967,7 @@
               </a:rPr>
               <a:t>의학·인지과학 근거</a:t>
             </a:r>
-            <a:endParaRPr lang="en-US" sz="1050" dirty="0"/>
+            <a:endParaRPr lang="en-US" sz="1300" dirty="0"/>
           </a:p>
         </p:txBody>
       </p:sp>
@@ -10979,8 +10979,8 @@
         </p:nvSpPr>
         <p:spPr>
           <a:xfrm>
-            <a:off x="3410712" y="5669280"/>
-            <a:ext cx="8549640" cy="749808"/>
+            <a:off x="3410712" y="6446520"/>
+            <a:ext cx="8549640" cy="457200"/>
           </a:xfrm>
           <a:prstGeom prst="rect">
             <a:avLst/>
@@ -10998,7 +10998,7 @@
               <a:buNone/>
             </a:pPr>
             <a:r>
-              <a:rPr lang="en-US" sz="940" dirty="0">
+              <a:rPr lang="en-US" sz="1020" dirty="0">
                 <a:solidFill>
                   <a:srgbClr val="6A6A6A"/>
                 </a:solidFill>
@@ -11008,7 +11008,7 @@
               </a:rPr>
               <a:t>근거축: 지연회상 검증은 encode-delay-recognition 흐름을 통해 회상 흔적을 추적하고 임상 점수 대신 패턴을 누적 분석합니다.</a:t>
             </a:r>
-            <a:endParaRPr lang="en-US" sz="940" dirty="0"/>
+            <a:endParaRPr lang="en-US" sz="1020" dirty="0"/>
           </a:p>
         </p:txBody>
       </p:sp>
@@ -11491,7 +11491,7 @@
         </p:nvSpPr>
         <p:spPr>
           <a:xfrm>
-            <a:off x="3410712" y="3849624"/>
+            <a:off x="3410712" y="3872484"/>
             <a:ext cx="91440" cy="91440"/>
           </a:xfrm>
           <a:prstGeom prst="ellipse">
@@ -11518,8 +11518,8 @@
         </p:nvSpPr>
         <p:spPr>
           <a:xfrm>
-            <a:off x="3611880" y="3712464"/>
-            <a:ext cx="8348472" cy="365760"/>
+            <a:off x="3611880" y="3767328"/>
+            <a:ext cx="8348472" cy="301752"/>
           </a:xfrm>
           <a:prstGeom prst="rect">
             <a:avLst/>
@@ -11559,7 +11559,7 @@
         </p:nvSpPr>
         <p:spPr>
           <a:xfrm>
-            <a:off x="3410712" y="4215384"/>
+            <a:off x="3410712" y="4174236"/>
             <a:ext cx="91440" cy="91440"/>
           </a:xfrm>
           <a:prstGeom prst="ellipse">
@@ -11586,8 +11586,8 @@
         </p:nvSpPr>
         <p:spPr>
           <a:xfrm>
-            <a:off x="3611880" y="4078224"/>
-            <a:ext cx="8348472" cy="365760"/>
+            <a:off x="3611880" y="4069080"/>
+            <a:ext cx="8348472" cy="301752"/>
           </a:xfrm>
           <a:prstGeom prst="rect">
             <a:avLst/>
@@ -11627,7 +11627,7 @@
         </p:nvSpPr>
         <p:spPr>
           <a:xfrm>
-            <a:off x="3410712" y="4581144"/>
+            <a:off x="3410712" y="4475988"/>
             <a:ext cx="91440" cy="91440"/>
           </a:xfrm>
           <a:prstGeom prst="ellipse">
@@ -11654,8 +11654,8 @@
         </p:nvSpPr>
         <p:spPr>
           <a:xfrm>
-            <a:off x="3611880" y="4443984"/>
-            <a:ext cx="8348472" cy="365760"/>
+            <a:off x="3611880" y="4370832"/>
+            <a:ext cx="8348472" cy="301752"/>
           </a:xfrm>
           <a:prstGeom prst="rect">
             <a:avLst/>
@@ -11695,7 +11695,7 @@
         </p:nvSpPr>
         <p:spPr>
           <a:xfrm>
-            <a:off x="3410712" y="4946904"/>
+            <a:off x="3410712" y="4777740"/>
             <a:ext cx="91440" cy="91440"/>
           </a:xfrm>
           <a:prstGeom prst="ellipse">
@@ -11722,8 +11722,8 @@
         </p:nvSpPr>
         <p:spPr>
           <a:xfrm>
-            <a:off x="3611880" y="4809744"/>
-            <a:ext cx="8348472" cy="365760"/>
+            <a:off x="3611880" y="4672584"/>
+            <a:ext cx="8348472" cy="301752"/>
           </a:xfrm>
           <a:prstGeom prst="rect">
             <a:avLst/>
@@ -11763,7 +11763,7 @@
         </p:nvSpPr>
         <p:spPr>
           <a:xfrm>
-            <a:off x="3410712" y="5047488"/>
+            <a:off x="3410712" y="5120640"/>
             <a:ext cx="1188720" cy="256032"/>
           </a:xfrm>
           <a:prstGeom prst="rect">
@@ -11782,7 +11782,7 @@
               <a:buNone/>
             </a:pPr>
             <a:r>
-              <a:rPr lang="en-US" sz="1200" b="1" dirty="0">
+              <a:rPr lang="en-US" sz="1300" b="1" dirty="0">
                 <a:solidFill>
                   <a:srgbClr val="222222"/>
                 </a:solidFill>
@@ -11792,7 +11792,7 @@
               </a:rPr>
               <a:t>디자인 포인트</a:t>
             </a:r>
-            <a:endParaRPr lang="en-US" sz="1200" dirty="0"/>
+            <a:endParaRPr lang="en-US" sz="1300" dirty="0"/>
           </a:p>
         </p:txBody>
       </p:sp>
@@ -11804,8 +11804,8 @@
         </p:nvSpPr>
         <p:spPr>
           <a:xfrm>
-            <a:off x="3410712" y="5248656"/>
-            <a:ext cx="8549640" cy="411480"/>
+            <a:off x="3410712" y="5468112"/>
+            <a:ext cx="8549640" cy="484632"/>
           </a:xfrm>
           <a:prstGeom prst="rect">
             <a:avLst/>
@@ -11845,7 +11845,7 @@
         </p:nvSpPr>
         <p:spPr>
           <a:xfrm>
-            <a:off x="3410712" y="5486400"/>
+            <a:off x="3410712" y="6099048"/>
             <a:ext cx="8549640" cy="219456"/>
           </a:xfrm>
           <a:prstGeom prst="rect">
@@ -11864,7 +11864,7 @@
               <a:buNone/>
             </a:pPr>
             <a:r>
-              <a:rPr lang="en-US" sz="1050" b="1" dirty="0">
+              <a:rPr lang="en-US" sz="1300" b="1" dirty="0">
                 <a:solidFill>
                   <a:srgbClr val="222222"/>
                 </a:solidFill>
@@ -11874,7 +11874,7 @@
               </a:rPr>
               <a:t>의학·인지과학 근거</a:t>
             </a:r>
-            <a:endParaRPr lang="en-US" sz="1050" dirty="0"/>
+            <a:endParaRPr lang="en-US" sz="1300" dirty="0"/>
           </a:p>
         </p:txBody>
       </p:sp>
@@ -11886,8 +11886,8 @@
         </p:nvSpPr>
         <p:spPr>
           <a:xfrm>
-            <a:off x="3410712" y="5669280"/>
-            <a:ext cx="8549640" cy="749808"/>
+            <a:off x="3410712" y="6446520"/>
+            <a:ext cx="8549640" cy="457200"/>
           </a:xfrm>
           <a:prstGeom prst="rect">
             <a:avLst/>
@@ -11905,7 +11905,7 @@
               <a:buNone/>
             </a:pPr>
             <a:r>
-              <a:rPr lang="en-US" sz="940" dirty="0">
+              <a:rPr lang="en-US" sz="1020" dirty="0">
                 <a:solidFill>
                   <a:srgbClr val="6A6A6A"/>
                 </a:solidFill>
@@ -11915,7 +11915,7 @@
               </a:rPr>
               <a:t>근거축: 개인 기억 수집은 회상 소재를 보호자 대화로 연결하기 위한 일상 맥락형 기록이며, 공유 동의 분리 저장 원칙을 따릅니다.</a:t>
             </a:r>
-            <a:endParaRPr lang="en-US" sz="940" dirty="0"/>
+            <a:endParaRPr lang="en-US" sz="1020" dirty="0"/>
           </a:p>
         </p:txBody>
       </p:sp>
@@ -12398,7 +12398,7 @@
         </p:nvSpPr>
         <p:spPr>
           <a:xfrm>
-            <a:off x="3410712" y="3849624"/>
+            <a:off x="3410712" y="3872484"/>
             <a:ext cx="91440" cy="91440"/>
           </a:xfrm>
           <a:prstGeom prst="ellipse">
@@ -12425,8 +12425,8 @@
         </p:nvSpPr>
         <p:spPr>
           <a:xfrm>
-            <a:off x="3611880" y="3712464"/>
-            <a:ext cx="8348472" cy="365760"/>
+            <a:off x="3611880" y="3767328"/>
+            <a:ext cx="8348472" cy="301752"/>
           </a:xfrm>
           <a:prstGeom prst="rect">
             <a:avLst/>
@@ -12466,7 +12466,7 @@
         </p:nvSpPr>
         <p:spPr>
           <a:xfrm>
-            <a:off x="3410712" y="4215384"/>
+            <a:off x="3410712" y="4174236"/>
             <a:ext cx="91440" cy="91440"/>
           </a:xfrm>
           <a:prstGeom prst="ellipse">
@@ -12493,8 +12493,8 @@
         </p:nvSpPr>
         <p:spPr>
           <a:xfrm>
-            <a:off x="3611880" y="4078224"/>
-            <a:ext cx="8348472" cy="365760"/>
+            <a:off x="3611880" y="4069080"/>
+            <a:ext cx="8348472" cy="301752"/>
           </a:xfrm>
           <a:prstGeom prst="rect">
             <a:avLst/>
@@ -12534,7 +12534,7 @@
         </p:nvSpPr>
         <p:spPr>
           <a:xfrm>
-            <a:off x="3410712" y="4581144"/>
+            <a:off x="3410712" y="4475988"/>
             <a:ext cx="91440" cy="91440"/>
           </a:xfrm>
           <a:prstGeom prst="ellipse">
@@ -12561,8 +12561,8 @@
         </p:nvSpPr>
         <p:spPr>
           <a:xfrm>
-            <a:off x="3611880" y="4443984"/>
-            <a:ext cx="8348472" cy="365760"/>
+            <a:off x="3611880" y="4370832"/>
+            <a:ext cx="8348472" cy="301752"/>
           </a:xfrm>
           <a:prstGeom prst="rect">
             <a:avLst/>
@@ -12602,7 +12602,7 @@
         </p:nvSpPr>
         <p:spPr>
           <a:xfrm>
-            <a:off x="3410712" y="4946904"/>
+            <a:off x="3410712" y="4777740"/>
             <a:ext cx="91440" cy="91440"/>
           </a:xfrm>
           <a:prstGeom prst="ellipse">
@@ -12629,8 +12629,8 @@
         </p:nvSpPr>
         <p:spPr>
           <a:xfrm>
-            <a:off x="3611880" y="4809744"/>
-            <a:ext cx="8348472" cy="365760"/>
+            <a:off x="3611880" y="4672584"/>
+            <a:ext cx="8348472" cy="301752"/>
           </a:xfrm>
           <a:prstGeom prst="rect">
             <a:avLst/>
@@ -12670,7 +12670,7 @@
         </p:nvSpPr>
         <p:spPr>
           <a:xfrm>
-            <a:off x="3410712" y="5047488"/>
+            <a:off x="3410712" y="5120640"/>
             <a:ext cx="1188720" cy="256032"/>
           </a:xfrm>
           <a:prstGeom prst="rect">
@@ -12689,7 +12689,7 @@
               <a:buNone/>
             </a:pPr>
             <a:r>
-              <a:rPr lang="en-US" sz="1200" b="1" dirty="0">
+              <a:rPr lang="en-US" sz="1300" b="1" dirty="0">
                 <a:solidFill>
                   <a:srgbClr val="222222"/>
                 </a:solidFill>
@@ -12699,7 +12699,7 @@
               </a:rPr>
               <a:t>디자인 포인트</a:t>
             </a:r>
-            <a:endParaRPr lang="en-US" sz="1200" dirty="0"/>
+            <a:endParaRPr lang="en-US" sz="1300" dirty="0"/>
           </a:p>
         </p:txBody>
       </p:sp>
@@ -12711,8 +12711,8 @@
         </p:nvSpPr>
         <p:spPr>
           <a:xfrm>
-            <a:off x="3410712" y="5248656"/>
-            <a:ext cx="8549640" cy="411480"/>
+            <a:off x="3410712" y="5468112"/>
+            <a:ext cx="8549640" cy="484632"/>
           </a:xfrm>
           <a:prstGeom prst="rect">
             <a:avLst/>
@@ -12752,7 +12752,7 @@
         </p:nvSpPr>
         <p:spPr>
           <a:xfrm>
-            <a:off x="3410712" y="5486400"/>
+            <a:off x="3410712" y="6099048"/>
             <a:ext cx="8549640" cy="219456"/>
           </a:xfrm>
           <a:prstGeom prst="rect">
@@ -12771,7 +12771,7 @@
               <a:buNone/>
             </a:pPr>
             <a:r>
-              <a:rPr lang="en-US" sz="1050" b="1" dirty="0">
+              <a:rPr lang="en-US" sz="1300" b="1" dirty="0">
                 <a:solidFill>
                   <a:srgbClr val="222222"/>
                 </a:solidFill>
@@ -12781,7 +12781,7 @@
               </a:rPr>
               <a:t>의학·인지과학 근거</a:t>
             </a:r>
-            <a:endParaRPr lang="en-US" sz="1050" dirty="0"/>
+            <a:endParaRPr lang="en-US" sz="1300" dirty="0"/>
           </a:p>
         </p:txBody>
       </p:sp>
@@ -12793,8 +12793,8 @@
         </p:nvSpPr>
         <p:spPr>
           <a:xfrm>
-            <a:off x="3410712" y="5669280"/>
-            <a:ext cx="8549640" cy="749808"/>
+            <a:off x="3410712" y="6446520"/>
+            <a:ext cx="8549640" cy="457200"/>
           </a:xfrm>
           <a:prstGeom prst="rect">
             <a:avLst/>
@@ -12812,7 +12812,7 @@
               <a:buNone/>
             </a:pPr>
             <a:r>
-              <a:rPr lang="en-US" sz="940" dirty="0">
+              <a:rPr lang="en-US" sz="1020" dirty="0">
                 <a:solidFill>
                   <a:srgbClr val="6A6A6A"/>
                 </a:solidFill>
@@ -12822,7 +12822,7 @@
               </a:rPr>
               <a:t>근거축: 감정 라벨은 정서 맥락을 확보해 대화 연계를 돕는 메타 데이터로만 사용되며, 의학적 판정 근거로 쓰지 않습니다.</a:t>
             </a:r>
-            <a:endParaRPr lang="en-US" sz="940" dirty="0"/>
+            <a:endParaRPr lang="en-US" sz="1020" dirty="0"/>
           </a:p>
         </p:txBody>
       </p:sp>
@@ -13305,7 +13305,7 @@
         </p:nvSpPr>
         <p:spPr>
           <a:xfrm>
-            <a:off x="3410712" y="3849624"/>
+            <a:off x="3410712" y="3872484"/>
             <a:ext cx="91440" cy="91440"/>
           </a:xfrm>
           <a:prstGeom prst="ellipse">
@@ -13332,8 +13332,8 @@
         </p:nvSpPr>
         <p:spPr>
           <a:xfrm>
-            <a:off x="3611880" y="3712464"/>
-            <a:ext cx="8348472" cy="365760"/>
+            <a:off x="3611880" y="3767328"/>
+            <a:ext cx="8348472" cy="301752"/>
           </a:xfrm>
           <a:prstGeom prst="rect">
             <a:avLst/>
@@ -13373,7 +13373,7 @@
         </p:nvSpPr>
         <p:spPr>
           <a:xfrm>
-            <a:off x="3410712" y="4215384"/>
+            <a:off x="3410712" y="4174236"/>
             <a:ext cx="91440" cy="91440"/>
           </a:xfrm>
           <a:prstGeom prst="ellipse">
@@ -13400,8 +13400,8 @@
         </p:nvSpPr>
         <p:spPr>
           <a:xfrm>
-            <a:off x="3611880" y="4078224"/>
-            <a:ext cx="8348472" cy="365760"/>
+            <a:off x="3611880" y="4069080"/>
+            <a:ext cx="8348472" cy="301752"/>
           </a:xfrm>
           <a:prstGeom prst="rect">
             <a:avLst/>
@@ -13441,7 +13441,7 @@
         </p:nvSpPr>
         <p:spPr>
           <a:xfrm>
-            <a:off x="3410712" y="4581144"/>
+            <a:off x="3410712" y="4475988"/>
             <a:ext cx="91440" cy="91440"/>
           </a:xfrm>
           <a:prstGeom prst="ellipse">
@@ -13468,8 +13468,8 @@
         </p:nvSpPr>
         <p:spPr>
           <a:xfrm>
-            <a:off x="3611880" y="4443984"/>
-            <a:ext cx="8348472" cy="365760"/>
+            <a:off x="3611880" y="4370832"/>
+            <a:ext cx="8348472" cy="301752"/>
           </a:xfrm>
           <a:prstGeom prst="rect">
             <a:avLst/>
@@ -13509,7 +13509,7 @@
         </p:nvSpPr>
         <p:spPr>
           <a:xfrm>
-            <a:off x="3410712" y="4946904"/>
+            <a:off x="3410712" y="4777740"/>
             <a:ext cx="91440" cy="91440"/>
           </a:xfrm>
           <a:prstGeom prst="ellipse">
@@ -13536,8 +13536,8 @@
         </p:nvSpPr>
         <p:spPr>
           <a:xfrm>
-            <a:off x="3611880" y="4809744"/>
-            <a:ext cx="8348472" cy="365760"/>
+            <a:off x="3611880" y="4672584"/>
+            <a:ext cx="8348472" cy="301752"/>
           </a:xfrm>
           <a:prstGeom prst="rect">
             <a:avLst/>
@@ -13577,7 +13577,7 @@
         </p:nvSpPr>
         <p:spPr>
           <a:xfrm>
-            <a:off x="3410712" y="5047488"/>
+            <a:off x="3410712" y="5120640"/>
             <a:ext cx="1188720" cy="256032"/>
           </a:xfrm>
           <a:prstGeom prst="rect">
@@ -13596,7 +13596,7 @@
               <a:buNone/>
             </a:pPr>
             <a:r>
-              <a:rPr lang="en-US" sz="1200" b="1" dirty="0">
+              <a:rPr lang="en-US" sz="1300" b="1" dirty="0">
                 <a:solidFill>
                   <a:srgbClr val="222222"/>
                 </a:solidFill>
@@ -13606,7 +13606,7 @@
               </a:rPr>
               <a:t>디자인 포인트</a:t>
             </a:r>
-            <a:endParaRPr lang="en-US" sz="1200" dirty="0"/>
+            <a:endParaRPr lang="en-US" sz="1300" dirty="0"/>
           </a:p>
         </p:txBody>
       </p:sp>
@@ -13618,8 +13618,8 @@
         </p:nvSpPr>
         <p:spPr>
           <a:xfrm>
-            <a:off x="3410712" y="5248656"/>
-            <a:ext cx="8549640" cy="411480"/>
+            <a:off x="3410712" y="5468112"/>
+            <a:ext cx="8549640" cy="484632"/>
           </a:xfrm>
           <a:prstGeom prst="rect">
             <a:avLst/>
@@ -13659,7 +13659,7 @@
         </p:nvSpPr>
         <p:spPr>
           <a:xfrm>
-            <a:off x="3410712" y="5486400"/>
+            <a:off x="3410712" y="6099048"/>
             <a:ext cx="8549640" cy="219456"/>
           </a:xfrm>
           <a:prstGeom prst="rect">
@@ -13678,7 +13678,7 @@
               <a:buNone/>
             </a:pPr>
             <a:r>
-              <a:rPr lang="en-US" sz="1050" b="1" dirty="0">
+              <a:rPr lang="en-US" sz="1300" b="1" dirty="0">
                 <a:solidFill>
                   <a:srgbClr val="222222"/>
                 </a:solidFill>
@@ -13688,7 +13688,7 @@
               </a:rPr>
               <a:t>의학·인지과학 근거</a:t>
             </a:r>
-            <a:endParaRPr lang="en-US" sz="1050" dirty="0"/>
+            <a:endParaRPr lang="en-US" sz="1300" dirty="0"/>
           </a:p>
         </p:txBody>
       </p:sp>
@@ -13700,8 +13700,8 @@
         </p:nvSpPr>
         <p:spPr>
           <a:xfrm>
-            <a:off x="3410712" y="5669280"/>
-            <a:ext cx="8549640" cy="749808"/>
+            <a:off x="3410712" y="6446520"/>
+            <a:ext cx="8549640" cy="457200"/>
           </a:xfrm>
           <a:prstGeom prst="rect">
             <a:avLst/>
@@ -13719,7 +13719,7 @@
               <a:buNone/>
             </a:pPr>
             <a:r>
-              <a:rPr lang="en-US" sz="940" dirty="0">
+              <a:rPr lang="en-US" sz="1020" dirty="0">
                 <a:solidFill>
                   <a:srgbClr val="6A6A6A"/>
                 </a:solidFill>
@@ -13729,7 +13729,7 @@
               </a:rPr>
               <a:t>근거축: 홈의 동선 분리와 큰 우선순위 표시, 접근성 중심 구성은 W3C WAI Older Adults 접근성 가이드 원칙을 반영했습니다.</a:t>
             </a:r>
-            <a:endParaRPr lang="en-US" sz="940" dirty="0"/>
+            <a:endParaRPr lang="en-US" sz="1020" dirty="0"/>
           </a:p>
         </p:txBody>
       </p:sp>
@@ -14212,7 +14212,7 @@
         </p:nvSpPr>
         <p:spPr>
           <a:xfrm>
-            <a:off x="3410712" y="3849624"/>
+            <a:off x="3410712" y="3872484"/>
             <a:ext cx="91440" cy="91440"/>
           </a:xfrm>
           <a:prstGeom prst="ellipse">
@@ -14239,8 +14239,8 @@
         </p:nvSpPr>
         <p:spPr>
           <a:xfrm>
-            <a:off x="3611880" y="3712464"/>
-            <a:ext cx="8348472" cy="365760"/>
+            <a:off x="3611880" y="3767328"/>
+            <a:ext cx="8348472" cy="301752"/>
           </a:xfrm>
           <a:prstGeom prst="rect">
             <a:avLst/>
@@ -14280,7 +14280,7 @@
         </p:nvSpPr>
         <p:spPr>
           <a:xfrm>
-            <a:off x="3410712" y="4215384"/>
+            <a:off x="3410712" y="4174236"/>
             <a:ext cx="91440" cy="91440"/>
           </a:xfrm>
           <a:prstGeom prst="ellipse">
@@ -14307,8 +14307,8 @@
         </p:nvSpPr>
         <p:spPr>
           <a:xfrm>
-            <a:off x="3611880" y="4078224"/>
-            <a:ext cx="8348472" cy="365760"/>
+            <a:off x="3611880" y="4069080"/>
+            <a:ext cx="8348472" cy="301752"/>
           </a:xfrm>
           <a:prstGeom prst="rect">
             <a:avLst/>
@@ -14348,7 +14348,7 @@
         </p:nvSpPr>
         <p:spPr>
           <a:xfrm>
-            <a:off x="3410712" y="4581144"/>
+            <a:off x="3410712" y="4475988"/>
             <a:ext cx="91440" cy="91440"/>
           </a:xfrm>
           <a:prstGeom prst="ellipse">
@@ -14375,8 +14375,8 @@
         </p:nvSpPr>
         <p:spPr>
           <a:xfrm>
-            <a:off x="3611880" y="4443984"/>
-            <a:ext cx="8348472" cy="365760"/>
+            <a:off x="3611880" y="4370832"/>
+            <a:ext cx="8348472" cy="301752"/>
           </a:xfrm>
           <a:prstGeom prst="rect">
             <a:avLst/>
@@ -14416,7 +14416,7 @@
         </p:nvSpPr>
         <p:spPr>
           <a:xfrm>
-            <a:off x="3410712" y="4946904"/>
+            <a:off x="3410712" y="4777740"/>
             <a:ext cx="91440" cy="91440"/>
           </a:xfrm>
           <a:prstGeom prst="ellipse">
@@ -14443,8 +14443,8 @@
         </p:nvSpPr>
         <p:spPr>
           <a:xfrm>
-            <a:off x="3611880" y="4809744"/>
-            <a:ext cx="8348472" cy="365760"/>
+            <a:off x="3611880" y="4672584"/>
+            <a:ext cx="8348472" cy="301752"/>
           </a:xfrm>
           <a:prstGeom prst="rect">
             <a:avLst/>
@@ -14484,7 +14484,7 @@
         </p:nvSpPr>
         <p:spPr>
           <a:xfrm>
-            <a:off x="3410712" y="5047488"/>
+            <a:off x="3410712" y="5120640"/>
             <a:ext cx="1188720" cy="256032"/>
           </a:xfrm>
           <a:prstGeom prst="rect">
@@ -14503,7 +14503,7 @@
               <a:buNone/>
             </a:pPr>
             <a:r>
-              <a:rPr lang="en-US" sz="1200" b="1" dirty="0">
+              <a:rPr lang="en-US" sz="1300" b="1" dirty="0">
                 <a:solidFill>
                   <a:srgbClr val="222222"/>
                 </a:solidFill>
@@ -14513,7 +14513,7 @@
               </a:rPr>
               <a:t>디자인 포인트</a:t>
             </a:r>
-            <a:endParaRPr lang="en-US" sz="1200" dirty="0"/>
+            <a:endParaRPr lang="en-US" sz="1300" dirty="0"/>
           </a:p>
         </p:txBody>
       </p:sp>
@@ -14525,8 +14525,8 @@
         </p:nvSpPr>
         <p:spPr>
           <a:xfrm>
-            <a:off x="3410712" y="5248656"/>
-            <a:ext cx="8549640" cy="411480"/>
+            <a:off x="3410712" y="5468112"/>
+            <a:ext cx="8549640" cy="484632"/>
           </a:xfrm>
           <a:prstGeom prst="rect">
             <a:avLst/>
@@ -14566,7 +14566,7 @@
         </p:nvSpPr>
         <p:spPr>
           <a:xfrm>
-            <a:off x="3410712" y="5486400"/>
+            <a:off x="3410712" y="6099048"/>
             <a:ext cx="8549640" cy="219456"/>
           </a:xfrm>
           <a:prstGeom prst="rect">
@@ -14585,7 +14585,7 @@
               <a:buNone/>
             </a:pPr>
             <a:r>
-              <a:rPr lang="en-US" sz="1050" b="1" dirty="0">
+              <a:rPr lang="en-US" sz="1300" b="1" dirty="0">
                 <a:solidFill>
                   <a:srgbClr val="222222"/>
                 </a:solidFill>
@@ -14595,7 +14595,7 @@
               </a:rPr>
               <a:t>의학·인지과학 근거</a:t>
             </a:r>
-            <a:endParaRPr lang="en-US" sz="1050" dirty="0"/>
+            <a:endParaRPr lang="en-US" sz="1300" dirty="0"/>
           </a:p>
         </p:txBody>
       </p:sp>
@@ -14607,8 +14607,8 @@
         </p:nvSpPr>
         <p:spPr>
           <a:xfrm>
-            <a:off x="3410712" y="5669280"/>
-            <a:ext cx="8549640" cy="749808"/>
+            <a:off x="3410712" y="6446520"/>
+            <a:ext cx="8549640" cy="457200"/>
           </a:xfrm>
           <a:prstGeom prst="rect">
             <a:avLst/>
@@ -14626,7 +14626,7 @@
               <a:buNone/>
             </a:pPr>
             <a:r>
-              <a:rPr lang="en-US" sz="940" dirty="0">
+              <a:rPr lang="en-US" sz="1020" dirty="0">
                 <a:solidFill>
                   <a:srgbClr val="6A6A6A"/>
                 </a:solidFill>
@@ -14636,7 +14636,7 @@
               </a:rPr>
               <a:t>근거축: 세션 요약은 정답률보다 완료 경험과 참여 연속성을 중심으로 동기 지속 신호를 제공합니다.</a:t>
             </a:r>
-            <a:endParaRPr lang="en-US" sz="940" dirty="0"/>
+            <a:endParaRPr lang="en-US" sz="1020" dirty="0"/>
           </a:p>
         </p:txBody>
       </p:sp>
@@ -15119,7 +15119,7 @@
         </p:nvSpPr>
         <p:spPr>
           <a:xfrm>
-            <a:off x="3410712" y="3849624"/>
+            <a:off x="3410712" y="3872484"/>
             <a:ext cx="91440" cy="91440"/>
           </a:xfrm>
           <a:prstGeom prst="ellipse">
@@ -15146,8 +15146,8 @@
         </p:nvSpPr>
         <p:spPr>
           <a:xfrm>
-            <a:off x="3611880" y="3712464"/>
-            <a:ext cx="8348472" cy="365760"/>
+            <a:off x="3611880" y="3767328"/>
+            <a:ext cx="8348472" cy="301752"/>
           </a:xfrm>
           <a:prstGeom prst="rect">
             <a:avLst/>
@@ -15187,7 +15187,7 @@
         </p:nvSpPr>
         <p:spPr>
           <a:xfrm>
-            <a:off x="3410712" y="4215384"/>
+            <a:off x="3410712" y="4174236"/>
             <a:ext cx="91440" cy="91440"/>
           </a:xfrm>
           <a:prstGeom prst="ellipse">
@@ -15214,8 +15214,8 @@
         </p:nvSpPr>
         <p:spPr>
           <a:xfrm>
-            <a:off x="3611880" y="4078224"/>
-            <a:ext cx="8348472" cy="365760"/>
+            <a:off x="3611880" y="4069080"/>
+            <a:ext cx="8348472" cy="301752"/>
           </a:xfrm>
           <a:prstGeom prst="rect">
             <a:avLst/>
@@ -15255,7 +15255,7 @@
         </p:nvSpPr>
         <p:spPr>
           <a:xfrm>
-            <a:off x="3410712" y="4581144"/>
+            <a:off x="3410712" y="4475988"/>
             <a:ext cx="91440" cy="91440"/>
           </a:xfrm>
           <a:prstGeom prst="ellipse">
@@ -15282,8 +15282,8 @@
         </p:nvSpPr>
         <p:spPr>
           <a:xfrm>
-            <a:off x="3611880" y="4443984"/>
-            <a:ext cx="8348472" cy="365760"/>
+            <a:off x="3611880" y="4370832"/>
+            <a:ext cx="8348472" cy="301752"/>
           </a:xfrm>
           <a:prstGeom prst="rect">
             <a:avLst/>
@@ -15323,7 +15323,7 @@
         </p:nvSpPr>
         <p:spPr>
           <a:xfrm>
-            <a:off x="3410712" y="4946904"/>
+            <a:off x="3410712" y="4777740"/>
             <a:ext cx="91440" cy="91440"/>
           </a:xfrm>
           <a:prstGeom prst="ellipse">
@@ -15350,8 +15350,8 @@
         </p:nvSpPr>
         <p:spPr>
           <a:xfrm>
-            <a:off x="3611880" y="4809744"/>
-            <a:ext cx="8348472" cy="365760"/>
+            <a:off x="3611880" y="4672584"/>
+            <a:ext cx="8348472" cy="301752"/>
           </a:xfrm>
           <a:prstGeom prst="rect">
             <a:avLst/>
@@ -15391,7 +15391,7 @@
         </p:nvSpPr>
         <p:spPr>
           <a:xfrm>
-            <a:off x="3410712" y="5047488"/>
+            <a:off x="3410712" y="5120640"/>
             <a:ext cx="1188720" cy="256032"/>
           </a:xfrm>
           <a:prstGeom prst="rect">
@@ -15410,7 +15410,7 @@
               <a:buNone/>
             </a:pPr>
             <a:r>
-              <a:rPr lang="en-US" sz="1200" b="1" dirty="0">
+              <a:rPr lang="en-US" sz="1300" b="1" dirty="0">
                 <a:solidFill>
                   <a:srgbClr val="222222"/>
                 </a:solidFill>
@@ -15420,7 +15420,7 @@
               </a:rPr>
               <a:t>디자인 포인트</a:t>
             </a:r>
-            <a:endParaRPr lang="en-US" sz="1200" dirty="0"/>
+            <a:endParaRPr lang="en-US" sz="1300" dirty="0"/>
           </a:p>
         </p:txBody>
       </p:sp>
@@ -15432,8 +15432,8 @@
         </p:nvSpPr>
         <p:spPr>
           <a:xfrm>
-            <a:off x="3410712" y="5248656"/>
-            <a:ext cx="8549640" cy="411480"/>
+            <a:off x="3410712" y="5468112"/>
+            <a:ext cx="8549640" cy="484632"/>
           </a:xfrm>
           <a:prstGeom prst="rect">
             <a:avLst/>
@@ -15473,7 +15473,7 @@
         </p:nvSpPr>
         <p:spPr>
           <a:xfrm>
-            <a:off x="3410712" y="5486400"/>
+            <a:off x="3410712" y="6099048"/>
             <a:ext cx="8549640" cy="219456"/>
           </a:xfrm>
           <a:prstGeom prst="rect">
@@ -15492,7 +15492,7 @@
               <a:buNone/>
             </a:pPr>
             <a:r>
-              <a:rPr lang="en-US" sz="1050" b="1" dirty="0">
+              <a:rPr lang="en-US" sz="1300" b="1" dirty="0">
                 <a:solidFill>
                   <a:srgbClr val="222222"/>
                 </a:solidFill>
@@ -15502,7 +15502,7 @@
               </a:rPr>
               <a:t>의학·인지과학 근거</a:t>
             </a:r>
-            <a:endParaRPr lang="en-US" sz="1050" dirty="0"/>
+            <a:endParaRPr lang="en-US" sz="1300" dirty="0"/>
           </a:p>
         </p:txBody>
       </p:sp>
@@ -15514,8 +15514,8 @@
         </p:nvSpPr>
         <p:spPr>
           <a:xfrm>
-            <a:off x="3410712" y="5669280"/>
-            <a:ext cx="8549640" cy="749808"/>
+            <a:off x="3410712" y="6446520"/>
+            <a:ext cx="8549640" cy="457200"/>
           </a:xfrm>
           <a:prstGeom prst="rect">
             <a:avLst/>
@@ -15533,7 +15533,7 @@
               <a:buNone/>
             </a:pPr>
             <a:r>
-              <a:rPr lang="en-US" sz="940" dirty="0">
+              <a:rPr lang="en-US" sz="1020" dirty="0">
                 <a:solidFill>
                   <a:srgbClr val="6A6A6A"/>
                 </a:solidFill>
@@ -15543,7 +15543,7 @@
               </a:rPr>
               <a:t>근거축: 정원형 보상은 매일 참여를 시각적으로 지속화하는 동기부여 요소로, 의료 성적 지표와 분리해 운영됩니다.</a:t>
             </a:r>
-            <a:endParaRPr lang="en-US" sz="940" dirty="0"/>
+            <a:endParaRPr lang="en-US" sz="1020" dirty="0"/>
           </a:p>
         </p:txBody>
       </p:sp>
@@ -16026,7 +16026,7 @@
         </p:nvSpPr>
         <p:spPr>
           <a:xfrm>
-            <a:off x="3410712" y="3849624"/>
+            <a:off x="3410712" y="3872484"/>
             <a:ext cx="91440" cy="91440"/>
           </a:xfrm>
           <a:prstGeom prst="ellipse">
@@ -16053,8 +16053,8 @@
         </p:nvSpPr>
         <p:spPr>
           <a:xfrm>
-            <a:off x="3611880" y="3712464"/>
-            <a:ext cx="8348472" cy="365760"/>
+            <a:off x="3611880" y="3767328"/>
+            <a:ext cx="8348472" cy="301752"/>
           </a:xfrm>
           <a:prstGeom prst="rect">
             <a:avLst/>
@@ -16094,7 +16094,7 @@
         </p:nvSpPr>
         <p:spPr>
           <a:xfrm>
-            <a:off x="3410712" y="4215384"/>
+            <a:off x="3410712" y="4174236"/>
             <a:ext cx="91440" cy="91440"/>
           </a:xfrm>
           <a:prstGeom prst="ellipse">
@@ -16121,8 +16121,8 @@
         </p:nvSpPr>
         <p:spPr>
           <a:xfrm>
-            <a:off x="3611880" y="4078224"/>
-            <a:ext cx="8348472" cy="365760"/>
+            <a:off x="3611880" y="4069080"/>
+            <a:ext cx="8348472" cy="301752"/>
           </a:xfrm>
           <a:prstGeom prst="rect">
             <a:avLst/>
@@ -16162,7 +16162,7 @@
         </p:nvSpPr>
         <p:spPr>
           <a:xfrm>
-            <a:off x="3410712" y="4581144"/>
+            <a:off x="3410712" y="4475988"/>
             <a:ext cx="91440" cy="91440"/>
           </a:xfrm>
           <a:prstGeom prst="ellipse">
@@ -16189,8 +16189,8 @@
         </p:nvSpPr>
         <p:spPr>
           <a:xfrm>
-            <a:off x="3611880" y="4443984"/>
-            <a:ext cx="8348472" cy="365760"/>
+            <a:off x="3611880" y="4370832"/>
+            <a:ext cx="8348472" cy="301752"/>
           </a:xfrm>
           <a:prstGeom prst="rect">
             <a:avLst/>
@@ -16230,7 +16230,7 @@
         </p:nvSpPr>
         <p:spPr>
           <a:xfrm>
-            <a:off x="3410712" y="4946904"/>
+            <a:off x="3410712" y="4777740"/>
             <a:ext cx="91440" cy="91440"/>
           </a:xfrm>
           <a:prstGeom prst="ellipse">
@@ -16257,8 +16257,8 @@
         </p:nvSpPr>
         <p:spPr>
           <a:xfrm>
-            <a:off x="3611880" y="4809744"/>
-            <a:ext cx="8348472" cy="365760"/>
+            <a:off x="3611880" y="4672584"/>
+            <a:ext cx="8348472" cy="301752"/>
           </a:xfrm>
           <a:prstGeom prst="rect">
             <a:avLst/>
@@ -16298,7 +16298,7 @@
         </p:nvSpPr>
         <p:spPr>
           <a:xfrm>
-            <a:off x="3410712" y="5047488"/>
+            <a:off x="3410712" y="5120640"/>
             <a:ext cx="1188720" cy="256032"/>
           </a:xfrm>
           <a:prstGeom prst="rect">
@@ -16317,7 +16317,7 @@
               <a:buNone/>
             </a:pPr>
             <a:r>
-              <a:rPr lang="en-US" sz="1200" b="1" dirty="0">
+              <a:rPr lang="en-US" sz="1300" b="1" dirty="0">
                 <a:solidFill>
                   <a:srgbClr val="222222"/>
                 </a:solidFill>
@@ -16327,7 +16327,7 @@
               </a:rPr>
               <a:t>디자인 포인트</a:t>
             </a:r>
-            <a:endParaRPr lang="en-US" sz="1200" dirty="0"/>
+            <a:endParaRPr lang="en-US" sz="1300" dirty="0"/>
           </a:p>
         </p:txBody>
       </p:sp>
@@ -16339,8 +16339,8 @@
         </p:nvSpPr>
         <p:spPr>
           <a:xfrm>
-            <a:off x="3410712" y="5248656"/>
-            <a:ext cx="8549640" cy="411480"/>
+            <a:off x="3410712" y="5468112"/>
+            <a:ext cx="8549640" cy="484632"/>
           </a:xfrm>
           <a:prstGeom prst="rect">
             <a:avLst/>
@@ -16380,7 +16380,7 @@
         </p:nvSpPr>
         <p:spPr>
           <a:xfrm>
-            <a:off x="3410712" y="5486400"/>
+            <a:off x="3410712" y="6099048"/>
             <a:ext cx="8549640" cy="219456"/>
           </a:xfrm>
           <a:prstGeom prst="rect">
@@ -16399,7 +16399,7 @@
               <a:buNone/>
             </a:pPr>
             <a:r>
-              <a:rPr lang="en-US" sz="1050" b="1" dirty="0">
+              <a:rPr lang="en-US" sz="1300" b="1" dirty="0">
                 <a:solidFill>
                   <a:srgbClr val="222222"/>
                 </a:solidFill>
@@ -16409,7 +16409,7 @@
               </a:rPr>
               <a:t>의학·인지과학 근거</a:t>
             </a:r>
-            <a:endParaRPr lang="en-US" sz="1050" dirty="0"/>
+            <a:endParaRPr lang="en-US" sz="1300" dirty="0"/>
           </a:p>
         </p:txBody>
       </p:sp>
@@ -16421,8 +16421,8 @@
         </p:nvSpPr>
         <p:spPr>
           <a:xfrm>
-            <a:off x="3410712" y="5669280"/>
-            <a:ext cx="8549640" cy="749808"/>
+            <a:off x="3410712" y="6446520"/>
+            <a:ext cx="8549640" cy="457200"/>
           </a:xfrm>
           <a:prstGeom prst="rect">
             <a:avLst/>
@@ -16440,7 +16440,7 @@
               <a:buNone/>
             </a:pPr>
             <a:r>
-              <a:rPr lang="en-US" sz="940" dirty="0">
+              <a:rPr lang="en-US" sz="1020" dirty="0">
                 <a:solidFill>
                   <a:srgbClr val="6A6A6A"/>
                 </a:solidFill>
@@ -16450,7 +16450,7 @@
               </a:rPr>
               <a:t>근거축: 상담사 보고는 수행 이력·공유 기억·보호자 관찰 데이터를 합쳐 대화 설계를 지원하는 트렌드 신호를 제공합니다.</a:t>
             </a:r>
-            <a:endParaRPr lang="en-US" sz="940" dirty="0"/>
+            <a:endParaRPr lang="en-US" sz="1020" dirty="0"/>
           </a:p>
         </p:txBody>
       </p:sp>
@@ -16933,7 +16933,7 @@
         </p:nvSpPr>
         <p:spPr>
           <a:xfrm>
-            <a:off x="3410712" y="3849624"/>
+            <a:off x="3410712" y="3872484"/>
             <a:ext cx="91440" cy="91440"/>
           </a:xfrm>
           <a:prstGeom prst="ellipse">
@@ -16960,8 +16960,8 @@
         </p:nvSpPr>
         <p:spPr>
           <a:xfrm>
-            <a:off x="3611880" y="3712464"/>
-            <a:ext cx="8348472" cy="365760"/>
+            <a:off x="3611880" y="3767328"/>
+            <a:ext cx="8348472" cy="301752"/>
           </a:xfrm>
           <a:prstGeom prst="rect">
             <a:avLst/>
@@ -17001,7 +17001,7 @@
         </p:nvSpPr>
         <p:spPr>
           <a:xfrm>
-            <a:off x="3410712" y="4215384"/>
+            <a:off x="3410712" y="4174236"/>
             <a:ext cx="91440" cy="91440"/>
           </a:xfrm>
           <a:prstGeom prst="ellipse">
@@ -17028,8 +17028,8 @@
         </p:nvSpPr>
         <p:spPr>
           <a:xfrm>
-            <a:off x="3611880" y="4078224"/>
-            <a:ext cx="8348472" cy="365760"/>
+            <a:off x="3611880" y="4069080"/>
+            <a:ext cx="8348472" cy="301752"/>
           </a:xfrm>
           <a:prstGeom prst="rect">
             <a:avLst/>
@@ -17069,7 +17069,7 @@
         </p:nvSpPr>
         <p:spPr>
           <a:xfrm>
-            <a:off x="3410712" y="4581144"/>
+            <a:off x="3410712" y="4475988"/>
             <a:ext cx="91440" cy="91440"/>
           </a:xfrm>
           <a:prstGeom prst="ellipse">
@@ -17096,8 +17096,8 @@
         </p:nvSpPr>
         <p:spPr>
           <a:xfrm>
-            <a:off x="3611880" y="4443984"/>
-            <a:ext cx="8348472" cy="365760"/>
+            <a:off x="3611880" y="4370832"/>
+            <a:ext cx="8348472" cy="301752"/>
           </a:xfrm>
           <a:prstGeom prst="rect">
             <a:avLst/>
@@ -17137,7 +17137,7 @@
         </p:nvSpPr>
         <p:spPr>
           <a:xfrm>
-            <a:off x="3410712" y="4946904"/>
+            <a:off x="3410712" y="4777740"/>
             <a:ext cx="91440" cy="91440"/>
           </a:xfrm>
           <a:prstGeom prst="ellipse">
@@ -17164,8 +17164,8 @@
         </p:nvSpPr>
         <p:spPr>
           <a:xfrm>
-            <a:off x="3611880" y="4809744"/>
-            <a:ext cx="8348472" cy="365760"/>
+            <a:off x="3611880" y="4672584"/>
+            <a:ext cx="8348472" cy="301752"/>
           </a:xfrm>
           <a:prstGeom prst="rect">
             <a:avLst/>
@@ -17205,7 +17205,7 @@
         </p:nvSpPr>
         <p:spPr>
           <a:xfrm>
-            <a:off x="3410712" y="5047488"/>
+            <a:off x="3410712" y="5120640"/>
             <a:ext cx="1188720" cy="256032"/>
           </a:xfrm>
           <a:prstGeom prst="rect">
@@ -17224,7 +17224,7 @@
               <a:buNone/>
             </a:pPr>
             <a:r>
-              <a:rPr lang="en-US" sz="1200" b="1" dirty="0">
+              <a:rPr lang="en-US" sz="1300" b="1" dirty="0">
                 <a:solidFill>
                   <a:srgbClr val="222222"/>
                 </a:solidFill>
@@ -17234,7 +17234,7 @@
               </a:rPr>
               <a:t>디자인 포인트</a:t>
             </a:r>
-            <a:endParaRPr lang="en-US" sz="1200" dirty="0"/>
+            <a:endParaRPr lang="en-US" sz="1300" dirty="0"/>
           </a:p>
         </p:txBody>
       </p:sp>
@@ -17246,8 +17246,8 @@
         </p:nvSpPr>
         <p:spPr>
           <a:xfrm>
-            <a:off x="3410712" y="5248656"/>
-            <a:ext cx="8549640" cy="411480"/>
+            <a:off x="3410712" y="5468112"/>
+            <a:ext cx="8549640" cy="484632"/>
           </a:xfrm>
           <a:prstGeom prst="rect">
             <a:avLst/>
@@ -17287,7 +17287,7 @@
         </p:nvSpPr>
         <p:spPr>
           <a:xfrm>
-            <a:off x="3410712" y="5486400"/>
+            <a:off x="3410712" y="6099048"/>
             <a:ext cx="8549640" cy="219456"/>
           </a:xfrm>
           <a:prstGeom prst="rect">
@@ -17306,7 +17306,7 @@
               <a:buNone/>
             </a:pPr>
             <a:r>
-              <a:rPr lang="en-US" sz="1050" b="1" dirty="0">
+              <a:rPr lang="en-US" sz="1300" b="1" dirty="0">
                 <a:solidFill>
                   <a:srgbClr val="222222"/>
                 </a:solidFill>
@@ -17316,7 +17316,7 @@
               </a:rPr>
               <a:t>의학·인지과학 근거</a:t>
             </a:r>
-            <a:endParaRPr lang="en-US" sz="1050" dirty="0"/>
+            <a:endParaRPr lang="en-US" sz="1300" dirty="0"/>
           </a:p>
         </p:txBody>
       </p:sp>
@@ -17328,8 +17328,8 @@
         </p:nvSpPr>
         <p:spPr>
           <a:xfrm>
-            <a:off x="3410712" y="5669280"/>
-            <a:ext cx="8549640" cy="749808"/>
+            <a:off x="3410712" y="6446520"/>
+            <a:ext cx="8549640" cy="457200"/>
           </a:xfrm>
           <a:prstGeom prst="rect">
             <a:avLst/>
@@ -17347,7 +17347,7 @@
               <a:buNone/>
             </a:pPr>
             <a:r>
-              <a:rPr lang="en-US" sz="940" dirty="0">
+              <a:rPr lang="en-US" sz="1020" dirty="0">
                 <a:solidFill>
                   <a:srgbClr val="6A6A6A"/>
                 </a:solidFill>
@@ -17357,7 +17357,7 @@
               </a:rPr>
               <a:t>근거축: 보호자 보고는 AD8 (Galvin et al., 2005)와 GPCOG의 정보공유 철학을 참고해 일상 변화 요약만 공유 범위 내로 제시합니다.</a:t>
             </a:r>
-            <a:endParaRPr lang="en-US" sz="940" dirty="0"/>
+            <a:endParaRPr lang="en-US" sz="1020" dirty="0"/>
           </a:p>
         </p:txBody>
       </p:sp>
@@ -17840,7 +17840,7 @@
         </p:nvSpPr>
         <p:spPr>
           <a:xfrm>
-            <a:off x="3410712" y="3849624"/>
+            <a:off x="3410712" y="3872484"/>
             <a:ext cx="91440" cy="91440"/>
           </a:xfrm>
           <a:prstGeom prst="ellipse">
@@ -17867,8 +17867,8 @@
         </p:nvSpPr>
         <p:spPr>
           <a:xfrm>
-            <a:off x="3611880" y="3712464"/>
-            <a:ext cx="8348472" cy="365760"/>
+            <a:off x="3611880" y="3767328"/>
+            <a:ext cx="8348472" cy="301752"/>
           </a:xfrm>
           <a:prstGeom prst="rect">
             <a:avLst/>
@@ -17908,7 +17908,7 @@
         </p:nvSpPr>
         <p:spPr>
           <a:xfrm>
-            <a:off x="3410712" y="4215384"/>
+            <a:off x="3410712" y="4174236"/>
             <a:ext cx="91440" cy="91440"/>
           </a:xfrm>
           <a:prstGeom prst="ellipse">
@@ -17935,8 +17935,8 @@
         </p:nvSpPr>
         <p:spPr>
           <a:xfrm>
-            <a:off x="3611880" y="4078224"/>
-            <a:ext cx="8348472" cy="365760"/>
+            <a:off x="3611880" y="4069080"/>
+            <a:ext cx="8348472" cy="301752"/>
           </a:xfrm>
           <a:prstGeom prst="rect">
             <a:avLst/>
@@ -17976,7 +17976,7 @@
         </p:nvSpPr>
         <p:spPr>
           <a:xfrm>
-            <a:off x="3410712" y="4581144"/>
+            <a:off x="3410712" y="4475988"/>
             <a:ext cx="91440" cy="91440"/>
           </a:xfrm>
           <a:prstGeom prst="ellipse">
@@ -18003,8 +18003,8 @@
         </p:nvSpPr>
         <p:spPr>
           <a:xfrm>
-            <a:off x="3611880" y="4443984"/>
-            <a:ext cx="8348472" cy="365760"/>
+            <a:off x="3611880" y="4370832"/>
+            <a:ext cx="8348472" cy="301752"/>
           </a:xfrm>
           <a:prstGeom prst="rect">
             <a:avLst/>
@@ -18044,7 +18044,7 @@
         </p:nvSpPr>
         <p:spPr>
           <a:xfrm>
-            <a:off x="3410712" y="4946904"/>
+            <a:off x="3410712" y="4777740"/>
             <a:ext cx="91440" cy="91440"/>
           </a:xfrm>
           <a:prstGeom prst="ellipse">
@@ -18071,8 +18071,8 @@
         </p:nvSpPr>
         <p:spPr>
           <a:xfrm>
-            <a:off x="3611880" y="4809744"/>
-            <a:ext cx="8348472" cy="365760"/>
+            <a:off x="3611880" y="4672584"/>
+            <a:ext cx="8348472" cy="301752"/>
           </a:xfrm>
           <a:prstGeom prst="rect">
             <a:avLst/>
@@ -18112,7 +18112,7 @@
         </p:nvSpPr>
         <p:spPr>
           <a:xfrm>
-            <a:off x="3410712" y="5047488"/>
+            <a:off x="3410712" y="5120640"/>
             <a:ext cx="1188720" cy="256032"/>
           </a:xfrm>
           <a:prstGeom prst="rect">
@@ -18131,7 +18131,7 @@
               <a:buNone/>
             </a:pPr>
             <a:r>
-              <a:rPr lang="en-US" sz="1200" b="1" dirty="0">
+              <a:rPr lang="en-US" sz="1300" b="1" dirty="0">
                 <a:solidFill>
                   <a:srgbClr val="222222"/>
                 </a:solidFill>
@@ -18141,7 +18141,7 @@
               </a:rPr>
               <a:t>디자인 포인트</a:t>
             </a:r>
-            <a:endParaRPr lang="en-US" sz="1200" dirty="0"/>
+            <a:endParaRPr lang="en-US" sz="1300" dirty="0"/>
           </a:p>
         </p:txBody>
       </p:sp>
@@ -18153,8 +18153,8 @@
         </p:nvSpPr>
         <p:spPr>
           <a:xfrm>
-            <a:off x="3410712" y="5248656"/>
-            <a:ext cx="8549640" cy="411480"/>
+            <a:off x="3410712" y="5468112"/>
+            <a:ext cx="8549640" cy="484632"/>
           </a:xfrm>
           <a:prstGeom prst="rect">
             <a:avLst/>
@@ -18194,7 +18194,7 @@
         </p:nvSpPr>
         <p:spPr>
           <a:xfrm>
-            <a:off x="3410712" y="5486400"/>
+            <a:off x="3410712" y="6099048"/>
             <a:ext cx="8549640" cy="219456"/>
           </a:xfrm>
           <a:prstGeom prst="rect">
@@ -18213,7 +18213,7 @@
               <a:buNone/>
             </a:pPr>
             <a:r>
-              <a:rPr lang="en-US" sz="1050" b="1" dirty="0">
+              <a:rPr lang="en-US" sz="1300" b="1" dirty="0">
                 <a:solidFill>
                   <a:srgbClr val="222222"/>
                 </a:solidFill>
@@ -18223,7 +18223,7 @@
               </a:rPr>
               <a:t>의학·인지과학 근거</a:t>
             </a:r>
-            <a:endParaRPr lang="en-US" sz="1050" dirty="0"/>
+            <a:endParaRPr lang="en-US" sz="1300" dirty="0"/>
           </a:p>
         </p:txBody>
       </p:sp>
@@ -18235,8 +18235,8 @@
         </p:nvSpPr>
         <p:spPr>
           <a:xfrm>
-            <a:off x="3410712" y="5669280"/>
-            <a:ext cx="8549640" cy="749808"/>
+            <a:off x="3410712" y="6446520"/>
+            <a:ext cx="8549640" cy="457200"/>
           </a:xfrm>
           <a:prstGeom prst="rect">
             <a:avLst/>
@@ -18254,7 +18254,7 @@
               <a:buNone/>
             </a:pPr>
             <a:r>
-              <a:rPr lang="en-US" sz="940" dirty="0">
+              <a:rPr lang="en-US" sz="1020" dirty="0">
                 <a:solidFill>
                   <a:srgbClr val="6A6A6A"/>
                 </a:solidFill>
@@ -18264,7 +18264,7 @@
               </a:rPr>
               <a:t>근거축: 데이터 삭제 및 공유 제어는 W3C WAI 접근성/개인정보보호 원칙 기반으로 사용자의 동의와 제어권을 우선 보장합니다.</a:t>
             </a:r>
-            <a:endParaRPr lang="en-US" sz="940" dirty="0"/>
+            <a:endParaRPr lang="en-US" sz="1020" dirty="0"/>
           </a:p>
         </p:txBody>
       </p:sp>
@@ -18747,7 +18747,7 @@
         </p:nvSpPr>
         <p:spPr>
           <a:xfrm>
-            <a:off x="3410712" y="3849624"/>
+            <a:off x="3410712" y="3872484"/>
             <a:ext cx="91440" cy="91440"/>
           </a:xfrm>
           <a:prstGeom prst="ellipse">
@@ -18774,8 +18774,8 @@
         </p:nvSpPr>
         <p:spPr>
           <a:xfrm>
-            <a:off x="3611880" y="3712464"/>
-            <a:ext cx="8348472" cy="365760"/>
+            <a:off x="3611880" y="3767328"/>
+            <a:ext cx="8348472" cy="301752"/>
           </a:xfrm>
           <a:prstGeom prst="rect">
             <a:avLst/>
@@ -18815,7 +18815,7 @@
         </p:nvSpPr>
         <p:spPr>
           <a:xfrm>
-            <a:off x="3410712" y="4215384"/>
+            <a:off x="3410712" y="4174236"/>
             <a:ext cx="91440" cy="91440"/>
           </a:xfrm>
           <a:prstGeom prst="ellipse">
@@ -18842,8 +18842,8 @@
         </p:nvSpPr>
         <p:spPr>
           <a:xfrm>
-            <a:off x="3611880" y="4078224"/>
-            <a:ext cx="8348472" cy="365760"/>
+            <a:off x="3611880" y="4069080"/>
+            <a:ext cx="8348472" cy="301752"/>
           </a:xfrm>
           <a:prstGeom prst="rect">
             <a:avLst/>
@@ -18883,7 +18883,7 @@
         </p:nvSpPr>
         <p:spPr>
           <a:xfrm>
-            <a:off x="3410712" y="4581144"/>
+            <a:off x="3410712" y="4475988"/>
             <a:ext cx="91440" cy="91440"/>
           </a:xfrm>
           <a:prstGeom prst="ellipse">
@@ -18910,8 +18910,8 @@
         </p:nvSpPr>
         <p:spPr>
           <a:xfrm>
-            <a:off x="3611880" y="4443984"/>
-            <a:ext cx="8348472" cy="365760"/>
+            <a:off x="3611880" y="4370832"/>
+            <a:ext cx="8348472" cy="301752"/>
           </a:xfrm>
           <a:prstGeom prst="rect">
             <a:avLst/>
@@ -18951,7 +18951,7 @@
         </p:nvSpPr>
         <p:spPr>
           <a:xfrm>
-            <a:off x="3410712" y="4946904"/>
+            <a:off x="3410712" y="4777740"/>
             <a:ext cx="91440" cy="91440"/>
           </a:xfrm>
           <a:prstGeom prst="ellipse">
@@ -18978,8 +18978,8 @@
         </p:nvSpPr>
         <p:spPr>
           <a:xfrm>
-            <a:off x="3611880" y="4809744"/>
-            <a:ext cx="8348472" cy="365760"/>
+            <a:off x="3611880" y="4672584"/>
+            <a:ext cx="8348472" cy="301752"/>
           </a:xfrm>
           <a:prstGeom prst="rect">
             <a:avLst/>
@@ -19019,7 +19019,7 @@
         </p:nvSpPr>
         <p:spPr>
           <a:xfrm>
-            <a:off x="3410712" y="5047488"/>
+            <a:off x="3410712" y="5120640"/>
             <a:ext cx="1188720" cy="256032"/>
           </a:xfrm>
           <a:prstGeom prst="rect">
@@ -19038,7 +19038,7 @@
               <a:buNone/>
             </a:pPr>
             <a:r>
-              <a:rPr lang="en-US" sz="1200" b="1" dirty="0">
+              <a:rPr lang="en-US" sz="1300" b="1" dirty="0">
                 <a:solidFill>
                   <a:srgbClr val="222222"/>
                 </a:solidFill>
@@ -19048,7 +19048,7 @@
               </a:rPr>
               <a:t>디자인 포인트</a:t>
             </a:r>
-            <a:endParaRPr lang="en-US" sz="1200" dirty="0"/>
+            <a:endParaRPr lang="en-US" sz="1300" dirty="0"/>
           </a:p>
         </p:txBody>
       </p:sp>
@@ -19060,8 +19060,8 @@
         </p:nvSpPr>
         <p:spPr>
           <a:xfrm>
-            <a:off x="3410712" y="5248656"/>
-            <a:ext cx="8549640" cy="411480"/>
+            <a:off x="3410712" y="5468112"/>
+            <a:ext cx="8549640" cy="484632"/>
           </a:xfrm>
           <a:prstGeom prst="rect">
             <a:avLst/>
@@ -19101,7 +19101,7 @@
         </p:nvSpPr>
         <p:spPr>
           <a:xfrm>
-            <a:off x="3410712" y="5486400"/>
+            <a:off x="3410712" y="6099048"/>
             <a:ext cx="8549640" cy="219456"/>
           </a:xfrm>
           <a:prstGeom prst="rect">
@@ -19120,7 +19120,7 @@
               <a:buNone/>
             </a:pPr>
             <a:r>
-              <a:rPr lang="en-US" sz="1050" b="1" dirty="0">
+              <a:rPr lang="en-US" sz="1300" b="1" dirty="0">
                 <a:solidFill>
                   <a:srgbClr val="222222"/>
                 </a:solidFill>
@@ -19130,7 +19130,7 @@
               </a:rPr>
               <a:t>의학·인지과학 근거</a:t>
             </a:r>
-            <a:endParaRPr lang="en-US" sz="1050" dirty="0"/>
+            <a:endParaRPr lang="en-US" sz="1300" dirty="0"/>
           </a:p>
         </p:txBody>
       </p:sp>
@@ -19142,8 +19142,8 @@
         </p:nvSpPr>
         <p:spPr>
           <a:xfrm>
-            <a:off x="3410712" y="5669280"/>
-            <a:ext cx="8549640" cy="749808"/>
+            <a:off x="3410712" y="6446520"/>
+            <a:ext cx="8549640" cy="457200"/>
           </a:xfrm>
           <a:prstGeom prst="rect">
             <a:avLst/>
@@ -19161,7 +19161,7 @@
               <a:buNone/>
             </a:pPr>
             <a:r>
-              <a:rPr lang="en-US" sz="940" dirty="0">
+              <a:rPr lang="en-US" sz="1020" dirty="0">
                 <a:solidFill>
                   <a:srgbClr val="6A6A6A"/>
                 </a:solidFill>
@@ -19171,7 +19171,7 @@
               </a:rPr>
               <a:t>근거축: 범주 단서 기반 지연회상은 Dubois et al. (2002) 5-Word Test의 인코딩-지연-재인 구조를 Haru화한 형태입니다(진단 점수화는 별도 수행 안함).</a:t>
             </a:r>
-            <a:endParaRPr lang="en-US" sz="940" dirty="0"/>
+            <a:endParaRPr lang="en-US" sz="1020" dirty="0"/>
           </a:p>
         </p:txBody>
       </p:sp>
@@ -19654,7 +19654,7 @@
         </p:nvSpPr>
         <p:spPr>
           <a:xfrm>
-            <a:off x="3410712" y="3849624"/>
+            <a:off x="3410712" y="3872484"/>
             <a:ext cx="91440" cy="91440"/>
           </a:xfrm>
           <a:prstGeom prst="ellipse">
@@ -19681,8 +19681,8 @@
         </p:nvSpPr>
         <p:spPr>
           <a:xfrm>
-            <a:off x="3611880" y="3712464"/>
-            <a:ext cx="8348472" cy="365760"/>
+            <a:off x="3611880" y="3767328"/>
+            <a:ext cx="8348472" cy="301752"/>
           </a:xfrm>
           <a:prstGeom prst="rect">
             <a:avLst/>
@@ -19722,7 +19722,7 @@
         </p:nvSpPr>
         <p:spPr>
           <a:xfrm>
-            <a:off x="3410712" y="4215384"/>
+            <a:off x="3410712" y="4174236"/>
             <a:ext cx="91440" cy="91440"/>
           </a:xfrm>
           <a:prstGeom prst="ellipse">
@@ -19749,8 +19749,8 @@
         </p:nvSpPr>
         <p:spPr>
           <a:xfrm>
-            <a:off x="3611880" y="4078224"/>
-            <a:ext cx="8348472" cy="365760"/>
+            <a:off x="3611880" y="4069080"/>
+            <a:ext cx="8348472" cy="301752"/>
           </a:xfrm>
           <a:prstGeom prst="rect">
             <a:avLst/>
@@ -19790,7 +19790,7 @@
         </p:nvSpPr>
         <p:spPr>
           <a:xfrm>
-            <a:off x="3410712" y="4581144"/>
+            <a:off x="3410712" y="4475988"/>
             <a:ext cx="91440" cy="91440"/>
           </a:xfrm>
           <a:prstGeom prst="ellipse">
@@ -19817,8 +19817,8 @@
         </p:nvSpPr>
         <p:spPr>
           <a:xfrm>
-            <a:off x="3611880" y="4443984"/>
-            <a:ext cx="8348472" cy="365760"/>
+            <a:off x="3611880" y="4370832"/>
+            <a:ext cx="8348472" cy="301752"/>
           </a:xfrm>
           <a:prstGeom prst="rect">
             <a:avLst/>
@@ -19858,7 +19858,7 @@
         </p:nvSpPr>
         <p:spPr>
           <a:xfrm>
-            <a:off x="3410712" y="4946904"/>
+            <a:off x="3410712" y="4777740"/>
             <a:ext cx="91440" cy="91440"/>
           </a:xfrm>
           <a:prstGeom prst="ellipse">
@@ -19885,8 +19885,8 @@
         </p:nvSpPr>
         <p:spPr>
           <a:xfrm>
-            <a:off x="3611880" y="4809744"/>
-            <a:ext cx="8348472" cy="365760"/>
+            <a:off x="3611880" y="4672584"/>
+            <a:ext cx="8348472" cy="301752"/>
           </a:xfrm>
           <a:prstGeom prst="rect">
             <a:avLst/>
@@ -19926,7 +19926,7 @@
         </p:nvSpPr>
         <p:spPr>
           <a:xfrm>
-            <a:off x="3410712" y="5047488"/>
+            <a:off x="3410712" y="5120640"/>
             <a:ext cx="1188720" cy="256032"/>
           </a:xfrm>
           <a:prstGeom prst="rect">
@@ -19945,7 +19945,7 @@
               <a:buNone/>
             </a:pPr>
             <a:r>
-              <a:rPr lang="en-US" sz="1200" b="1" dirty="0">
+              <a:rPr lang="en-US" sz="1300" b="1" dirty="0">
                 <a:solidFill>
                   <a:srgbClr val="222222"/>
                 </a:solidFill>
@@ -19955,7 +19955,7 @@
               </a:rPr>
               <a:t>디자인 포인트</a:t>
             </a:r>
-            <a:endParaRPr lang="en-US" sz="1200" dirty="0"/>
+            <a:endParaRPr lang="en-US" sz="1300" dirty="0"/>
           </a:p>
         </p:txBody>
       </p:sp>
@@ -19967,8 +19967,8 @@
         </p:nvSpPr>
         <p:spPr>
           <a:xfrm>
-            <a:off x="3410712" y="5248656"/>
-            <a:ext cx="8549640" cy="411480"/>
+            <a:off x="3410712" y="5468112"/>
+            <a:ext cx="8549640" cy="484632"/>
           </a:xfrm>
           <a:prstGeom prst="rect">
             <a:avLst/>
@@ -20008,7 +20008,7 @@
         </p:nvSpPr>
         <p:spPr>
           <a:xfrm>
-            <a:off x="3410712" y="5486400"/>
+            <a:off x="3410712" y="6099048"/>
             <a:ext cx="8549640" cy="219456"/>
           </a:xfrm>
           <a:prstGeom prst="rect">
@@ -20027,7 +20027,7 @@
               <a:buNone/>
             </a:pPr>
             <a:r>
-              <a:rPr lang="en-US" sz="1050" b="1" dirty="0">
+              <a:rPr lang="en-US" sz="1300" b="1" dirty="0">
                 <a:solidFill>
                   <a:srgbClr val="222222"/>
                 </a:solidFill>
@@ -20037,7 +20037,7 @@
               </a:rPr>
               <a:t>의학·인지과학 근거</a:t>
             </a:r>
-            <a:endParaRPr lang="en-US" sz="1050" dirty="0"/>
+            <a:endParaRPr lang="en-US" sz="1300" dirty="0"/>
           </a:p>
         </p:txBody>
       </p:sp>
@@ -20049,8 +20049,8 @@
         </p:nvSpPr>
         <p:spPr>
           <a:xfrm>
-            <a:off x="3410712" y="5669280"/>
-            <a:ext cx="8549640" cy="749808"/>
+            <a:off x="3410712" y="6446520"/>
+            <a:ext cx="8549640" cy="457200"/>
           </a:xfrm>
           <a:prstGeom prst="rect">
             <a:avLst/>
@@ -20068,7 +20068,7 @@
               <a:buNone/>
             </a:pPr>
             <a:r>
-              <a:rPr lang="en-US" sz="940" dirty="0">
+              <a:rPr lang="en-US" sz="1020" dirty="0">
                 <a:solidFill>
                   <a:srgbClr val="6A6A6A"/>
                 </a:solidFill>
@@ -20078,7 +20078,7 @@
               </a:rPr>
               <a:t>근거축: 의미적 선택은 semantic fluency 계열의 범주 단서 전략에서 착안해 언어 반응의 전환 비용을 완화하도록 구성했습니다.</a:t>
             </a:r>
-            <a:endParaRPr lang="en-US" sz="940" dirty="0"/>
+            <a:endParaRPr lang="en-US" sz="1020" dirty="0"/>
           </a:p>
         </p:txBody>
       </p:sp>
@@ -20561,7 +20561,7 @@
         </p:nvSpPr>
         <p:spPr>
           <a:xfrm>
-            <a:off x="3410712" y="3849624"/>
+            <a:off x="3410712" y="3872484"/>
             <a:ext cx="91440" cy="91440"/>
           </a:xfrm>
           <a:prstGeom prst="ellipse">
@@ -20588,8 +20588,8 @@
         </p:nvSpPr>
         <p:spPr>
           <a:xfrm>
-            <a:off x="3611880" y="3712464"/>
-            <a:ext cx="8348472" cy="365760"/>
+            <a:off x="3611880" y="3767328"/>
+            <a:ext cx="8348472" cy="301752"/>
           </a:xfrm>
           <a:prstGeom prst="rect">
             <a:avLst/>
@@ -20629,7 +20629,7 @@
         </p:nvSpPr>
         <p:spPr>
           <a:xfrm>
-            <a:off x="3410712" y="4215384"/>
+            <a:off x="3410712" y="4174236"/>
             <a:ext cx="91440" cy="91440"/>
           </a:xfrm>
           <a:prstGeom prst="ellipse">
@@ -20656,8 +20656,8 @@
         </p:nvSpPr>
         <p:spPr>
           <a:xfrm>
-            <a:off x="3611880" y="4078224"/>
-            <a:ext cx="8348472" cy="365760"/>
+            <a:off x="3611880" y="4069080"/>
+            <a:ext cx="8348472" cy="301752"/>
           </a:xfrm>
           <a:prstGeom prst="rect">
             <a:avLst/>
@@ -20697,7 +20697,7 @@
         </p:nvSpPr>
         <p:spPr>
           <a:xfrm>
-            <a:off x="3410712" y="4581144"/>
+            <a:off x="3410712" y="4475988"/>
             <a:ext cx="91440" cy="91440"/>
           </a:xfrm>
           <a:prstGeom prst="ellipse">
@@ -20724,8 +20724,8 @@
         </p:nvSpPr>
         <p:spPr>
           <a:xfrm>
-            <a:off x="3611880" y="4443984"/>
-            <a:ext cx="8348472" cy="365760"/>
+            <a:off x="3611880" y="4370832"/>
+            <a:ext cx="8348472" cy="301752"/>
           </a:xfrm>
           <a:prstGeom prst="rect">
             <a:avLst/>
@@ -20765,7 +20765,7 @@
         </p:nvSpPr>
         <p:spPr>
           <a:xfrm>
-            <a:off x="3410712" y="4946904"/>
+            <a:off x="3410712" y="4777740"/>
             <a:ext cx="91440" cy="91440"/>
           </a:xfrm>
           <a:prstGeom prst="ellipse">
@@ -20792,8 +20792,8 @@
         </p:nvSpPr>
         <p:spPr>
           <a:xfrm>
-            <a:off x="3611880" y="4809744"/>
-            <a:ext cx="8348472" cy="365760"/>
+            <a:off x="3611880" y="4672584"/>
+            <a:ext cx="8348472" cy="301752"/>
           </a:xfrm>
           <a:prstGeom prst="rect">
             <a:avLst/>
@@ -20833,7 +20833,7 @@
         </p:nvSpPr>
         <p:spPr>
           <a:xfrm>
-            <a:off x="3410712" y="5047488"/>
+            <a:off x="3410712" y="5120640"/>
             <a:ext cx="1188720" cy="256032"/>
           </a:xfrm>
           <a:prstGeom prst="rect">
@@ -20852,7 +20852,7 @@
               <a:buNone/>
             </a:pPr>
             <a:r>
-              <a:rPr lang="en-US" sz="1200" b="1" dirty="0">
+              <a:rPr lang="en-US" sz="1300" b="1" dirty="0">
                 <a:solidFill>
                   <a:srgbClr val="222222"/>
                 </a:solidFill>
@@ -20862,7 +20862,7 @@
               </a:rPr>
               <a:t>디자인 포인트</a:t>
             </a:r>
-            <a:endParaRPr lang="en-US" sz="1200" dirty="0"/>
+            <a:endParaRPr lang="en-US" sz="1300" dirty="0"/>
           </a:p>
         </p:txBody>
       </p:sp>
@@ -20874,8 +20874,8 @@
         </p:nvSpPr>
         <p:spPr>
           <a:xfrm>
-            <a:off x="3410712" y="5248656"/>
-            <a:ext cx="8549640" cy="411480"/>
+            <a:off x="3410712" y="5468112"/>
+            <a:ext cx="8549640" cy="484632"/>
           </a:xfrm>
           <a:prstGeom prst="rect">
             <a:avLst/>
@@ -20915,7 +20915,7 @@
         </p:nvSpPr>
         <p:spPr>
           <a:xfrm>
-            <a:off x="3410712" y="5486400"/>
+            <a:off x="3410712" y="6099048"/>
             <a:ext cx="8549640" cy="219456"/>
           </a:xfrm>
           <a:prstGeom prst="rect">
@@ -20934,7 +20934,7 @@
               <a:buNone/>
             </a:pPr>
             <a:r>
-              <a:rPr lang="en-US" sz="1050" b="1" dirty="0">
+              <a:rPr lang="en-US" sz="1300" b="1" dirty="0">
                 <a:solidFill>
                   <a:srgbClr val="222222"/>
                 </a:solidFill>
@@ -20944,7 +20944,7 @@
               </a:rPr>
               <a:t>의학·인지과학 근거</a:t>
             </a:r>
-            <a:endParaRPr lang="en-US" sz="1050" dirty="0"/>
+            <a:endParaRPr lang="en-US" sz="1300" dirty="0"/>
           </a:p>
         </p:txBody>
       </p:sp>
@@ -20956,8 +20956,8 @@
         </p:nvSpPr>
         <p:spPr>
           <a:xfrm>
-            <a:off x="3410712" y="5669280"/>
-            <a:ext cx="8549640" cy="749808"/>
+            <a:off x="3410712" y="6446520"/>
+            <a:ext cx="8549640" cy="457200"/>
           </a:xfrm>
           <a:prstGeom prst="rect">
             <a:avLst/>
@@ -20975,7 +20975,7 @@
               <a:buNone/>
             </a:pPr>
             <a:r>
-              <a:rPr lang="en-US" sz="940" dirty="0">
+              <a:rPr lang="en-US" sz="1020" dirty="0">
                 <a:solidFill>
                   <a:srgbClr val="6A6A6A"/>
                 </a:solidFill>
@@ -20985,7 +20985,7 @@
               </a:rPr>
               <a:t>근거축: 상황 이해형 판단은 GPCOG(Brodaty et al., 2002) 정보제공자 맥락의 접근을 루틴형으로 경량 적용했습니다.</a:t>
             </a:r>
-            <a:endParaRPr lang="en-US" sz="940" dirty="0"/>
+            <a:endParaRPr lang="en-US" sz="1020" dirty="0"/>
           </a:p>
         </p:txBody>
       </p:sp>
@@ -21468,7 +21468,7 @@
         </p:nvSpPr>
         <p:spPr>
           <a:xfrm>
-            <a:off x="3410712" y="3849624"/>
+            <a:off x="3410712" y="3872484"/>
             <a:ext cx="91440" cy="91440"/>
           </a:xfrm>
           <a:prstGeom prst="ellipse">
@@ -21495,8 +21495,8 @@
         </p:nvSpPr>
         <p:spPr>
           <a:xfrm>
-            <a:off x="3611880" y="3712464"/>
-            <a:ext cx="8348472" cy="365760"/>
+            <a:off x="3611880" y="3767328"/>
+            <a:ext cx="8348472" cy="301752"/>
           </a:xfrm>
           <a:prstGeom prst="rect">
             <a:avLst/>
@@ -21536,7 +21536,7 @@
         </p:nvSpPr>
         <p:spPr>
           <a:xfrm>
-            <a:off x="3410712" y="4215384"/>
+            <a:off x="3410712" y="4174236"/>
             <a:ext cx="91440" cy="91440"/>
           </a:xfrm>
           <a:prstGeom prst="ellipse">
@@ -21563,8 +21563,8 @@
         </p:nvSpPr>
         <p:spPr>
           <a:xfrm>
-            <a:off x="3611880" y="4078224"/>
-            <a:ext cx="8348472" cy="365760"/>
+            <a:off x="3611880" y="4069080"/>
+            <a:ext cx="8348472" cy="301752"/>
           </a:xfrm>
           <a:prstGeom prst="rect">
             <a:avLst/>
@@ -21604,7 +21604,7 @@
         </p:nvSpPr>
         <p:spPr>
           <a:xfrm>
-            <a:off x="3410712" y="4581144"/>
+            <a:off x="3410712" y="4475988"/>
             <a:ext cx="91440" cy="91440"/>
           </a:xfrm>
           <a:prstGeom prst="ellipse">
@@ -21631,8 +21631,8 @@
         </p:nvSpPr>
         <p:spPr>
           <a:xfrm>
-            <a:off x="3611880" y="4443984"/>
-            <a:ext cx="8348472" cy="365760"/>
+            <a:off x="3611880" y="4370832"/>
+            <a:ext cx="8348472" cy="301752"/>
           </a:xfrm>
           <a:prstGeom prst="rect">
             <a:avLst/>
@@ -21672,7 +21672,7 @@
         </p:nvSpPr>
         <p:spPr>
           <a:xfrm>
-            <a:off x="3410712" y="4946904"/>
+            <a:off x="3410712" y="4777740"/>
             <a:ext cx="91440" cy="91440"/>
           </a:xfrm>
           <a:prstGeom prst="ellipse">
@@ -21699,8 +21699,8 @@
         </p:nvSpPr>
         <p:spPr>
           <a:xfrm>
-            <a:off x="3611880" y="4809744"/>
-            <a:ext cx="8348472" cy="365760"/>
+            <a:off x="3611880" y="4672584"/>
+            <a:ext cx="8348472" cy="301752"/>
           </a:xfrm>
           <a:prstGeom prst="rect">
             <a:avLst/>
@@ -21740,7 +21740,7 @@
         </p:nvSpPr>
         <p:spPr>
           <a:xfrm>
-            <a:off x="3410712" y="5047488"/>
+            <a:off x="3410712" y="5120640"/>
             <a:ext cx="1188720" cy="256032"/>
           </a:xfrm>
           <a:prstGeom prst="rect">
@@ -21759,7 +21759,7 @@
               <a:buNone/>
             </a:pPr>
             <a:r>
-              <a:rPr lang="en-US" sz="1200" b="1" dirty="0">
+              <a:rPr lang="en-US" sz="1300" b="1" dirty="0">
                 <a:solidFill>
                   <a:srgbClr val="222222"/>
                 </a:solidFill>
@@ -21769,7 +21769,7 @@
               </a:rPr>
               <a:t>디자인 포인트</a:t>
             </a:r>
-            <a:endParaRPr lang="en-US" sz="1200" dirty="0"/>
+            <a:endParaRPr lang="en-US" sz="1300" dirty="0"/>
           </a:p>
         </p:txBody>
       </p:sp>
@@ -21781,8 +21781,8 @@
         </p:nvSpPr>
         <p:spPr>
           <a:xfrm>
-            <a:off x="3410712" y="5248656"/>
-            <a:ext cx="8549640" cy="411480"/>
+            <a:off x="3410712" y="5468112"/>
+            <a:ext cx="8549640" cy="484632"/>
           </a:xfrm>
           <a:prstGeom prst="rect">
             <a:avLst/>
@@ -21822,7 +21822,7 @@
         </p:nvSpPr>
         <p:spPr>
           <a:xfrm>
-            <a:off x="3410712" y="5486400"/>
+            <a:off x="3410712" y="6099048"/>
             <a:ext cx="8549640" cy="219456"/>
           </a:xfrm>
           <a:prstGeom prst="rect">
@@ -21841,7 +21841,7 @@
               <a:buNone/>
             </a:pPr>
             <a:r>
-              <a:rPr lang="en-US" sz="1050" b="1" dirty="0">
+              <a:rPr lang="en-US" sz="1300" b="1" dirty="0">
                 <a:solidFill>
                   <a:srgbClr val="222222"/>
                 </a:solidFill>
@@ -21851,7 +21851,7 @@
               </a:rPr>
               <a:t>의학·인지과학 근거</a:t>
             </a:r>
-            <a:endParaRPr lang="en-US" sz="1050" dirty="0"/>
+            <a:endParaRPr lang="en-US" sz="1300" dirty="0"/>
           </a:p>
         </p:txBody>
       </p:sp>
@@ -21863,8 +21863,8 @@
         </p:nvSpPr>
         <p:spPr>
           <a:xfrm>
-            <a:off x="3410712" y="5669280"/>
-            <a:ext cx="8549640" cy="749808"/>
+            <a:off x="3410712" y="6446520"/>
+            <a:ext cx="8549640" cy="457200"/>
           </a:xfrm>
           <a:prstGeom prst="rect">
             <a:avLst/>
@@ -21882,7 +21882,7 @@
               <a:buNone/>
             </a:pPr>
             <a:r>
-              <a:rPr lang="en-US" sz="940" dirty="0">
+              <a:rPr lang="en-US" sz="1020" dirty="0">
                 <a:solidFill>
                   <a:srgbClr val="6A6A6A"/>
                 </a:solidFill>
@@ -21892,7 +21892,7 @@
               </a:rPr>
               <a:t>근거축: 저부하 수열-패턴 과제는 Digit Span/주의조절의 기본 원리를 참고해 반응 패턴을 장기 지표로 누적합니다.</a:t>
             </a:r>
-            <a:endParaRPr lang="en-US" sz="940" dirty="0"/>
+            <a:endParaRPr lang="en-US" sz="1020" dirty="0"/>
           </a:p>
         </p:txBody>
       </p:sp>
@@ -22375,7 +22375,7 @@
         </p:nvSpPr>
         <p:spPr>
           <a:xfrm>
-            <a:off x="3410712" y="3849624"/>
+            <a:off x="3410712" y="3872484"/>
             <a:ext cx="91440" cy="91440"/>
           </a:xfrm>
           <a:prstGeom prst="ellipse">
@@ -22402,8 +22402,8 @@
         </p:nvSpPr>
         <p:spPr>
           <a:xfrm>
-            <a:off x="3611880" y="3712464"/>
-            <a:ext cx="8348472" cy="365760"/>
+            <a:off x="3611880" y="3767328"/>
+            <a:ext cx="8348472" cy="301752"/>
           </a:xfrm>
           <a:prstGeom prst="rect">
             <a:avLst/>
@@ -22443,7 +22443,7 @@
         </p:nvSpPr>
         <p:spPr>
           <a:xfrm>
-            <a:off x="3410712" y="4215384"/>
+            <a:off x="3410712" y="4174236"/>
             <a:ext cx="91440" cy="91440"/>
           </a:xfrm>
           <a:prstGeom prst="ellipse">
@@ -22470,8 +22470,8 @@
         </p:nvSpPr>
         <p:spPr>
           <a:xfrm>
-            <a:off x="3611880" y="4078224"/>
-            <a:ext cx="8348472" cy="365760"/>
+            <a:off x="3611880" y="4069080"/>
+            <a:ext cx="8348472" cy="301752"/>
           </a:xfrm>
           <a:prstGeom prst="rect">
             <a:avLst/>
@@ -22511,7 +22511,7 @@
         </p:nvSpPr>
         <p:spPr>
           <a:xfrm>
-            <a:off x="3410712" y="4581144"/>
+            <a:off x="3410712" y="4475988"/>
             <a:ext cx="91440" cy="91440"/>
           </a:xfrm>
           <a:prstGeom prst="ellipse">
@@ -22538,8 +22538,8 @@
         </p:nvSpPr>
         <p:spPr>
           <a:xfrm>
-            <a:off x="3611880" y="4443984"/>
-            <a:ext cx="8348472" cy="365760"/>
+            <a:off x="3611880" y="4370832"/>
+            <a:ext cx="8348472" cy="301752"/>
           </a:xfrm>
           <a:prstGeom prst="rect">
             <a:avLst/>
@@ -22579,7 +22579,7 @@
         </p:nvSpPr>
         <p:spPr>
           <a:xfrm>
-            <a:off x="3410712" y="4946904"/>
+            <a:off x="3410712" y="4777740"/>
             <a:ext cx="91440" cy="91440"/>
           </a:xfrm>
           <a:prstGeom prst="ellipse">
@@ -22606,8 +22606,8 @@
         </p:nvSpPr>
         <p:spPr>
           <a:xfrm>
-            <a:off x="3611880" y="4809744"/>
-            <a:ext cx="8348472" cy="365760"/>
+            <a:off x="3611880" y="4672584"/>
+            <a:ext cx="8348472" cy="301752"/>
           </a:xfrm>
           <a:prstGeom prst="rect">
             <a:avLst/>
@@ -22647,7 +22647,7 @@
         </p:nvSpPr>
         <p:spPr>
           <a:xfrm>
-            <a:off x="3410712" y="5047488"/>
+            <a:off x="3410712" y="5120640"/>
             <a:ext cx="1188720" cy="256032"/>
           </a:xfrm>
           <a:prstGeom prst="rect">
@@ -22666,7 +22666,7 @@
               <a:buNone/>
             </a:pPr>
             <a:r>
-              <a:rPr lang="en-US" sz="1200" b="1" dirty="0">
+              <a:rPr lang="en-US" sz="1300" b="1" dirty="0">
                 <a:solidFill>
                   <a:srgbClr val="222222"/>
                 </a:solidFill>
@@ -22676,7 +22676,7 @@
               </a:rPr>
               <a:t>디자인 포인트</a:t>
             </a:r>
-            <a:endParaRPr lang="en-US" sz="1200" dirty="0"/>
+            <a:endParaRPr lang="en-US" sz="1300" dirty="0"/>
           </a:p>
         </p:txBody>
       </p:sp>
@@ -22688,8 +22688,8 @@
         </p:nvSpPr>
         <p:spPr>
           <a:xfrm>
-            <a:off x="3410712" y="5248656"/>
-            <a:ext cx="8549640" cy="411480"/>
+            <a:off x="3410712" y="5468112"/>
+            <a:ext cx="8549640" cy="484632"/>
           </a:xfrm>
           <a:prstGeom prst="rect">
             <a:avLst/>
@@ -22729,7 +22729,7 @@
         </p:nvSpPr>
         <p:spPr>
           <a:xfrm>
-            <a:off x="3410712" y="5486400"/>
+            <a:off x="3410712" y="6099048"/>
             <a:ext cx="8549640" cy="219456"/>
           </a:xfrm>
           <a:prstGeom prst="rect">
@@ -22748,7 +22748,7 @@
               <a:buNone/>
             </a:pPr>
             <a:r>
-              <a:rPr lang="en-US" sz="1050" b="1" dirty="0">
+              <a:rPr lang="en-US" sz="1300" b="1" dirty="0">
                 <a:solidFill>
                   <a:srgbClr val="222222"/>
                 </a:solidFill>
@@ -22758,7 +22758,7 @@
               </a:rPr>
               <a:t>의학·인지과학 근거</a:t>
             </a:r>
-            <a:endParaRPr lang="en-US" sz="1050" dirty="0"/>
+            <a:endParaRPr lang="en-US" sz="1300" dirty="0"/>
           </a:p>
         </p:txBody>
       </p:sp>
@@ -22770,8 +22770,8 @@
         </p:nvSpPr>
         <p:spPr>
           <a:xfrm>
-            <a:off x="3410712" y="5669280"/>
-            <a:ext cx="8549640" cy="749808"/>
+            <a:off x="3410712" y="6446520"/>
+            <a:ext cx="8549640" cy="457200"/>
           </a:xfrm>
           <a:prstGeom prst="rect">
             <a:avLst/>
@@ -22789,7 +22789,7 @@
               <a:buNone/>
             </a:pPr>
             <a:r>
-              <a:rPr lang="en-US" sz="940" dirty="0">
+              <a:rPr lang="en-US" sz="1020" dirty="0">
                 <a:solidFill>
                   <a:srgbClr val="6A6A6A"/>
                 </a:solidFill>
@@ -22799,7 +22799,7 @@
               </a:rPr>
               <a:t>근거축: 날짜·요일 선택은 GPCOG/Brodaty(2002), MMSE/MoCA의 시간 지남력 항목 발췌를 루틴 점검용으로 축소 적용한 구성입니다.</a:t>
             </a:r>
-            <a:endParaRPr lang="en-US" sz="940" dirty="0"/>
+            <a:endParaRPr lang="en-US" sz="1020" dirty="0"/>
           </a:p>
         </p:txBody>
       </p:sp>
@@ -23282,7 +23282,7 @@
         </p:nvSpPr>
         <p:spPr>
           <a:xfrm>
-            <a:off x="3410712" y="3849624"/>
+            <a:off x="3410712" y="3872484"/>
             <a:ext cx="91440" cy="91440"/>
           </a:xfrm>
           <a:prstGeom prst="ellipse">
@@ -23309,8 +23309,8 @@
         </p:nvSpPr>
         <p:spPr>
           <a:xfrm>
-            <a:off x="3611880" y="3712464"/>
-            <a:ext cx="8348472" cy="365760"/>
+            <a:off x="3611880" y="3767328"/>
+            <a:ext cx="8348472" cy="301752"/>
           </a:xfrm>
           <a:prstGeom prst="rect">
             <a:avLst/>
@@ -23350,7 +23350,7 @@
         </p:nvSpPr>
         <p:spPr>
           <a:xfrm>
-            <a:off x="3410712" y="4215384"/>
+            <a:off x="3410712" y="4174236"/>
             <a:ext cx="91440" cy="91440"/>
           </a:xfrm>
           <a:prstGeom prst="ellipse">
@@ -23377,8 +23377,8 @@
         </p:nvSpPr>
         <p:spPr>
           <a:xfrm>
-            <a:off x="3611880" y="4078224"/>
-            <a:ext cx="8348472" cy="365760"/>
+            <a:off x="3611880" y="4069080"/>
+            <a:ext cx="8348472" cy="301752"/>
           </a:xfrm>
           <a:prstGeom prst="rect">
             <a:avLst/>
@@ -23418,7 +23418,7 @@
         </p:nvSpPr>
         <p:spPr>
           <a:xfrm>
-            <a:off x="3410712" y="4581144"/>
+            <a:off x="3410712" y="4475988"/>
             <a:ext cx="91440" cy="91440"/>
           </a:xfrm>
           <a:prstGeom prst="ellipse">
@@ -23445,8 +23445,8 @@
         </p:nvSpPr>
         <p:spPr>
           <a:xfrm>
-            <a:off x="3611880" y="4443984"/>
-            <a:ext cx="8348472" cy="365760"/>
+            <a:off x="3611880" y="4370832"/>
+            <a:ext cx="8348472" cy="301752"/>
           </a:xfrm>
           <a:prstGeom prst="rect">
             <a:avLst/>
@@ -23486,7 +23486,7 @@
         </p:nvSpPr>
         <p:spPr>
           <a:xfrm>
-            <a:off x="3410712" y="4946904"/>
+            <a:off x="3410712" y="4777740"/>
             <a:ext cx="91440" cy="91440"/>
           </a:xfrm>
           <a:prstGeom prst="ellipse">
@@ -23513,8 +23513,8 @@
         </p:nvSpPr>
         <p:spPr>
           <a:xfrm>
-            <a:off x="3611880" y="4809744"/>
-            <a:ext cx="8348472" cy="365760"/>
+            <a:off x="3611880" y="4672584"/>
+            <a:ext cx="8348472" cy="301752"/>
           </a:xfrm>
           <a:prstGeom prst="rect">
             <a:avLst/>
@@ -23554,7 +23554,7 @@
         </p:nvSpPr>
         <p:spPr>
           <a:xfrm>
-            <a:off x="3410712" y="5047488"/>
+            <a:off x="3410712" y="5120640"/>
             <a:ext cx="1188720" cy="256032"/>
           </a:xfrm>
           <a:prstGeom prst="rect">
@@ -23573,7 +23573,7 @@
               <a:buNone/>
             </a:pPr>
             <a:r>
-              <a:rPr lang="en-US" sz="1200" b="1" dirty="0">
+              <a:rPr lang="en-US" sz="1300" b="1" dirty="0">
                 <a:solidFill>
                   <a:srgbClr val="222222"/>
                 </a:solidFill>
@@ -23583,7 +23583,7 @@
               </a:rPr>
               <a:t>디자인 포인트</a:t>
             </a:r>
-            <a:endParaRPr lang="en-US" sz="1200" dirty="0"/>
+            <a:endParaRPr lang="en-US" sz="1300" dirty="0"/>
           </a:p>
         </p:txBody>
       </p:sp>
@@ -23595,8 +23595,8 @@
         </p:nvSpPr>
         <p:spPr>
           <a:xfrm>
-            <a:off x="3410712" y="5248656"/>
-            <a:ext cx="8549640" cy="411480"/>
+            <a:off x="3410712" y="5468112"/>
+            <a:ext cx="8549640" cy="484632"/>
           </a:xfrm>
           <a:prstGeom prst="rect">
             <a:avLst/>
@@ -23636,7 +23636,7 @@
         </p:nvSpPr>
         <p:spPr>
           <a:xfrm>
-            <a:off x="3410712" y="5486400"/>
+            <a:off x="3410712" y="6099048"/>
             <a:ext cx="8549640" cy="219456"/>
           </a:xfrm>
           <a:prstGeom prst="rect">
@@ -23655,7 +23655,7 @@
               <a:buNone/>
             </a:pPr>
             <a:r>
-              <a:rPr lang="en-US" sz="1050" b="1" dirty="0">
+              <a:rPr lang="en-US" sz="1300" b="1" dirty="0">
                 <a:solidFill>
                   <a:srgbClr val="222222"/>
                 </a:solidFill>
@@ -23665,7 +23665,7 @@
               </a:rPr>
               <a:t>의학·인지과학 근거</a:t>
             </a:r>
-            <a:endParaRPr lang="en-US" sz="1050" dirty="0"/>
+            <a:endParaRPr lang="en-US" sz="1300" dirty="0"/>
           </a:p>
         </p:txBody>
       </p:sp>
@@ -23677,8 +23677,8 @@
         </p:nvSpPr>
         <p:spPr>
           <a:xfrm>
-            <a:off x="3410712" y="5669280"/>
-            <a:ext cx="8549640" cy="749808"/>
+            <a:off x="3410712" y="6446520"/>
+            <a:ext cx="8549640" cy="457200"/>
           </a:xfrm>
           <a:prstGeom prst="rect">
             <a:avLst/>
@@ -23696,7 +23696,7 @@
               <a:buNone/>
             </a:pPr>
             <a:r>
-              <a:rPr lang="en-US" sz="940" dirty="0">
+              <a:rPr lang="en-US" sz="1020" dirty="0">
                 <a:solidFill>
                   <a:srgbClr val="6A6A6A"/>
                 </a:solidFill>
@@ -23706,7 +23706,7 @@
               </a:rPr>
               <a:t>근거축: 작업기억 순/역방향 숫자 처리 과제는 작업기억(작업공간 + 조작) 동선을 관찰하는 안전한 경량 과제 흐름입니다.</a:t>
             </a:r>
-            <a:endParaRPr lang="en-US" sz="940" dirty="0"/>
+            <a:endParaRPr lang="en-US" sz="1020" dirty="0"/>
           </a:p>
         </p:txBody>
       </p:sp>
@@ -24189,7 +24189,7 @@
         </p:nvSpPr>
         <p:spPr>
           <a:xfrm>
-            <a:off x="3410712" y="3849624"/>
+            <a:off x="3410712" y="3872484"/>
             <a:ext cx="91440" cy="91440"/>
           </a:xfrm>
           <a:prstGeom prst="ellipse">
@@ -24216,8 +24216,8 @@
         </p:nvSpPr>
         <p:spPr>
           <a:xfrm>
-            <a:off x="3611880" y="3712464"/>
-            <a:ext cx="8348472" cy="365760"/>
+            <a:off x="3611880" y="3767328"/>
+            <a:ext cx="8348472" cy="301752"/>
           </a:xfrm>
           <a:prstGeom prst="rect">
             <a:avLst/>
@@ -24257,7 +24257,7 @@
         </p:nvSpPr>
         <p:spPr>
           <a:xfrm>
-            <a:off x="3410712" y="4215384"/>
+            <a:off x="3410712" y="4174236"/>
             <a:ext cx="91440" cy="91440"/>
           </a:xfrm>
           <a:prstGeom prst="ellipse">
@@ -24284,8 +24284,8 @@
         </p:nvSpPr>
         <p:spPr>
           <a:xfrm>
-            <a:off x="3611880" y="4078224"/>
-            <a:ext cx="8348472" cy="365760"/>
+            <a:off x="3611880" y="4069080"/>
+            <a:ext cx="8348472" cy="301752"/>
           </a:xfrm>
           <a:prstGeom prst="rect">
             <a:avLst/>
@@ -24325,7 +24325,7 @@
         </p:nvSpPr>
         <p:spPr>
           <a:xfrm>
-            <a:off x="3410712" y="4581144"/>
+            <a:off x="3410712" y="4475988"/>
             <a:ext cx="91440" cy="91440"/>
           </a:xfrm>
           <a:prstGeom prst="ellipse">
@@ -24352,8 +24352,8 @@
         </p:nvSpPr>
         <p:spPr>
           <a:xfrm>
-            <a:off x="3611880" y="4443984"/>
-            <a:ext cx="8348472" cy="365760"/>
+            <a:off x="3611880" y="4370832"/>
+            <a:ext cx="8348472" cy="301752"/>
           </a:xfrm>
           <a:prstGeom prst="rect">
             <a:avLst/>
@@ -24393,7 +24393,7 @@
         </p:nvSpPr>
         <p:spPr>
           <a:xfrm>
-            <a:off x="3410712" y="4946904"/>
+            <a:off x="3410712" y="4777740"/>
             <a:ext cx="91440" cy="91440"/>
           </a:xfrm>
           <a:prstGeom prst="ellipse">
@@ -24420,8 +24420,8 @@
         </p:nvSpPr>
         <p:spPr>
           <a:xfrm>
-            <a:off x="3611880" y="4809744"/>
-            <a:ext cx="8348472" cy="365760"/>
+            <a:off x="3611880" y="4672584"/>
+            <a:ext cx="8348472" cy="301752"/>
           </a:xfrm>
           <a:prstGeom prst="rect">
             <a:avLst/>
@@ -24461,7 +24461,7 @@
         </p:nvSpPr>
         <p:spPr>
           <a:xfrm>
-            <a:off x="3410712" y="5047488"/>
+            <a:off x="3410712" y="5120640"/>
             <a:ext cx="1188720" cy="256032"/>
           </a:xfrm>
           <a:prstGeom prst="rect">
@@ -24480,7 +24480,7 @@
               <a:buNone/>
             </a:pPr>
             <a:r>
-              <a:rPr lang="en-US" sz="1200" b="1" dirty="0">
+              <a:rPr lang="en-US" sz="1300" b="1" dirty="0">
                 <a:solidFill>
                   <a:srgbClr val="222222"/>
                 </a:solidFill>
@@ -24490,7 +24490,7 @@
               </a:rPr>
               <a:t>디자인 포인트</a:t>
             </a:r>
-            <a:endParaRPr lang="en-US" sz="1200" dirty="0"/>
+            <a:endParaRPr lang="en-US" sz="1300" dirty="0"/>
           </a:p>
         </p:txBody>
       </p:sp>
@@ -24502,8 +24502,8 @@
         </p:nvSpPr>
         <p:spPr>
           <a:xfrm>
-            <a:off x="3410712" y="5248656"/>
-            <a:ext cx="8549640" cy="411480"/>
+            <a:off x="3410712" y="5468112"/>
+            <a:ext cx="8549640" cy="484632"/>
           </a:xfrm>
           <a:prstGeom prst="rect">
             <a:avLst/>
@@ -24543,7 +24543,7 @@
         </p:nvSpPr>
         <p:spPr>
           <a:xfrm>
-            <a:off x="3410712" y="5486400"/>
+            <a:off x="3410712" y="6099048"/>
             <a:ext cx="8549640" cy="219456"/>
           </a:xfrm>
           <a:prstGeom prst="rect">
@@ -24562,7 +24562,7 @@
               <a:buNone/>
             </a:pPr>
             <a:r>
-              <a:rPr lang="en-US" sz="1050" b="1" dirty="0">
+              <a:rPr lang="en-US" sz="1300" b="1" dirty="0">
                 <a:solidFill>
                   <a:srgbClr val="222222"/>
                 </a:solidFill>
@@ -24572,7 +24572,7 @@
               </a:rPr>
               <a:t>의학·인지과학 근거</a:t>
             </a:r>
-            <a:endParaRPr lang="en-US" sz="1050" dirty="0"/>
+            <a:endParaRPr lang="en-US" sz="1300" dirty="0"/>
           </a:p>
         </p:txBody>
       </p:sp>
@@ -24584,8 +24584,8 @@
         </p:nvSpPr>
         <p:spPr>
           <a:xfrm>
-            <a:off x="3410712" y="5669280"/>
-            <a:ext cx="8549640" cy="749808"/>
+            <a:off x="3410712" y="6446520"/>
+            <a:ext cx="8549640" cy="457200"/>
           </a:xfrm>
           <a:prstGeom prst="rect">
             <a:avLst/>
@@ -24603,7 +24603,7 @@
               <a:buNone/>
             </a:pPr>
             <a:r>
-              <a:rPr lang="en-US" sz="940" dirty="0">
+              <a:rPr lang="en-US" sz="1020" dirty="0">
                 <a:solidFill>
                   <a:srgbClr val="6A6A6A"/>
                 </a:solidFill>
@@ -24613,7 +24613,7 @@
               </a:rPr>
               <a:t>근거축: 범주형 말하기/입력 과제는 Henry &amp; Crawford(2004) semantic fluency의 인출 동선을 브레인스토밍 형태로 경량화한 흐름입니다.</a:t>
             </a:r>
-            <a:endParaRPr lang="en-US" sz="940" dirty="0"/>
+            <a:endParaRPr lang="en-US" sz="1020" dirty="0"/>
           </a:p>
         </p:txBody>
       </p:sp>

</xml_diff>